<commit_message>
Modify basic template pptx
</commit_message>
<xml_diff>
--- a/template-source/basic_template.pptx
+++ b/template-source/basic_template.pptx
@@ -4,6 +4,9 @@
   <p:sldMasterIdLst>
     <p:sldMasterId id="2147483648" r:id="rId1"/>
   </p:sldMasterIdLst>
+  <p:notesMasterIdLst>
+    <p:notesMasterId r:id="rId27"/>
+  </p:notesMasterIdLst>
   <p:sldIdLst>
     <p:sldId id="256" r:id="rId7"/>
     <p:sldId id="257" r:id="rId8"/>
@@ -24,8 +27,9 @@
     <p:sldId id="272" r:id="rId23"/>
     <p:sldId id="273" r:id="rId24"/>
     <p:sldId id="274" r:id="rId25"/>
+    <p:sldId id="275" r:id="rId26"/>
   </p:sldIdLst>
-  <p:sldSz cx="12191695" cy="6858000" type="screen4x3"/>
+  <p:sldSz cx="12191695" cy="6858000" type="screen16x9"/>
   <p:notesSz cx="6858000" cy="9144000"/>
   <p:defaultTextStyle>
     <a:defPPr>
@@ -555,6 +559,129 @@
               <c:strCache>
                 <c:ptCount val="1"/>
                 <c:pt idx="0">
+                  <c:v>Count</c:v>
+                </c:pt>
+              </c:strCache>
+            </c:strRef>
+          </c:tx>
+          <c:cat>
+            <c:strRef>
+              <c:f>Sheet1!$A$2:$A$6</c:f>
+              <c:strCache>
+                <c:ptCount val="5"/>
+                <c:pt idx="0">
+                  <c:v>0-20</c:v>
+                </c:pt>
+                <c:pt idx="1">
+                  <c:v>20-40</c:v>
+                </c:pt>
+                <c:pt idx="2">
+                  <c:v>40-60</c:v>
+                </c:pt>
+                <c:pt idx="3">
+                  <c:v>60-80</c:v>
+                </c:pt>
+                <c:pt idx="4">
+                  <c:v>80-100</c:v>
+                </c:pt>
+              </c:strCache>
+            </c:strRef>
+          </c:cat>
+          <c:val>
+            <c:numRef>
+              <c:f>Sheet1!$B$2:$B$6</c:f>
+              <c:numCache>
+                <c:formatCode>General</c:formatCode>
+                <c:ptCount val="5"/>
+                <c:pt idx="0">
+                  <c:v>3</c:v>
+                </c:pt>
+                <c:pt idx="1">
+                  <c:v>12</c:v>
+                </c:pt>
+                <c:pt idx="2">
+                  <c:v>45</c:v>
+                </c:pt>
+                <c:pt idx="3">
+                  <c:v>30</c:v>
+                </c:pt>
+                <c:pt idx="4">
+                  <c:v>10</c:v>
+                </c:pt>
+              </c:numCache>
+            </c:numRef>
+          </c:val>
+        </c:ser>
+        <c:gapWidth val="10"/>
+        <c:axId val="-2068027336"/>
+        <c:axId val="-2113994440"/>
+      </c:barChart>
+      <c:catAx>
+        <c:axId val="-2068027336"/>
+        <c:scaling>
+          <c:orientation val="minMax"/>
+        </c:scaling>
+        <c:delete val="0"/>
+        <c:axPos val="b"/>
+        <c:majorTickMark val="out"/>
+        <c:minorTickMark val="none"/>
+        <c:tickLblPos val="nextTo"/>
+        <c:crossAx val="-2113994440"/>
+        <c:crosses val="autoZero"/>
+        <c:auto val="1"/>
+        <c:lblAlgn val="ctr"/>
+        <c:lblOffset val="100"/>
+        <c:noMultiLvlLbl val="0"/>
+      </c:catAx>
+      <c:valAx>
+        <c:axId val="-2113994440"/>
+        <c:scaling/>
+        <c:delete val="0"/>
+        <c:axPos val="l"/>
+        <c:majorGridlines/>
+        <c:majorTickMark val="out"/>
+        <c:minorTickMark val="none"/>
+        <c:tickLblPos val="nextTo"/>
+        <c:crossAx val="-2068027336"/>
+        <c:crosses val="autoZero"/>
+      </c:valAx>
+    </c:plotArea>
+    <c:dispBlanksAs val="gap"/>
+  </c:chart>
+  <c:txPr>
+    <a:bodyPr/>
+    <a:lstStyle/>
+    <a:p>
+      <a:pPr>
+        <a:defRPr sz="1800"/>
+      </a:pPr>
+      <a:endParaRPr lang="en-US"/>
+    </a:p>
+  </c:txPr>
+  <c:externalData r:id="rId1">
+    <c:autoUpdate val="0"/>
+  </c:externalData>
+</c:chartSpace>
+</file>
+
+<file path=ppt/charts/chart5.xml><?xml version="1.0" encoding="utf-8"?>
+<c:chartSpace xmlns:c="http://schemas.openxmlformats.org/drawingml/2006/chart" xmlns:a="http://schemas.openxmlformats.org/drawingml/2006/main" xmlns:r="http://schemas.openxmlformats.org/officeDocument/2006/relationships">
+  <c:date1904 val="0"/>
+  <c:chart>
+    <c:autoTitleDeleted val="0"/>
+    <c:plotArea>
+      <c:barChart>
+        <c:barDir val="col"/>
+        <c:grouping val="clustered"/>
+        <c:ser>
+          <c:idx val="0"/>
+          <c:order val="0"/>
+          <c:tx>
+            <c:strRef>
+              <c:f>Sheet1!$B$1</c:f>
+              <c:strCache>
+                <c:ptCount val="1"/>
+                <c:pt idx="0">
                   <c:v>Actual</c:v>
                 </c:pt>
               </c:strCache>
@@ -653,7 +780,7 @@
 </c:chartSpace>
 </file>
 
-<file path=ppt/charts/chart5.xml><?xml version="1.0" encoding="utf-8"?>
+<file path=ppt/charts/chart6.xml><?xml version="1.0" encoding="utf-8"?>
 <c:chartSpace xmlns:c="http://schemas.openxmlformats.org/drawingml/2006/chart" xmlns:a="http://schemas.openxmlformats.org/drawingml/2006/main" xmlns:r="http://schemas.openxmlformats.org/officeDocument/2006/relationships">
   <c:date1904 val="0"/>
   <c:chart>
@@ -829,6 +956,1756 @@
     <c:autoUpdate val="0"/>
   </c:externalData>
 </c:chartSpace>
+</file>
+
+<file path=ppt/notesMasters/notesMaster1.xml><?xml version="1.0" encoding="utf-8"?>
+<p:notesMaster xmlns:a="http://schemas.openxmlformats.org/drawingml/2006/main" xmlns:p="http://schemas.openxmlformats.org/presentationml/2006/main" xmlns:r="http://schemas.openxmlformats.org/officeDocument/2006/relationships">
+  <p:cSld>
+    <p:bg>
+      <p:bgRef idx="1001">
+        <a:schemeClr val="bg1"/>
+      </p:bgRef>
+    </p:bg>
+    <p:spTree>
+      <p:nvGrpSpPr>
+        <p:cNvPr id="1" name=""/>
+        <p:cNvGrpSpPr/>
+        <p:nvPr/>
+      </p:nvGrpSpPr>
+      <p:grpSpPr>
+        <a:xfrm>
+          <a:off x="0" y="0"/>
+          <a:ext cx="0" cy="0"/>
+          <a:chOff x="0" y="0"/>
+          <a:chExt cx="0" cy="0"/>
+        </a:xfrm>
+      </p:grpSpPr>
+      <p:sp>
+        <p:nvSpPr>
+          <p:cNvPr id="2" name="Header Placeholder 1"/>
+          <p:cNvSpPr>
+            <a:spLocks noGrp="1"/>
+          </p:cNvSpPr>
+          <p:nvPr>
+            <p:ph type="hdr" sz="quarter"/>
+          </p:nvPr>
+        </p:nvSpPr>
+        <p:spPr>
+          <a:xfrm>
+            <a:off x="0" y="0"/>
+            <a:ext cx="2971800" cy="457200"/>
+          </a:xfrm>
+          <a:prstGeom prst="rect">
+            <a:avLst/>
+          </a:prstGeom>
+        </p:spPr>
+        <p:txBody>
+          <a:bodyPr vert="horz" lIns="91440" tIns="45720" rIns="91440" bIns="45720" rtlCol="0"/>
+          <a:lstStyle>
+            <a:lvl1pPr algn="l">
+              <a:defRPr sz="1200"/>
+            </a:lvl1pPr>
+          </a:lstStyle>
+          <a:p>
+            <a:endParaRPr lang="en-US"/>
+          </a:p>
+        </p:txBody>
+      </p:sp>
+      <p:sp>
+        <p:nvSpPr>
+          <p:cNvPr id="3" name="Date Placeholder 2"/>
+          <p:cNvSpPr>
+            <a:spLocks noGrp="1"/>
+          </p:cNvSpPr>
+          <p:nvPr>
+            <p:ph type="dt" idx="1"/>
+          </p:nvPr>
+        </p:nvSpPr>
+        <p:spPr>
+          <a:xfrm>
+            <a:off x="3884613" y="0"/>
+            <a:ext cx="2971800" cy="457200"/>
+          </a:xfrm>
+          <a:prstGeom prst="rect">
+            <a:avLst/>
+          </a:prstGeom>
+        </p:spPr>
+        <p:txBody>
+          <a:bodyPr vert="horz" lIns="91440" tIns="45720" rIns="91440" bIns="45720" rtlCol="0"/>
+          <a:lstStyle>
+            <a:lvl1pPr algn="r">
+              <a:defRPr sz="1200"/>
+            </a:lvl1pPr>
+          </a:lstStyle>
+          <a:p>
+            <a:fld id="{0F89C1C7-3DCD-1040-A9CF-14679D8B5DDD}" type="datetimeFigureOut">
+              <a:rPr lang="en-US" smtClean="0"/>
+              <a:t>10/17/16</a:t>
+            </a:fld>
+            <a:endParaRPr lang="en-US"/>
+          </a:p>
+        </p:txBody>
+      </p:sp>
+      <p:sp>
+        <p:nvSpPr>
+          <p:cNvPr id="4" name="Slide Image Placeholder 3"/>
+          <p:cNvSpPr>
+            <a:spLocks noGrp="1" noRot="1" noChangeAspect="1"/>
+          </p:cNvSpPr>
+          <p:nvPr>
+            <p:ph type="sldImg" idx="2"/>
+          </p:nvPr>
+        </p:nvSpPr>
+        <p:spPr>
+          <a:xfrm>
+            <a:off x="1143000" y="685800"/>
+            <a:ext cx="4572000" cy="3429000"/>
+          </a:xfrm>
+          <a:prstGeom prst="rect">
+            <a:avLst/>
+          </a:prstGeom>
+          <a:noFill/>
+          <a:ln w="12700">
+            <a:solidFill>
+              <a:prstClr val="black"/>
+            </a:solidFill>
+          </a:ln>
+        </p:spPr>
+        <p:txBody>
+          <a:bodyPr vert="horz" lIns="91440" tIns="45720" rIns="91440" bIns="45720" rtlCol="0" anchor="ctr"/>
+          <a:lstStyle/>
+          <a:p>
+            <a:endParaRPr lang="en-US"/>
+          </a:p>
+        </p:txBody>
+      </p:sp>
+      <p:sp>
+        <p:nvSpPr>
+          <p:cNvPr id="5" name="Notes Placeholder 4"/>
+          <p:cNvSpPr>
+            <a:spLocks noGrp="1"/>
+          </p:cNvSpPr>
+          <p:nvPr>
+            <p:ph type="body" sz="quarter" idx="3"/>
+          </p:nvPr>
+        </p:nvSpPr>
+        <p:spPr>
+          <a:xfrm>
+            <a:off x="685800" y="4343400"/>
+            <a:ext cx="5486400" cy="4114800"/>
+          </a:xfrm>
+          <a:prstGeom prst="rect">
+            <a:avLst/>
+          </a:prstGeom>
+        </p:spPr>
+        <p:txBody>
+          <a:bodyPr vert="horz" lIns="91440" tIns="45720" rIns="91440" bIns="45720" rtlCol="0"/>
+          <a:lstStyle/>
+          <a:p>
+            <a:pPr lvl="0"/>
+            <a:r>
+              <a:rPr lang="en-US" smtClean="0"/>
+              <a:t>Click to edit Master text styles</a:t>
+            </a:r>
+          </a:p>
+          <a:p>
+            <a:pPr lvl="1"/>
+            <a:r>
+              <a:rPr lang="en-US" smtClean="0"/>
+              <a:t>Second level</a:t>
+            </a:r>
+          </a:p>
+          <a:p>
+            <a:pPr lvl="2"/>
+            <a:r>
+              <a:rPr lang="en-US" smtClean="0"/>
+              <a:t>Third level</a:t>
+            </a:r>
+          </a:p>
+          <a:p>
+            <a:pPr lvl="3"/>
+            <a:r>
+              <a:rPr lang="en-US" smtClean="0"/>
+              <a:t>Fourth level</a:t>
+            </a:r>
+          </a:p>
+          <a:p>
+            <a:pPr lvl="4"/>
+            <a:r>
+              <a:rPr lang="en-US" smtClean="0"/>
+              <a:t>Fifth level</a:t>
+            </a:r>
+            <a:endParaRPr lang="en-US"/>
+          </a:p>
+        </p:txBody>
+      </p:sp>
+      <p:sp>
+        <p:nvSpPr>
+          <p:cNvPr id="6" name="Footer Placeholder 5"/>
+          <p:cNvSpPr>
+            <a:spLocks noGrp="1"/>
+          </p:cNvSpPr>
+          <p:nvPr>
+            <p:ph type="ftr" sz="quarter" idx="4"/>
+          </p:nvPr>
+        </p:nvSpPr>
+        <p:spPr>
+          <a:xfrm>
+            <a:off x="0" y="8685213"/>
+            <a:ext cx="2971800" cy="457200"/>
+          </a:xfrm>
+          <a:prstGeom prst="rect">
+            <a:avLst/>
+          </a:prstGeom>
+        </p:spPr>
+        <p:txBody>
+          <a:bodyPr vert="horz" lIns="91440" tIns="45720" rIns="91440" bIns="45720" rtlCol="0" anchor="b"/>
+          <a:lstStyle>
+            <a:lvl1pPr algn="l">
+              <a:defRPr sz="1200"/>
+            </a:lvl1pPr>
+          </a:lstStyle>
+          <a:p>
+            <a:endParaRPr lang="en-US"/>
+          </a:p>
+        </p:txBody>
+      </p:sp>
+      <p:sp>
+        <p:nvSpPr>
+          <p:cNvPr id="7" name="Slide Number Placeholder 6"/>
+          <p:cNvSpPr>
+            <a:spLocks noGrp="1"/>
+          </p:cNvSpPr>
+          <p:nvPr>
+            <p:ph type="sldNum" sz="quarter" idx="5"/>
+          </p:nvPr>
+        </p:nvSpPr>
+        <p:spPr>
+          <a:xfrm>
+            <a:off x="3884613" y="8685213"/>
+            <a:ext cx="2971800" cy="457200"/>
+          </a:xfrm>
+          <a:prstGeom prst="rect">
+            <a:avLst/>
+          </a:prstGeom>
+        </p:spPr>
+        <p:txBody>
+          <a:bodyPr vert="horz" lIns="91440" tIns="45720" rIns="91440" bIns="45720" rtlCol="0" anchor="b"/>
+          <a:lstStyle>
+            <a:lvl1pPr algn="r">
+              <a:defRPr sz="1200"/>
+            </a:lvl1pPr>
+          </a:lstStyle>
+          <a:p>
+            <a:fld id="{BB5E49A5-4136-284D-997B-48E1D791AD67}" type="slidenum">
+              <a:rPr lang="en-US" smtClean="0"/>
+              <a:t>‹#›</a:t>
+            </a:fld>
+            <a:endParaRPr lang="en-US"/>
+          </a:p>
+        </p:txBody>
+      </p:sp>
+    </p:spTree>
+    <p:extLst>
+      <p:ext uri="{BB962C8B-B14F-4D97-AF65-F5344CB8AC3E}">
+        <p14:creationId xmlns:p14="http://schemas.microsoft.com/office/powerpoint/2010/main" val="2623252185"/>
+      </p:ext>
+    </p:extLst>
+  </p:cSld>
+  <p:clrMap bg1="lt1" tx1="dk1" bg2="lt2" tx2="dk2" accent1="accent1" accent2="accent2" accent3="accent3" accent4="accent4" accent5="accent5" accent6="accent6" hlink="hlink" folHlink="folHlink"/>
+  <p:notesStyle>
+    <a:lvl1pPr marL="0" algn="l" defTabSz="457200" rtl="0" eaLnBrk="1" latinLnBrk="0" hangingPunct="1">
+      <a:defRPr sz="1200" kern="1200">
+        <a:solidFill>
+          <a:schemeClr val="tx1"/>
+        </a:solidFill>
+        <a:latin typeface="+mn-lt"/>
+        <a:ea typeface="+mn-ea"/>
+        <a:cs typeface="+mn-cs"/>
+      </a:defRPr>
+    </a:lvl1pPr>
+    <a:lvl2pPr marL="457200" algn="l" defTabSz="457200" rtl="0" eaLnBrk="1" latinLnBrk="0" hangingPunct="1">
+      <a:defRPr sz="1200" kern="1200">
+        <a:solidFill>
+          <a:schemeClr val="tx1"/>
+        </a:solidFill>
+        <a:latin typeface="+mn-lt"/>
+        <a:ea typeface="+mn-ea"/>
+        <a:cs typeface="+mn-cs"/>
+      </a:defRPr>
+    </a:lvl2pPr>
+    <a:lvl3pPr marL="914400" algn="l" defTabSz="457200" rtl="0" eaLnBrk="1" latinLnBrk="0" hangingPunct="1">
+      <a:defRPr sz="1200" kern="1200">
+        <a:solidFill>
+          <a:schemeClr val="tx1"/>
+        </a:solidFill>
+        <a:latin typeface="+mn-lt"/>
+        <a:ea typeface="+mn-ea"/>
+        <a:cs typeface="+mn-cs"/>
+      </a:defRPr>
+    </a:lvl3pPr>
+    <a:lvl4pPr marL="1371600" algn="l" defTabSz="457200" rtl="0" eaLnBrk="1" latinLnBrk="0" hangingPunct="1">
+      <a:defRPr sz="1200" kern="1200">
+        <a:solidFill>
+          <a:schemeClr val="tx1"/>
+        </a:solidFill>
+        <a:latin typeface="+mn-lt"/>
+        <a:ea typeface="+mn-ea"/>
+        <a:cs typeface="+mn-cs"/>
+      </a:defRPr>
+    </a:lvl4pPr>
+    <a:lvl5pPr marL="1828800" algn="l" defTabSz="457200" rtl="0" eaLnBrk="1" latinLnBrk="0" hangingPunct="1">
+      <a:defRPr sz="1200" kern="1200">
+        <a:solidFill>
+          <a:schemeClr val="tx1"/>
+        </a:solidFill>
+        <a:latin typeface="+mn-lt"/>
+        <a:ea typeface="+mn-ea"/>
+        <a:cs typeface="+mn-cs"/>
+      </a:defRPr>
+    </a:lvl5pPr>
+    <a:lvl6pPr marL="2286000" algn="l" defTabSz="457200" rtl="0" eaLnBrk="1" latinLnBrk="0" hangingPunct="1">
+      <a:defRPr sz="1200" kern="1200">
+        <a:solidFill>
+          <a:schemeClr val="tx1"/>
+        </a:solidFill>
+        <a:latin typeface="+mn-lt"/>
+        <a:ea typeface="+mn-ea"/>
+        <a:cs typeface="+mn-cs"/>
+      </a:defRPr>
+    </a:lvl6pPr>
+    <a:lvl7pPr marL="2743200" algn="l" defTabSz="457200" rtl="0" eaLnBrk="1" latinLnBrk="0" hangingPunct="1">
+      <a:defRPr sz="1200" kern="1200">
+        <a:solidFill>
+          <a:schemeClr val="tx1"/>
+        </a:solidFill>
+        <a:latin typeface="+mn-lt"/>
+        <a:ea typeface="+mn-ea"/>
+        <a:cs typeface="+mn-cs"/>
+      </a:defRPr>
+    </a:lvl7pPr>
+    <a:lvl8pPr marL="3200400" algn="l" defTabSz="457200" rtl="0" eaLnBrk="1" latinLnBrk="0" hangingPunct="1">
+      <a:defRPr sz="1200" kern="1200">
+        <a:solidFill>
+          <a:schemeClr val="tx1"/>
+        </a:solidFill>
+        <a:latin typeface="+mn-lt"/>
+        <a:ea typeface="+mn-ea"/>
+        <a:cs typeface="+mn-cs"/>
+      </a:defRPr>
+    </a:lvl8pPr>
+    <a:lvl9pPr marL="3657600" algn="l" defTabSz="457200" rtl="0" eaLnBrk="1" latinLnBrk="0" hangingPunct="1">
+      <a:defRPr sz="1200" kern="1200">
+        <a:solidFill>
+          <a:schemeClr val="tx1"/>
+        </a:solidFill>
+        <a:latin typeface="+mn-lt"/>
+        <a:ea typeface="+mn-ea"/>
+        <a:cs typeface="+mn-cs"/>
+      </a:defRPr>
+    </a:lvl9pPr>
+  </p:notesStyle>
+</p:notesMaster>
+</file>
+
+<file path=ppt/notesSlides/notesSlide1.xml><?xml version="1.0" encoding="utf-8"?>
+<p:notes xmlns:a="http://schemas.openxmlformats.org/drawingml/2006/main" xmlns:p="http://schemas.openxmlformats.org/presentationml/2006/main" xmlns:r="http://schemas.openxmlformats.org/officeDocument/2006/relationships">
+  <p:cSld>
+    <p:spTree>
+      <p:nvGrpSpPr>
+        <p:cNvPr id="1" name=""/>
+        <p:cNvGrpSpPr/>
+        <p:nvPr/>
+      </p:nvGrpSpPr>
+      <p:grpSpPr>
+        <a:xfrm>
+          <a:off x="0" y="0"/>
+          <a:ext cx="0" cy="0"/>
+          <a:chOff x="0" y="0"/>
+          <a:chExt cx="0" cy="0"/>
+        </a:xfrm>
+      </p:grpSpPr>
+      <p:sp>
+        <p:nvSpPr>
+          <p:cNvPr id="2" name="Slide Image Placeholder 1"/>
+          <p:cNvSpPr>
+            <a:spLocks noGrp="1"/>
+          </p:cNvSpPr>
+          <p:nvPr>
+            <p:ph type="sldImg" idx="2"/>
+          </p:nvPr>
+        </p:nvSpPr>
+        <p:spPr/>
+      </p:sp>
+      <p:sp>
+        <p:nvSpPr>
+          <p:cNvPr id="3" name="Notes Placeholder 2"/>
+          <p:cNvSpPr>
+            <a:spLocks noGrp="1"/>
+          </p:cNvSpPr>
+          <p:nvPr>
+            <p:ph type="body" idx="3" sz="quarter"/>
+          </p:nvPr>
+        </p:nvSpPr>
+        <p:spPr/>
+        <p:txBody>
+          <a:bodyPr/>
+          <a:lstStyle/>
+          <a:p>
+            <a:r>
+              <a:t>Speaker notes here.</a:t>
+            </a:r>
+          </a:p>
+        </p:txBody>
+      </p:sp>
+      <p:sp>
+        <p:nvSpPr>
+          <p:cNvPr id="4" name="Slide Number Placeholder 3"/>
+          <p:cNvSpPr>
+            <a:spLocks noGrp="1"/>
+          </p:cNvSpPr>
+          <p:nvPr>
+            <p:ph type="sldNum" idx="5" sz="quarter"/>
+          </p:nvPr>
+        </p:nvSpPr>
+        <p:spPr/>
+      </p:sp>
+    </p:spTree>
+  </p:cSld>
+  <p:clrMapOvr>
+    <a:masterClrMapping/>
+  </p:clrMapOvr>
+</p:notes>
+</file>
+
+<file path=ppt/notesSlides/notesSlide10.xml><?xml version="1.0" encoding="utf-8"?>
+<p:notes xmlns:a="http://schemas.openxmlformats.org/drawingml/2006/main" xmlns:p="http://schemas.openxmlformats.org/presentationml/2006/main" xmlns:r="http://schemas.openxmlformats.org/officeDocument/2006/relationships">
+  <p:cSld>
+    <p:spTree>
+      <p:nvGrpSpPr>
+        <p:cNvPr id="1" name=""/>
+        <p:cNvGrpSpPr/>
+        <p:nvPr/>
+      </p:nvGrpSpPr>
+      <p:grpSpPr>
+        <a:xfrm>
+          <a:off x="0" y="0"/>
+          <a:ext cx="0" cy="0"/>
+          <a:chOff x="0" y="0"/>
+          <a:chExt cx="0" cy="0"/>
+        </a:xfrm>
+      </p:grpSpPr>
+      <p:sp>
+        <p:nvSpPr>
+          <p:cNvPr id="2" name="Slide Image Placeholder 1"/>
+          <p:cNvSpPr>
+            <a:spLocks noGrp="1"/>
+          </p:cNvSpPr>
+          <p:nvPr>
+            <p:ph type="sldImg" idx="2"/>
+          </p:nvPr>
+        </p:nvSpPr>
+        <p:spPr/>
+      </p:sp>
+      <p:sp>
+        <p:nvSpPr>
+          <p:cNvPr id="3" name="Notes Placeholder 2"/>
+          <p:cNvSpPr>
+            <a:spLocks noGrp="1"/>
+          </p:cNvSpPr>
+          <p:nvPr>
+            <p:ph type="body" idx="3" sz="quarter"/>
+          </p:nvPr>
+        </p:nvSpPr>
+        <p:spPr/>
+        <p:txBody>
+          <a:bodyPr/>
+          <a:lstStyle/>
+          <a:p>
+            <a:r>
+              <a:t>Speaker notes here.</a:t>
+            </a:r>
+          </a:p>
+        </p:txBody>
+      </p:sp>
+      <p:sp>
+        <p:nvSpPr>
+          <p:cNvPr id="4" name="Slide Number Placeholder 3"/>
+          <p:cNvSpPr>
+            <a:spLocks noGrp="1"/>
+          </p:cNvSpPr>
+          <p:nvPr>
+            <p:ph type="sldNum" idx="5" sz="quarter"/>
+          </p:nvPr>
+        </p:nvSpPr>
+        <p:spPr/>
+      </p:sp>
+    </p:spTree>
+  </p:cSld>
+  <p:clrMapOvr>
+    <a:masterClrMapping/>
+  </p:clrMapOvr>
+</p:notes>
+</file>
+
+<file path=ppt/notesSlides/notesSlide11.xml><?xml version="1.0" encoding="utf-8"?>
+<p:notes xmlns:a="http://schemas.openxmlformats.org/drawingml/2006/main" xmlns:p="http://schemas.openxmlformats.org/presentationml/2006/main" xmlns:r="http://schemas.openxmlformats.org/officeDocument/2006/relationships">
+  <p:cSld>
+    <p:spTree>
+      <p:nvGrpSpPr>
+        <p:cNvPr id="1" name=""/>
+        <p:cNvGrpSpPr/>
+        <p:nvPr/>
+      </p:nvGrpSpPr>
+      <p:grpSpPr>
+        <a:xfrm>
+          <a:off x="0" y="0"/>
+          <a:ext cx="0" cy="0"/>
+          <a:chOff x="0" y="0"/>
+          <a:chExt cx="0" cy="0"/>
+        </a:xfrm>
+      </p:grpSpPr>
+      <p:sp>
+        <p:nvSpPr>
+          <p:cNvPr id="2" name="Slide Image Placeholder 1"/>
+          <p:cNvSpPr>
+            <a:spLocks noGrp="1"/>
+          </p:cNvSpPr>
+          <p:nvPr>
+            <p:ph type="sldImg" idx="2"/>
+          </p:nvPr>
+        </p:nvSpPr>
+        <p:spPr/>
+      </p:sp>
+      <p:sp>
+        <p:nvSpPr>
+          <p:cNvPr id="3" name="Notes Placeholder 2"/>
+          <p:cNvSpPr>
+            <a:spLocks noGrp="1"/>
+          </p:cNvSpPr>
+          <p:nvPr>
+            <p:ph type="body" idx="3" sz="quarter"/>
+          </p:nvPr>
+        </p:nvSpPr>
+        <p:spPr/>
+        <p:txBody>
+          <a:bodyPr/>
+          <a:lstStyle/>
+          <a:p>
+            <a:r>
+              <a:t>Speaker notes here.</a:t>
+            </a:r>
+          </a:p>
+        </p:txBody>
+      </p:sp>
+      <p:sp>
+        <p:nvSpPr>
+          <p:cNvPr id="4" name="Slide Number Placeholder 3"/>
+          <p:cNvSpPr>
+            <a:spLocks noGrp="1"/>
+          </p:cNvSpPr>
+          <p:nvPr>
+            <p:ph type="sldNum" idx="5" sz="quarter"/>
+          </p:nvPr>
+        </p:nvSpPr>
+        <p:spPr/>
+      </p:sp>
+    </p:spTree>
+  </p:cSld>
+  <p:clrMapOvr>
+    <a:masterClrMapping/>
+  </p:clrMapOvr>
+</p:notes>
+</file>
+
+<file path=ppt/notesSlides/notesSlide12.xml><?xml version="1.0" encoding="utf-8"?>
+<p:notes xmlns:a="http://schemas.openxmlformats.org/drawingml/2006/main" xmlns:p="http://schemas.openxmlformats.org/presentationml/2006/main" xmlns:r="http://schemas.openxmlformats.org/officeDocument/2006/relationships">
+  <p:cSld>
+    <p:spTree>
+      <p:nvGrpSpPr>
+        <p:cNvPr id="1" name=""/>
+        <p:cNvGrpSpPr/>
+        <p:nvPr/>
+      </p:nvGrpSpPr>
+      <p:grpSpPr>
+        <a:xfrm>
+          <a:off x="0" y="0"/>
+          <a:ext cx="0" cy="0"/>
+          <a:chOff x="0" y="0"/>
+          <a:chExt cx="0" cy="0"/>
+        </a:xfrm>
+      </p:grpSpPr>
+      <p:sp>
+        <p:nvSpPr>
+          <p:cNvPr id="2" name="Slide Image Placeholder 1"/>
+          <p:cNvSpPr>
+            <a:spLocks noGrp="1"/>
+          </p:cNvSpPr>
+          <p:nvPr>
+            <p:ph type="sldImg" idx="2"/>
+          </p:nvPr>
+        </p:nvSpPr>
+        <p:spPr/>
+      </p:sp>
+      <p:sp>
+        <p:nvSpPr>
+          <p:cNvPr id="3" name="Notes Placeholder 2"/>
+          <p:cNvSpPr>
+            <a:spLocks noGrp="1"/>
+          </p:cNvSpPr>
+          <p:nvPr>
+            <p:ph type="body" idx="3" sz="quarter"/>
+          </p:nvPr>
+        </p:nvSpPr>
+        <p:spPr/>
+        <p:txBody>
+          <a:bodyPr/>
+          <a:lstStyle/>
+          <a:p>
+            <a:r>
+              <a:t>Speaker notes here.</a:t>
+            </a:r>
+          </a:p>
+        </p:txBody>
+      </p:sp>
+      <p:sp>
+        <p:nvSpPr>
+          <p:cNvPr id="4" name="Slide Number Placeholder 3"/>
+          <p:cNvSpPr>
+            <a:spLocks noGrp="1"/>
+          </p:cNvSpPr>
+          <p:nvPr>
+            <p:ph type="sldNum" idx="5" sz="quarter"/>
+          </p:nvPr>
+        </p:nvSpPr>
+        <p:spPr/>
+      </p:sp>
+    </p:spTree>
+  </p:cSld>
+  <p:clrMapOvr>
+    <a:masterClrMapping/>
+  </p:clrMapOvr>
+</p:notes>
+</file>
+
+<file path=ppt/notesSlides/notesSlide13.xml><?xml version="1.0" encoding="utf-8"?>
+<p:notes xmlns:a="http://schemas.openxmlformats.org/drawingml/2006/main" xmlns:p="http://schemas.openxmlformats.org/presentationml/2006/main" xmlns:r="http://schemas.openxmlformats.org/officeDocument/2006/relationships">
+  <p:cSld>
+    <p:spTree>
+      <p:nvGrpSpPr>
+        <p:cNvPr id="1" name=""/>
+        <p:cNvGrpSpPr/>
+        <p:nvPr/>
+      </p:nvGrpSpPr>
+      <p:grpSpPr>
+        <a:xfrm>
+          <a:off x="0" y="0"/>
+          <a:ext cx="0" cy="0"/>
+          <a:chOff x="0" y="0"/>
+          <a:chExt cx="0" cy="0"/>
+        </a:xfrm>
+      </p:grpSpPr>
+      <p:sp>
+        <p:nvSpPr>
+          <p:cNvPr id="2" name="Slide Image Placeholder 1"/>
+          <p:cNvSpPr>
+            <a:spLocks noGrp="1"/>
+          </p:cNvSpPr>
+          <p:nvPr>
+            <p:ph type="sldImg" idx="2"/>
+          </p:nvPr>
+        </p:nvSpPr>
+        <p:spPr/>
+      </p:sp>
+      <p:sp>
+        <p:nvSpPr>
+          <p:cNvPr id="3" name="Notes Placeholder 2"/>
+          <p:cNvSpPr>
+            <a:spLocks noGrp="1"/>
+          </p:cNvSpPr>
+          <p:nvPr>
+            <p:ph type="body" idx="3" sz="quarter"/>
+          </p:nvPr>
+        </p:nvSpPr>
+        <p:spPr/>
+        <p:txBody>
+          <a:bodyPr/>
+          <a:lstStyle/>
+          <a:p>
+            <a:r>
+              <a:t>Speaker notes here.</a:t>
+            </a:r>
+          </a:p>
+        </p:txBody>
+      </p:sp>
+      <p:sp>
+        <p:nvSpPr>
+          <p:cNvPr id="4" name="Slide Number Placeholder 3"/>
+          <p:cNvSpPr>
+            <a:spLocks noGrp="1"/>
+          </p:cNvSpPr>
+          <p:nvPr>
+            <p:ph type="sldNum" idx="5" sz="quarter"/>
+          </p:nvPr>
+        </p:nvSpPr>
+        <p:spPr/>
+      </p:sp>
+    </p:spTree>
+  </p:cSld>
+  <p:clrMapOvr>
+    <a:masterClrMapping/>
+  </p:clrMapOvr>
+</p:notes>
+</file>
+
+<file path=ppt/notesSlides/notesSlide14.xml><?xml version="1.0" encoding="utf-8"?>
+<p:notes xmlns:a="http://schemas.openxmlformats.org/drawingml/2006/main" xmlns:p="http://schemas.openxmlformats.org/presentationml/2006/main" xmlns:r="http://schemas.openxmlformats.org/officeDocument/2006/relationships">
+  <p:cSld>
+    <p:spTree>
+      <p:nvGrpSpPr>
+        <p:cNvPr id="1" name=""/>
+        <p:cNvGrpSpPr/>
+        <p:nvPr/>
+      </p:nvGrpSpPr>
+      <p:grpSpPr>
+        <a:xfrm>
+          <a:off x="0" y="0"/>
+          <a:ext cx="0" cy="0"/>
+          <a:chOff x="0" y="0"/>
+          <a:chExt cx="0" cy="0"/>
+        </a:xfrm>
+      </p:grpSpPr>
+      <p:sp>
+        <p:nvSpPr>
+          <p:cNvPr id="2" name="Slide Image Placeholder 1"/>
+          <p:cNvSpPr>
+            <a:spLocks noGrp="1"/>
+          </p:cNvSpPr>
+          <p:nvPr>
+            <p:ph type="sldImg" idx="2"/>
+          </p:nvPr>
+        </p:nvSpPr>
+        <p:spPr/>
+      </p:sp>
+      <p:sp>
+        <p:nvSpPr>
+          <p:cNvPr id="3" name="Notes Placeholder 2"/>
+          <p:cNvSpPr>
+            <a:spLocks noGrp="1"/>
+          </p:cNvSpPr>
+          <p:nvPr>
+            <p:ph type="body" idx="3" sz="quarter"/>
+          </p:nvPr>
+        </p:nvSpPr>
+        <p:spPr/>
+        <p:txBody>
+          <a:bodyPr/>
+          <a:lstStyle/>
+          <a:p>
+            <a:r>
+              <a:t>Speaker notes here.</a:t>
+            </a:r>
+          </a:p>
+        </p:txBody>
+      </p:sp>
+      <p:sp>
+        <p:nvSpPr>
+          <p:cNvPr id="4" name="Slide Number Placeholder 3"/>
+          <p:cNvSpPr>
+            <a:spLocks noGrp="1"/>
+          </p:cNvSpPr>
+          <p:nvPr>
+            <p:ph type="sldNum" idx="5" sz="quarter"/>
+          </p:nvPr>
+        </p:nvSpPr>
+        <p:spPr/>
+      </p:sp>
+    </p:spTree>
+  </p:cSld>
+  <p:clrMapOvr>
+    <a:masterClrMapping/>
+  </p:clrMapOvr>
+</p:notes>
+</file>
+
+<file path=ppt/notesSlides/notesSlide15.xml><?xml version="1.0" encoding="utf-8"?>
+<p:notes xmlns:a="http://schemas.openxmlformats.org/drawingml/2006/main" xmlns:p="http://schemas.openxmlformats.org/presentationml/2006/main" xmlns:r="http://schemas.openxmlformats.org/officeDocument/2006/relationships">
+  <p:cSld>
+    <p:spTree>
+      <p:nvGrpSpPr>
+        <p:cNvPr id="1" name=""/>
+        <p:cNvGrpSpPr/>
+        <p:nvPr/>
+      </p:nvGrpSpPr>
+      <p:grpSpPr>
+        <a:xfrm>
+          <a:off x="0" y="0"/>
+          <a:ext cx="0" cy="0"/>
+          <a:chOff x="0" y="0"/>
+          <a:chExt cx="0" cy="0"/>
+        </a:xfrm>
+      </p:grpSpPr>
+      <p:sp>
+        <p:nvSpPr>
+          <p:cNvPr id="2" name="Slide Image Placeholder 1"/>
+          <p:cNvSpPr>
+            <a:spLocks noGrp="1"/>
+          </p:cNvSpPr>
+          <p:nvPr>
+            <p:ph type="sldImg" idx="2"/>
+          </p:nvPr>
+        </p:nvSpPr>
+        <p:spPr/>
+      </p:sp>
+      <p:sp>
+        <p:nvSpPr>
+          <p:cNvPr id="3" name="Notes Placeholder 2"/>
+          <p:cNvSpPr>
+            <a:spLocks noGrp="1"/>
+          </p:cNvSpPr>
+          <p:nvPr>
+            <p:ph type="body" idx="3" sz="quarter"/>
+          </p:nvPr>
+        </p:nvSpPr>
+        <p:spPr/>
+        <p:txBody>
+          <a:bodyPr/>
+          <a:lstStyle/>
+          <a:p>
+            <a:r>
+              <a:t>Speaker notes here.</a:t>
+            </a:r>
+          </a:p>
+        </p:txBody>
+      </p:sp>
+      <p:sp>
+        <p:nvSpPr>
+          <p:cNvPr id="4" name="Slide Number Placeholder 3"/>
+          <p:cNvSpPr>
+            <a:spLocks noGrp="1"/>
+          </p:cNvSpPr>
+          <p:nvPr>
+            <p:ph type="sldNum" idx="5" sz="quarter"/>
+          </p:nvPr>
+        </p:nvSpPr>
+        <p:spPr/>
+      </p:sp>
+    </p:spTree>
+  </p:cSld>
+  <p:clrMapOvr>
+    <a:masterClrMapping/>
+  </p:clrMapOvr>
+</p:notes>
+</file>
+
+<file path=ppt/notesSlides/notesSlide16.xml><?xml version="1.0" encoding="utf-8"?>
+<p:notes xmlns:a="http://schemas.openxmlformats.org/drawingml/2006/main" xmlns:p="http://schemas.openxmlformats.org/presentationml/2006/main" xmlns:r="http://schemas.openxmlformats.org/officeDocument/2006/relationships">
+  <p:cSld>
+    <p:spTree>
+      <p:nvGrpSpPr>
+        <p:cNvPr id="1" name=""/>
+        <p:cNvGrpSpPr/>
+        <p:nvPr/>
+      </p:nvGrpSpPr>
+      <p:grpSpPr>
+        <a:xfrm>
+          <a:off x="0" y="0"/>
+          <a:ext cx="0" cy="0"/>
+          <a:chOff x="0" y="0"/>
+          <a:chExt cx="0" cy="0"/>
+        </a:xfrm>
+      </p:grpSpPr>
+      <p:sp>
+        <p:nvSpPr>
+          <p:cNvPr id="2" name="Slide Image Placeholder 1"/>
+          <p:cNvSpPr>
+            <a:spLocks noGrp="1"/>
+          </p:cNvSpPr>
+          <p:nvPr>
+            <p:ph type="sldImg" idx="2"/>
+          </p:nvPr>
+        </p:nvSpPr>
+        <p:spPr/>
+      </p:sp>
+      <p:sp>
+        <p:nvSpPr>
+          <p:cNvPr id="3" name="Notes Placeholder 2"/>
+          <p:cNvSpPr>
+            <a:spLocks noGrp="1"/>
+          </p:cNvSpPr>
+          <p:nvPr>
+            <p:ph type="body" idx="3" sz="quarter"/>
+          </p:nvPr>
+        </p:nvSpPr>
+        <p:spPr/>
+        <p:txBody>
+          <a:bodyPr/>
+          <a:lstStyle/>
+          <a:p>
+            <a:r>
+              <a:t>Speaker notes here.</a:t>
+            </a:r>
+          </a:p>
+        </p:txBody>
+      </p:sp>
+      <p:sp>
+        <p:nvSpPr>
+          <p:cNvPr id="4" name="Slide Number Placeholder 3"/>
+          <p:cNvSpPr>
+            <a:spLocks noGrp="1"/>
+          </p:cNvSpPr>
+          <p:nvPr>
+            <p:ph type="sldNum" idx="5" sz="quarter"/>
+          </p:nvPr>
+        </p:nvSpPr>
+        <p:spPr/>
+      </p:sp>
+    </p:spTree>
+  </p:cSld>
+  <p:clrMapOvr>
+    <a:masterClrMapping/>
+  </p:clrMapOvr>
+</p:notes>
+</file>
+
+<file path=ppt/notesSlides/notesSlide17.xml><?xml version="1.0" encoding="utf-8"?>
+<p:notes xmlns:a="http://schemas.openxmlformats.org/drawingml/2006/main" xmlns:p="http://schemas.openxmlformats.org/presentationml/2006/main" xmlns:r="http://schemas.openxmlformats.org/officeDocument/2006/relationships">
+  <p:cSld>
+    <p:spTree>
+      <p:nvGrpSpPr>
+        <p:cNvPr id="1" name=""/>
+        <p:cNvGrpSpPr/>
+        <p:nvPr/>
+      </p:nvGrpSpPr>
+      <p:grpSpPr>
+        <a:xfrm>
+          <a:off x="0" y="0"/>
+          <a:ext cx="0" cy="0"/>
+          <a:chOff x="0" y="0"/>
+          <a:chExt cx="0" cy="0"/>
+        </a:xfrm>
+      </p:grpSpPr>
+      <p:sp>
+        <p:nvSpPr>
+          <p:cNvPr id="2" name="Slide Image Placeholder 1"/>
+          <p:cNvSpPr>
+            <a:spLocks noGrp="1"/>
+          </p:cNvSpPr>
+          <p:nvPr>
+            <p:ph type="sldImg" idx="2"/>
+          </p:nvPr>
+        </p:nvSpPr>
+        <p:spPr/>
+      </p:sp>
+      <p:sp>
+        <p:nvSpPr>
+          <p:cNvPr id="3" name="Notes Placeholder 2"/>
+          <p:cNvSpPr>
+            <a:spLocks noGrp="1"/>
+          </p:cNvSpPr>
+          <p:nvPr>
+            <p:ph type="body" idx="3" sz="quarter"/>
+          </p:nvPr>
+        </p:nvSpPr>
+        <p:spPr/>
+        <p:txBody>
+          <a:bodyPr/>
+          <a:lstStyle/>
+          <a:p>
+            <a:r>
+              <a:t>Speaker notes here.</a:t>
+            </a:r>
+          </a:p>
+        </p:txBody>
+      </p:sp>
+      <p:sp>
+        <p:nvSpPr>
+          <p:cNvPr id="4" name="Slide Number Placeholder 3"/>
+          <p:cNvSpPr>
+            <a:spLocks noGrp="1"/>
+          </p:cNvSpPr>
+          <p:nvPr>
+            <p:ph type="sldNum" idx="5" sz="quarter"/>
+          </p:nvPr>
+        </p:nvSpPr>
+        <p:spPr/>
+      </p:sp>
+    </p:spTree>
+  </p:cSld>
+  <p:clrMapOvr>
+    <a:masterClrMapping/>
+  </p:clrMapOvr>
+</p:notes>
+</file>
+
+<file path=ppt/notesSlides/notesSlide18.xml><?xml version="1.0" encoding="utf-8"?>
+<p:notes xmlns:a="http://schemas.openxmlformats.org/drawingml/2006/main" xmlns:p="http://schemas.openxmlformats.org/presentationml/2006/main" xmlns:r="http://schemas.openxmlformats.org/officeDocument/2006/relationships">
+  <p:cSld>
+    <p:spTree>
+      <p:nvGrpSpPr>
+        <p:cNvPr id="1" name=""/>
+        <p:cNvGrpSpPr/>
+        <p:nvPr/>
+      </p:nvGrpSpPr>
+      <p:grpSpPr>
+        <a:xfrm>
+          <a:off x="0" y="0"/>
+          <a:ext cx="0" cy="0"/>
+          <a:chOff x="0" y="0"/>
+          <a:chExt cx="0" cy="0"/>
+        </a:xfrm>
+      </p:grpSpPr>
+      <p:sp>
+        <p:nvSpPr>
+          <p:cNvPr id="2" name="Slide Image Placeholder 1"/>
+          <p:cNvSpPr>
+            <a:spLocks noGrp="1"/>
+          </p:cNvSpPr>
+          <p:nvPr>
+            <p:ph type="sldImg" idx="2"/>
+          </p:nvPr>
+        </p:nvSpPr>
+        <p:spPr/>
+      </p:sp>
+      <p:sp>
+        <p:nvSpPr>
+          <p:cNvPr id="3" name="Notes Placeholder 2"/>
+          <p:cNvSpPr>
+            <a:spLocks noGrp="1"/>
+          </p:cNvSpPr>
+          <p:nvPr>
+            <p:ph type="body" idx="3" sz="quarter"/>
+          </p:nvPr>
+        </p:nvSpPr>
+        <p:spPr/>
+        <p:txBody>
+          <a:bodyPr/>
+          <a:lstStyle/>
+          <a:p>
+            <a:r>
+              <a:t>Speaker notes here.</a:t>
+            </a:r>
+          </a:p>
+        </p:txBody>
+      </p:sp>
+      <p:sp>
+        <p:nvSpPr>
+          <p:cNvPr id="4" name="Slide Number Placeholder 3"/>
+          <p:cNvSpPr>
+            <a:spLocks noGrp="1"/>
+          </p:cNvSpPr>
+          <p:nvPr>
+            <p:ph type="sldNum" idx="5" sz="quarter"/>
+          </p:nvPr>
+        </p:nvSpPr>
+        <p:spPr/>
+      </p:sp>
+    </p:spTree>
+  </p:cSld>
+  <p:clrMapOvr>
+    <a:masterClrMapping/>
+  </p:clrMapOvr>
+</p:notes>
+</file>
+
+<file path=ppt/notesSlides/notesSlide19.xml><?xml version="1.0" encoding="utf-8"?>
+<p:notes xmlns:a="http://schemas.openxmlformats.org/drawingml/2006/main" xmlns:p="http://schemas.openxmlformats.org/presentationml/2006/main" xmlns:r="http://schemas.openxmlformats.org/officeDocument/2006/relationships">
+  <p:cSld>
+    <p:spTree>
+      <p:nvGrpSpPr>
+        <p:cNvPr id="1" name=""/>
+        <p:cNvGrpSpPr/>
+        <p:nvPr/>
+      </p:nvGrpSpPr>
+      <p:grpSpPr>
+        <a:xfrm>
+          <a:off x="0" y="0"/>
+          <a:ext cx="0" cy="0"/>
+          <a:chOff x="0" y="0"/>
+          <a:chExt cx="0" cy="0"/>
+        </a:xfrm>
+      </p:grpSpPr>
+      <p:sp>
+        <p:nvSpPr>
+          <p:cNvPr id="2" name="Slide Image Placeholder 1"/>
+          <p:cNvSpPr>
+            <a:spLocks noGrp="1"/>
+          </p:cNvSpPr>
+          <p:nvPr>
+            <p:ph type="sldImg" idx="2"/>
+          </p:nvPr>
+        </p:nvSpPr>
+        <p:spPr/>
+      </p:sp>
+      <p:sp>
+        <p:nvSpPr>
+          <p:cNvPr id="3" name="Notes Placeholder 2"/>
+          <p:cNvSpPr>
+            <a:spLocks noGrp="1"/>
+          </p:cNvSpPr>
+          <p:nvPr>
+            <p:ph type="body" idx="3" sz="quarter"/>
+          </p:nvPr>
+        </p:nvSpPr>
+        <p:spPr/>
+        <p:txBody>
+          <a:bodyPr/>
+          <a:lstStyle/>
+          <a:p>
+            <a:r>
+              <a:t>Speaker notes here.</a:t>
+            </a:r>
+          </a:p>
+        </p:txBody>
+      </p:sp>
+      <p:sp>
+        <p:nvSpPr>
+          <p:cNvPr id="4" name="Slide Number Placeholder 3"/>
+          <p:cNvSpPr>
+            <a:spLocks noGrp="1"/>
+          </p:cNvSpPr>
+          <p:nvPr>
+            <p:ph type="sldNum" idx="5" sz="quarter"/>
+          </p:nvPr>
+        </p:nvSpPr>
+        <p:spPr/>
+      </p:sp>
+    </p:spTree>
+  </p:cSld>
+  <p:clrMapOvr>
+    <a:masterClrMapping/>
+  </p:clrMapOvr>
+</p:notes>
+</file>
+
+<file path=ppt/notesSlides/notesSlide2.xml><?xml version="1.0" encoding="utf-8"?>
+<p:notes xmlns:a="http://schemas.openxmlformats.org/drawingml/2006/main" xmlns:p="http://schemas.openxmlformats.org/presentationml/2006/main" xmlns:r="http://schemas.openxmlformats.org/officeDocument/2006/relationships">
+  <p:cSld>
+    <p:spTree>
+      <p:nvGrpSpPr>
+        <p:cNvPr id="1" name=""/>
+        <p:cNvGrpSpPr/>
+        <p:nvPr/>
+      </p:nvGrpSpPr>
+      <p:grpSpPr>
+        <a:xfrm>
+          <a:off x="0" y="0"/>
+          <a:ext cx="0" cy="0"/>
+          <a:chOff x="0" y="0"/>
+          <a:chExt cx="0" cy="0"/>
+        </a:xfrm>
+      </p:grpSpPr>
+      <p:sp>
+        <p:nvSpPr>
+          <p:cNvPr id="2" name="Slide Image Placeholder 1"/>
+          <p:cNvSpPr>
+            <a:spLocks noGrp="1"/>
+          </p:cNvSpPr>
+          <p:nvPr>
+            <p:ph type="sldImg" idx="2"/>
+          </p:nvPr>
+        </p:nvSpPr>
+        <p:spPr/>
+      </p:sp>
+      <p:sp>
+        <p:nvSpPr>
+          <p:cNvPr id="3" name="Notes Placeholder 2"/>
+          <p:cNvSpPr>
+            <a:spLocks noGrp="1"/>
+          </p:cNvSpPr>
+          <p:nvPr>
+            <p:ph type="body" idx="3" sz="quarter"/>
+          </p:nvPr>
+        </p:nvSpPr>
+        <p:spPr/>
+        <p:txBody>
+          <a:bodyPr/>
+          <a:lstStyle/>
+          <a:p>
+            <a:r>
+              <a:t>Speaker notes here.</a:t>
+            </a:r>
+          </a:p>
+        </p:txBody>
+      </p:sp>
+      <p:sp>
+        <p:nvSpPr>
+          <p:cNvPr id="4" name="Slide Number Placeholder 3"/>
+          <p:cNvSpPr>
+            <a:spLocks noGrp="1"/>
+          </p:cNvSpPr>
+          <p:nvPr>
+            <p:ph type="sldNum" idx="5" sz="quarter"/>
+          </p:nvPr>
+        </p:nvSpPr>
+        <p:spPr/>
+      </p:sp>
+    </p:spTree>
+  </p:cSld>
+  <p:clrMapOvr>
+    <a:masterClrMapping/>
+  </p:clrMapOvr>
+</p:notes>
+</file>
+
+<file path=ppt/notesSlides/notesSlide20.xml><?xml version="1.0" encoding="utf-8"?>
+<p:notes xmlns:a="http://schemas.openxmlformats.org/drawingml/2006/main" xmlns:p="http://schemas.openxmlformats.org/presentationml/2006/main" xmlns:r="http://schemas.openxmlformats.org/officeDocument/2006/relationships">
+  <p:cSld>
+    <p:spTree>
+      <p:nvGrpSpPr>
+        <p:cNvPr id="1" name=""/>
+        <p:cNvGrpSpPr/>
+        <p:nvPr/>
+      </p:nvGrpSpPr>
+      <p:grpSpPr>
+        <a:xfrm>
+          <a:off x="0" y="0"/>
+          <a:ext cx="0" cy="0"/>
+          <a:chOff x="0" y="0"/>
+          <a:chExt cx="0" cy="0"/>
+        </a:xfrm>
+      </p:grpSpPr>
+      <p:sp>
+        <p:nvSpPr>
+          <p:cNvPr id="2" name="Slide Image Placeholder 1"/>
+          <p:cNvSpPr>
+            <a:spLocks noGrp="1"/>
+          </p:cNvSpPr>
+          <p:nvPr>
+            <p:ph type="sldImg" idx="2"/>
+          </p:nvPr>
+        </p:nvSpPr>
+        <p:spPr/>
+      </p:sp>
+      <p:sp>
+        <p:nvSpPr>
+          <p:cNvPr id="3" name="Notes Placeholder 2"/>
+          <p:cNvSpPr>
+            <a:spLocks noGrp="1"/>
+          </p:cNvSpPr>
+          <p:nvPr>
+            <p:ph type="body" idx="3" sz="quarter"/>
+          </p:nvPr>
+        </p:nvSpPr>
+        <p:spPr/>
+        <p:txBody>
+          <a:bodyPr/>
+          <a:lstStyle/>
+          <a:p>
+            <a:r>
+              <a:t>Speaker notes here.</a:t>
+            </a:r>
+          </a:p>
+        </p:txBody>
+      </p:sp>
+      <p:sp>
+        <p:nvSpPr>
+          <p:cNvPr id="4" name="Slide Number Placeholder 3"/>
+          <p:cNvSpPr>
+            <a:spLocks noGrp="1"/>
+          </p:cNvSpPr>
+          <p:nvPr>
+            <p:ph type="sldNum" idx="5" sz="quarter"/>
+          </p:nvPr>
+        </p:nvSpPr>
+        <p:spPr/>
+      </p:sp>
+    </p:spTree>
+  </p:cSld>
+  <p:clrMapOvr>
+    <a:masterClrMapping/>
+  </p:clrMapOvr>
+</p:notes>
+</file>
+
+<file path=ppt/notesSlides/notesSlide3.xml><?xml version="1.0" encoding="utf-8"?>
+<p:notes xmlns:a="http://schemas.openxmlformats.org/drawingml/2006/main" xmlns:p="http://schemas.openxmlformats.org/presentationml/2006/main" xmlns:r="http://schemas.openxmlformats.org/officeDocument/2006/relationships">
+  <p:cSld>
+    <p:spTree>
+      <p:nvGrpSpPr>
+        <p:cNvPr id="1" name=""/>
+        <p:cNvGrpSpPr/>
+        <p:nvPr/>
+      </p:nvGrpSpPr>
+      <p:grpSpPr>
+        <a:xfrm>
+          <a:off x="0" y="0"/>
+          <a:ext cx="0" cy="0"/>
+          <a:chOff x="0" y="0"/>
+          <a:chExt cx="0" cy="0"/>
+        </a:xfrm>
+      </p:grpSpPr>
+      <p:sp>
+        <p:nvSpPr>
+          <p:cNvPr id="2" name="Slide Image Placeholder 1"/>
+          <p:cNvSpPr>
+            <a:spLocks noGrp="1"/>
+          </p:cNvSpPr>
+          <p:nvPr>
+            <p:ph type="sldImg" idx="2"/>
+          </p:nvPr>
+        </p:nvSpPr>
+        <p:spPr/>
+      </p:sp>
+      <p:sp>
+        <p:nvSpPr>
+          <p:cNvPr id="3" name="Notes Placeholder 2"/>
+          <p:cNvSpPr>
+            <a:spLocks noGrp="1"/>
+          </p:cNvSpPr>
+          <p:nvPr>
+            <p:ph type="body" idx="3" sz="quarter"/>
+          </p:nvPr>
+        </p:nvSpPr>
+        <p:spPr/>
+        <p:txBody>
+          <a:bodyPr/>
+          <a:lstStyle/>
+          <a:p>
+            <a:r>
+              <a:t>Speaker notes here.</a:t>
+            </a:r>
+          </a:p>
+        </p:txBody>
+      </p:sp>
+      <p:sp>
+        <p:nvSpPr>
+          <p:cNvPr id="4" name="Slide Number Placeholder 3"/>
+          <p:cNvSpPr>
+            <a:spLocks noGrp="1"/>
+          </p:cNvSpPr>
+          <p:nvPr>
+            <p:ph type="sldNum" idx="5" sz="quarter"/>
+          </p:nvPr>
+        </p:nvSpPr>
+        <p:spPr/>
+      </p:sp>
+    </p:spTree>
+  </p:cSld>
+  <p:clrMapOvr>
+    <a:masterClrMapping/>
+  </p:clrMapOvr>
+</p:notes>
+</file>
+
+<file path=ppt/notesSlides/notesSlide4.xml><?xml version="1.0" encoding="utf-8"?>
+<p:notes xmlns:a="http://schemas.openxmlformats.org/drawingml/2006/main" xmlns:p="http://schemas.openxmlformats.org/presentationml/2006/main" xmlns:r="http://schemas.openxmlformats.org/officeDocument/2006/relationships">
+  <p:cSld>
+    <p:spTree>
+      <p:nvGrpSpPr>
+        <p:cNvPr id="1" name=""/>
+        <p:cNvGrpSpPr/>
+        <p:nvPr/>
+      </p:nvGrpSpPr>
+      <p:grpSpPr>
+        <a:xfrm>
+          <a:off x="0" y="0"/>
+          <a:ext cx="0" cy="0"/>
+          <a:chOff x="0" y="0"/>
+          <a:chExt cx="0" cy="0"/>
+        </a:xfrm>
+      </p:grpSpPr>
+      <p:sp>
+        <p:nvSpPr>
+          <p:cNvPr id="2" name="Slide Image Placeholder 1"/>
+          <p:cNvSpPr>
+            <a:spLocks noGrp="1"/>
+          </p:cNvSpPr>
+          <p:nvPr>
+            <p:ph type="sldImg" idx="2"/>
+          </p:nvPr>
+        </p:nvSpPr>
+        <p:spPr/>
+      </p:sp>
+      <p:sp>
+        <p:nvSpPr>
+          <p:cNvPr id="3" name="Notes Placeholder 2"/>
+          <p:cNvSpPr>
+            <a:spLocks noGrp="1"/>
+          </p:cNvSpPr>
+          <p:nvPr>
+            <p:ph type="body" idx="3" sz="quarter"/>
+          </p:nvPr>
+        </p:nvSpPr>
+        <p:spPr/>
+        <p:txBody>
+          <a:bodyPr/>
+          <a:lstStyle/>
+          <a:p>
+            <a:r>
+              <a:t>Speaker notes here.</a:t>
+            </a:r>
+          </a:p>
+        </p:txBody>
+      </p:sp>
+      <p:sp>
+        <p:nvSpPr>
+          <p:cNvPr id="4" name="Slide Number Placeholder 3"/>
+          <p:cNvSpPr>
+            <a:spLocks noGrp="1"/>
+          </p:cNvSpPr>
+          <p:nvPr>
+            <p:ph type="sldNum" idx="5" sz="quarter"/>
+          </p:nvPr>
+        </p:nvSpPr>
+        <p:spPr/>
+      </p:sp>
+    </p:spTree>
+  </p:cSld>
+  <p:clrMapOvr>
+    <a:masterClrMapping/>
+  </p:clrMapOvr>
+</p:notes>
+</file>
+
+<file path=ppt/notesSlides/notesSlide5.xml><?xml version="1.0" encoding="utf-8"?>
+<p:notes xmlns:a="http://schemas.openxmlformats.org/drawingml/2006/main" xmlns:p="http://schemas.openxmlformats.org/presentationml/2006/main" xmlns:r="http://schemas.openxmlformats.org/officeDocument/2006/relationships">
+  <p:cSld>
+    <p:spTree>
+      <p:nvGrpSpPr>
+        <p:cNvPr id="1" name=""/>
+        <p:cNvGrpSpPr/>
+        <p:nvPr/>
+      </p:nvGrpSpPr>
+      <p:grpSpPr>
+        <a:xfrm>
+          <a:off x="0" y="0"/>
+          <a:ext cx="0" cy="0"/>
+          <a:chOff x="0" y="0"/>
+          <a:chExt cx="0" cy="0"/>
+        </a:xfrm>
+      </p:grpSpPr>
+      <p:sp>
+        <p:nvSpPr>
+          <p:cNvPr id="2" name="Slide Image Placeholder 1"/>
+          <p:cNvSpPr>
+            <a:spLocks noGrp="1"/>
+          </p:cNvSpPr>
+          <p:nvPr>
+            <p:ph type="sldImg" idx="2"/>
+          </p:nvPr>
+        </p:nvSpPr>
+        <p:spPr/>
+      </p:sp>
+      <p:sp>
+        <p:nvSpPr>
+          <p:cNvPr id="3" name="Notes Placeholder 2"/>
+          <p:cNvSpPr>
+            <a:spLocks noGrp="1"/>
+          </p:cNvSpPr>
+          <p:nvPr>
+            <p:ph type="body" idx="3" sz="quarter"/>
+          </p:nvPr>
+        </p:nvSpPr>
+        <p:spPr/>
+        <p:txBody>
+          <a:bodyPr/>
+          <a:lstStyle/>
+          <a:p>
+            <a:r>
+              <a:t>Speaker notes here.</a:t>
+            </a:r>
+          </a:p>
+        </p:txBody>
+      </p:sp>
+      <p:sp>
+        <p:nvSpPr>
+          <p:cNvPr id="4" name="Slide Number Placeholder 3"/>
+          <p:cNvSpPr>
+            <a:spLocks noGrp="1"/>
+          </p:cNvSpPr>
+          <p:nvPr>
+            <p:ph type="sldNum" idx="5" sz="quarter"/>
+          </p:nvPr>
+        </p:nvSpPr>
+        <p:spPr/>
+      </p:sp>
+    </p:spTree>
+  </p:cSld>
+  <p:clrMapOvr>
+    <a:masterClrMapping/>
+  </p:clrMapOvr>
+</p:notes>
+</file>
+
+<file path=ppt/notesSlides/notesSlide6.xml><?xml version="1.0" encoding="utf-8"?>
+<p:notes xmlns:a="http://schemas.openxmlformats.org/drawingml/2006/main" xmlns:p="http://schemas.openxmlformats.org/presentationml/2006/main" xmlns:r="http://schemas.openxmlformats.org/officeDocument/2006/relationships">
+  <p:cSld>
+    <p:spTree>
+      <p:nvGrpSpPr>
+        <p:cNvPr id="1" name=""/>
+        <p:cNvGrpSpPr/>
+        <p:nvPr/>
+      </p:nvGrpSpPr>
+      <p:grpSpPr>
+        <a:xfrm>
+          <a:off x="0" y="0"/>
+          <a:ext cx="0" cy="0"/>
+          <a:chOff x="0" y="0"/>
+          <a:chExt cx="0" cy="0"/>
+        </a:xfrm>
+      </p:grpSpPr>
+      <p:sp>
+        <p:nvSpPr>
+          <p:cNvPr id="2" name="Slide Image Placeholder 1"/>
+          <p:cNvSpPr>
+            <a:spLocks noGrp="1"/>
+          </p:cNvSpPr>
+          <p:nvPr>
+            <p:ph type="sldImg" idx="2"/>
+          </p:nvPr>
+        </p:nvSpPr>
+        <p:spPr/>
+      </p:sp>
+      <p:sp>
+        <p:nvSpPr>
+          <p:cNvPr id="3" name="Notes Placeholder 2"/>
+          <p:cNvSpPr>
+            <a:spLocks noGrp="1"/>
+          </p:cNvSpPr>
+          <p:nvPr>
+            <p:ph type="body" idx="3" sz="quarter"/>
+          </p:nvPr>
+        </p:nvSpPr>
+        <p:spPr/>
+        <p:txBody>
+          <a:bodyPr/>
+          <a:lstStyle/>
+          <a:p>
+            <a:r>
+              <a:t>Speaker notes here.</a:t>
+            </a:r>
+          </a:p>
+        </p:txBody>
+      </p:sp>
+      <p:sp>
+        <p:nvSpPr>
+          <p:cNvPr id="4" name="Slide Number Placeholder 3"/>
+          <p:cNvSpPr>
+            <a:spLocks noGrp="1"/>
+          </p:cNvSpPr>
+          <p:nvPr>
+            <p:ph type="sldNum" idx="5" sz="quarter"/>
+          </p:nvPr>
+        </p:nvSpPr>
+        <p:spPr/>
+      </p:sp>
+    </p:spTree>
+  </p:cSld>
+  <p:clrMapOvr>
+    <a:masterClrMapping/>
+  </p:clrMapOvr>
+</p:notes>
+</file>
+
+<file path=ppt/notesSlides/notesSlide7.xml><?xml version="1.0" encoding="utf-8"?>
+<p:notes xmlns:a="http://schemas.openxmlformats.org/drawingml/2006/main" xmlns:p="http://schemas.openxmlformats.org/presentationml/2006/main" xmlns:r="http://schemas.openxmlformats.org/officeDocument/2006/relationships">
+  <p:cSld>
+    <p:spTree>
+      <p:nvGrpSpPr>
+        <p:cNvPr id="1" name=""/>
+        <p:cNvGrpSpPr/>
+        <p:nvPr/>
+      </p:nvGrpSpPr>
+      <p:grpSpPr>
+        <a:xfrm>
+          <a:off x="0" y="0"/>
+          <a:ext cx="0" cy="0"/>
+          <a:chOff x="0" y="0"/>
+          <a:chExt cx="0" cy="0"/>
+        </a:xfrm>
+      </p:grpSpPr>
+      <p:sp>
+        <p:nvSpPr>
+          <p:cNvPr id="2" name="Slide Image Placeholder 1"/>
+          <p:cNvSpPr>
+            <a:spLocks noGrp="1"/>
+          </p:cNvSpPr>
+          <p:nvPr>
+            <p:ph type="sldImg" idx="2"/>
+          </p:nvPr>
+        </p:nvSpPr>
+        <p:spPr/>
+      </p:sp>
+      <p:sp>
+        <p:nvSpPr>
+          <p:cNvPr id="3" name="Notes Placeholder 2"/>
+          <p:cNvSpPr>
+            <a:spLocks noGrp="1"/>
+          </p:cNvSpPr>
+          <p:nvPr>
+            <p:ph type="body" idx="3" sz="quarter"/>
+          </p:nvPr>
+        </p:nvSpPr>
+        <p:spPr/>
+        <p:txBody>
+          <a:bodyPr/>
+          <a:lstStyle/>
+          <a:p>
+            <a:r>
+              <a:t>Speaker notes here.</a:t>
+            </a:r>
+          </a:p>
+        </p:txBody>
+      </p:sp>
+      <p:sp>
+        <p:nvSpPr>
+          <p:cNvPr id="4" name="Slide Number Placeholder 3"/>
+          <p:cNvSpPr>
+            <a:spLocks noGrp="1"/>
+          </p:cNvSpPr>
+          <p:nvPr>
+            <p:ph type="sldNum" idx="5" sz="quarter"/>
+          </p:nvPr>
+        </p:nvSpPr>
+        <p:spPr/>
+      </p:sp>
+    </p:spTree>
+  </p:cSld>
+  <p:clrMapOvr>
+    <a:masterClrMapping/>
+  </p:clrMapOvr>
+</p:notes>
+</file>
+
+<file path=ppt/notesSlides/notesSlide8.xml><?xml version="1.0" encoding="utf-8"?>
+<p:notes xmlns:a="http://schemas.openxmlformats.org/drawingml/2006/main" xmlns:p="http://schemas.openxmlformats.org/presentationml/2006/main" xmlns:r="http://schemas.openxmlformats.org/officeDocument/2006/relationships">
+  <p:cSld>
+    <p:spTree>
+      <p:nvGrpSpPr>
+        <p:cNvPr id="1" name=""/>
+        <p:cNvGrpSpPr/>
+        <p:nvPr/>
+      </p:nvGrpSpPr>
+      <p:grpSpPr>
+        <a:xfrm>
+          <a:off x="0" y="0"/>
+          <a:ext cx="0" cy="0"/>
+          <a:chOff x="0" y="0"/>
+          <a:chExt cx="0" cy="0"/>
+        </a:xfrm>
+      </p:grpSpPr>
+      <p:sp>
+        <p:nvSpPr>
+          <p:cNvPr id="2" name="Slide Image Placeholder 1"/>
+          <p:cNvSpPr>
+            <a:spLocks noGrp="1"/>
+          </p:cNvSpPr>
+          <p:nvPr>
+            <p:ph type="sldImg" idx="2"/>
+          </p:nvPr>
+        </p:nvSpPr>
+        <p:spPr/>
+      </p:sp>
+      <p:sp>
+        <p:nvSpPr>
+          <p:cNvPr id="3" name="Notes Placeholder 2"/>
+          <p:cNvSpPr>
+            <a:spLocks noGrp="1"/>
+          </p:cNvSpPr>
+          <p:nvPr>
+            <p:ph type="body" idx="3" sz="quarter"/>
+          </p:nvPr>
+        </p:nvSpPr>
+        <p:spPr/>
+        <p:txBody>
+          <a:bodyPr/>
+          <a:lstStyle/>
+          <a:p>
+            <a:r>
+              <a:t>Speaker notes here.</a:t>
+            </a:r>
+          </a:p>
+        </p:txBody>
+      </p:sp>
+      <p:sp>
+        <p:nvSpPr>
+          <p:cNvPr id="4" name="Slide Number Placeholder 3"/>
+          <p:cNvSpPr>
+            <a:spLocks noGrp="1"/>
+          </p:cNvSpPr>
+          <p:nvPr>
+            <p:ph type="sldNum" idx="5" sz="quarter"/>
+          </p:nvPr>
+        </p:nvSpPr>
+        <p:spPr/>
+      </p:sp>
+    </p:spTree>
+  </p:cSld>
+  <p:clrMapOvr>
+    <a:masterClrMapping/>
+  </p:clrMapOvr>
+</p:notes>
+</file>
+
+<file path=ppt/notesSlides/notesSlide9.xml><?xml version="1.0" encoding="utf-8"?>
+<p:notes xmlns:a="http://schemas.openxmlformats.org/drawingml/2006/main" xmlns:p="http://schemas.openxmlformats.org/presentationml/2006/main" xmlns:r="http://schemas.openxmlformats.org/officeDocument/2006/relationships">
+  <p:cSld>
+    <p:spTree>
+      <p:nvGrpSpPr>
+        <p:cNvPr id="1" name=""/>
+        <p:cNvGrpSpPr/>
+        <p:nvPr/>
+      </p:nvGrpSpPr>
+      <p:grpSpPr>
+        <a:xfrm>
+          <a:off x="0" y="0"/>
+          <a:ext cx="0" cy="0"/>
+          <a:chOff x="0" y="0"/>
+          <a:chExt cx="0" cy="0"/>
+        </a:xfrm>
+      </p:grpSpPr>
+      <p:sp>
+        <p:nvSpPr>
+          <p:cNvPr id="2" name="Slide Image Placeholder 1"/>
+          <p:cNvSpPr>
+            <a:spLocks noGrp="1"/>
+          </p:cNvSpPr>
+          <p:nvPr>
+            <p:ph type="sldImg" idx="2"/>
+          </p:nvPr>
+        </p:nvSpPr>
+        <p:spPr/>
+      </p:sp>
+      <p:sp>
+        <p:nvSpPr>
+          <p:cNvPr id="3" name="Notes Placeholder 2"/>
+          <p:cNvSpPr>
+            <a:spLocks noGrp="1"/>
+          </p:cNvSpPr>
+          <p:nvPr>
+            <p:ph type="body" idx="3" sz="quarter"/>
+          </p:nvPr>
+        </p:nvSpPr>
+        <p:spPr/>
+        <p:txBody>
+          <a:bodyPr/>
+          <a:lstStyle/>
+          <a:p>
+            <a:r>
+              <a:t>Speaker notes here.</a:t>
+            </a:r>
+          </a:p>
+        </p:txBody>
+      </p:sp>
+      <p:sp>
+        <p:nvSpPr>
+          <p:cNvPr id="4" name="Slide Number Placeholder 3"/>
+          <p:cNvSpPr>
+            <a:spLocks noGrp="1"/>
+          </p:cNvSpPr>
+          <p:nvPr>
+            <p:ph type="sldNum" idx="5" sz="quarter"/>
+          </p:nvPr>
+        </p:nvSpPr>
+        <p:spPr/>
+      </p:sp>
+    </p:spTree>
+  </p:cSld>
+  <p:clrMapOvr>
+    <a:masterClrMapping/>
+  </p:clrMapOvr>
+</p:notes>
 </file>
 
 <file path=ppt/slideLayouts/slideLayout1.xml><?xml version="1.0" encoding="utf-8"?>
@@ -3942,7 +5819,7 @@
         <p:spPr>
           <a:xfrm>
             <a:off x="822960" y="1033271"/>
-            <a:ext cx="2377440" cy="38100"/>
+            <a:ext cx="4754880" cy="38100"/>
           </a:xfrm>
           <a:prstGeom prst="rect">
             <a:avLst/>
@@ -4076,7 +5953,7 @@
                 </a:solidFill>
                 <a:latin typeface="Arial"/>
               </a:rPr>
-              <a:t>Text + Chart</a:t>
+              <a:t>Histogram</a:t>
             </a:r>
           </a:p>
         </p:txBody>
@@ -4090,7 +5967,7 @@
         <p:spPr>
           <a:xfrm>
             <a:off x="822960" y="1033271"/>
-            <a:ext cx="2377440" cy="38100"/>
+            <a:ext cx="4754880" cy="38100"/>
           </a:xfrm>
           <a:prstGeom prst="rect">
             <a:avLst/>
@@ -4133,6 +6010,154 @@
         </p:nvSpPr>
         <p:spPr>
           <a:xfrm>
+            <a:off x="822960" y="1463040"/>
+            <a:ext cx="10545775" cy="548640"/>
+          </a:xfrm>
+          <a:prstGeom prst="rect">
+            <a:avLst/>
+          </a:prstGeom>
+          <a:noFill/>
+        </p:spPr>
+        <p:txBody>
+          <a:bodyPr wrap="square">
+            <a:spAutoFit/>
+          </a:bodyPr>
+          <a:lstStyle/>
+          <a:p>
+            <a:r>
+              <a:rPr sz="1600" b="0" i="0">
+                <a:solidFill>
+                  <a:srgbClr val="6B7280"/>
+                </a:solidFill>
+                <a:latin typeface="Arial"/>
+              </a:rPr>
+              <a:t>One-line takeaway about the distribution.</a:t>
+            </a:r>
+          </a:p>
+        </p:txBody>
+      </p:sp>
+      <p:graphicFrame>
+        <p:nvGraphicFramePr>
+          <p:cNvPr id="5" name="Chart 4"/>
+          <p:cNvGraphicFramePr>
+            <a:graphicFrameLocks noGrp="1"/>
+          </p:cNvGraphicFramePr>
+          <p:nvPr/>
+        </p:nvGraphicFramePr>
+        <p:xfrm>
+          <a:off x="822960" y="2148840"/>
+          <a:ext cx="10545775" cy="4160520"/>
+        </p:xfrm>
+        <a:graphic>
+          <a:graphicData uri="http://schemas.openxmlformats.org/drawingml/2006/chart">
+            <c:chart xmlns:c="http://schemas.openxmlformats.org/drawingml/2006/chart" r:id="rId2"/>
+          </a:graphicData>
+        </a:graphic>
+      </p:graphicFrame>
+    </p:spTree>
+  </p:cSld>
+  <p:clrMapOvr>
+    <a:masterClrMapping/>
+  </p:clrMapOvr>
+</p:sld>
+</file>
+
+<file path=ppt/slides/slide12.xml><?xml version="1.0" encoding="utf-8"?>
+<p:sld xmlns:a="http://schemas.openxmlformats.org/drawingml/2006/main" xmlns:p="http://schemas.openxmlformats.org/presentationml/2006/main" xmlns:r="http://schemas.openxmlformats.org/officeDocument/2006/relationships">
+  <p:cSld>
+    <p:spTree>
+      <p:nvGrpSpPr>
+        <p:cNvPr id="1" name=""/>
+        <p:cNvGrpSpPr/>
+        <p:nvPr/>
+      </p:nvGrpSpPr>
+      <p:grpSpPr/>
+      <p:sp>
+        <p:nvSpPr>
+          <p:cNvPr id="2" name="TextBox 1"/>
+          <p:cNvSpPr txBox="1"/>
+          <p:nvPr/>
+        </p:nvSpPr>
+        <p:spPr>
+          <a:xfrm>
+            <a:off x="822960" y="502920"/>
+            <a:ext cx="10545775" cy="914400"/>
+          </a:xfrm>
+          <a:prstGeom prst="rect">
+            <a:avLst/>
+          </a:prstGeom>
+          <a:noFill/>
+        </p:spPr>
+        <p:txBody>
+          <a:bodyPr wrap="square">
+            <a:spAutoFit/>
+          </a:bodyPr>
+          <a:lstStyle/>
+          <a:p>
+            <a:r>
+              <a:rPr sz="3000" b="1" i="0">
+                <a:solidFill>
+                  <a:srgbClr val="262A2E"/>
+                </a:solidFill>
+                <a:latin typeface="Arial"/>
+              </a:rPr>
+              <a:t>Text + Chart</a:t>
+            </a:r>
+          </a:p>
+        </p:txBody>
+      </p:sp>
+      <p:sp>
+        <p:nvSpPr>
+          <p:cNvPr id="3" name="Rectangle 2"/>
+          <p:cNvSpPr/>
+          <p:nvPr/>
+        </p:nvSpPr>
+        <p:spPr>
+          <a:xfrm>
+            <a:off x="822960" y="1033271"/>
+            <a:ext cx="4754880" cy="38100"/>
+          </a:xfrm>
+          <a:prstGeom prst="rect">
+            <a:avLst/>
+          </a:prstGeom>
+          <a:solidFill>
+            <a:srgbClr val="3B6EA5"/>
+          </a:solidFill>
+          <a:ln>
+            <a:noFill/>
+          </a:ln>
+          <a:effectLst/>
+        </p:spPr>
+        <p:style>
+          <a:lnRef idx="1">
+            <a:schemeClr val="accent1"/>
+          </a:lnRef>
+          <a:fillRef idx="3">
+            <a:schemeClr val="accent1"/>
+          </a:fillRef>
+          <a:effectRef idx="2">
+            <a:schemeClr val="accent1"/>
+          </a:effectRef>
+          <a:fontRef idx="minor">
+            <a:schemeClr val="lt1"/>
+          </a:fontRef>
+        </p:style>
+        <p:txBody>
+          <a:bodyPr rtlCol="0" anchor="ctr"/>
+          <a:lstStyle/>
+          <a:p>
+            <a:pPr algn="ctr"/>
+          </a:p>
+        </p:txBody>
+      </p:sp>
+      <p:sp>
+        <p:nvSpPr>
+          <p:cNvPr id="4" name="TextBox 3"/>
+          <p:cNvSpPr txBox="1"/>
+          <p:nvPr/>
+        </p:nvSpPr>
+        <p:spPr>
+          <a:xfrm>
             <a:off x="822960" y="1828800"/>
             <a:ext cx="4297680" cy="4206240"/>
           </a:xfrm>
@@ -4238,7 +6263,7 @@
 </p:sld>
 </file>
 
-<file path=ppt/slides/slide12.xml><?xml version="1.0" encoding="utf-8"?>
+<file path=ppt/slides/slide13.xml><?xml version="1.0" encoding="utf-8"?>
 <p:sld xmlns:a="http://schemas.openxmlformats.org/drawingml/2006/main" xmlns:p="http://schemas.openxmlformats.org/presentationml/2006/main" xmlns:r="http://schemas.openxmlformats.org/officeDocument/2006/relationships">
   <p:cSld>
     <p:spTree>
@@ -4291,7 +6316,7 @@
         <p:spPr>
           <a:xfrm>
             <a:off x="822960" y="1033271"/>
-            <a:ext cx="2377440" cy="38100"/>
+            <a:ext cx="4754880" cy="38100"/>
           </a:xfrm>
           <a:prstGeom prst="rect">
             <a:avLst/>
@@ -4626,7 +6651,7 @@
         <p:spPr>
           <a:xfrm>
             <a:off x="822960" y="5029200"/>
-            <a:ext cx="10545775" cy="457200"/>
+            <a:ext cx="10545775" cy="548640"/>
           </a:xfrm>
           <a:prstGeom prst="rect">
             <a:avLst/>
@@ -4640,7 +6665,7 @@
           <a:lstStyle/>
           <a:p>
             <a:r>
-              <a:rPr sz="1200" b="0" i="1">
+              <a:rPr sz="1600" b="0" i="0">
                 <a:solidFill>
                   <a:srgbClr val="6B7280"/>
                 </a:solidFill>
@@ -4659,7 +6684,7 @@
 </p:sld>
 </file>
 
-<file path=ppt/slides/slide13.xml><?xml version="1.0" encoding="utf-8"?>
+<file path=ppt/slides/slide14.xml><?xml version="1.0" encoding="utf-8"?>
 <p:sld xmlns:a="http://schemas.openxmlformats.org/drawingml/2006/main" xmlns:p="http://schemas.openxmlformats.org/presentationml/2006/main" xmlns:r="http://schemas.openxmlformats.org/officeDocument/2006/relationships">
   <p:cSld>
     <p:spTree>
@@ -4712,7 +6737,7 @@
         <p:spPr>
           <a:xfrm>
             <a:off x="822960" y="1033271"/>
-            <a:ext cx="2377440" cy="38100"/>
+            <a:ext cx="4754880" cy="38100"/>
           </a:xfrm>
           <a:prstGeom prst="rect">
             <a:avLst/>
@@ -5304,7 +7329,7 @@
         <p:spPr>
           <a:xfrm>
             <a:off x="822960" y="5029200"/>
-            <a:ext cx="10545775" cy="457200"/>
+            <a:ext cx="10545775" cy="548640"/>
           </a:xfrm>
           <a:prstGeom prst="rect">
             <a:avLst/>
@@ -5318,7 +7343,7 @@
           <a:lstStyle/>
           <a:p>
             <a:r>
-              <a:rPr sz="1200" b="0" i="1">
+              <a:rPr sz="1600" b="0" i="0">
                 <a:solidFill>
                   <a:srgbClr val="6B7280"/>
                 </a:solidFill>
@@ -5337,7 +7362,7 @@
 </p:sld>
 </file>
 
-<file path=ppt/slides/slide14.xml><?xml version="1.0" encoding="utf-8"?>
+<file path=ppt/slides/slide15.xml><?xml version="1.0" encoding="utf-8"?>
 <p:sld xmlns:a="http://schemas.openxmlformats.org/drawingml/2006/main" xmlns:p="http://schemas.openxmlformats.org/presentationml/2006/main" xmlns:r="http://schemas.openxmlformats.org/officeDocument/2006/relationships">
   <p:cSld>
     <p:spTree>
@@ -5390,7 +7415,7 @@
         <p:spPr>
           <a:xfrm>
             <a:off x="822960" y="1033271"/>
-            <a:ext cx="2377440" cy="38100"/>
+            <a:ext cx="4754880" cy="38100"/>
           </a:xfrm>
           <a:prstGeom prst="rect">
             <a:avLst/>
@@ -5791,6 +7816,40 @@
           </a:graphicData>
         </a:graphic>
       </p:graphicFrame>
+      <p:sp>
+        <p:nvSpPr>
+          <p:cNvPr id="7" name="TextBox 6"/>
+          <p:cNvSpPr txBox="1"/>
+          <p:nvPr/>
+        </p:nvSpPr>
+        <p:spPr>
+          <a:xfrm>
+            <a:off x="822960" y="5212080"/>
+            <a:ext cx="10545775" cy="548640"/>
+          </a:xfrm>
+          <a:prstGeom prst="rect">
+            <a:avLst/>
+          </a:prstGeom>
+          <a:noFill/>
+        </p:spPr>
+        <p:txBody>
+          <a:bodyPr wrap="square">
+            <a:spAutoFit/>
+          </a:bodyPr>
+          <a:lstStyle/>
+          <a:p>
+            <a:r>
+              <a:rPr sz="1600" b="0" i="0">
+                <a:solidFill>
+                  <a:srgbClr val="6B7280"/>
+                </a:solidFill>
+                <a:latin typeface="Arial"/>
+              </a:rPr>
+              <a:t>Source / footnote line below the table and chart.</a:t>
+            </a:r>
+          </a:p>
+        </p:txBody>
+      </p:sp>
     </p:spTree>
   </p:cSld>
   <p:clrMapOvr>
@@ -5799,7 +7858,7 @@
 </p:sld>
 </file>
 
-<file path=ppt/slides/slide15.xml><?xml version="1.0" encoding="utf-8"?>
+<file path=ppt/slides/slide16.xml><?xml version="1.0" encoding="utf-8"?>
 <p:sld xmlns:a="http://schemas.openxmlformats.org/drawingml/2006/main" xmlns:p="http://schemas.openxmlformats.org/presentationml/2006/main" xmlns:r="http://schemas.openxmlformats.org/officeDocument/2006/relationships">
   <p:cSld>
     <p:spTree>
@@ -5852,7 +7911,7 @@
         <p:spPr>
           <a:xfrm>
             <a:off x="822960" y="1033271"/>
-            <a:ext cx="2377440" cy="38100"/>
+            <a:ext cx="4754880" cy="38100"/>
           </a:xfrm>
           <a:prstGeom prst="rect">
             <a:avLst/>
@@ -6131,7 +8190,7 @@
         <p:spPr>
           <a:xfrm>
             <a:off x="822960" y="4892040"/>
-            <a:ext cx="10545775" cy="457200"/>
+            <a:ext cx="10545775" cy="548640"/>
           </a:xfrm>
           <a:prstGeom prst="rect">
             <a:avLst/>
@@ -6145,7 +8204,7 @@
           <a:lstStyle/>
           <a:p>
             <a:r>
-              <a:rPr sz="1200" b="0" i="1">
+              <a:rPr sz="1600" b="0" i="0">
                 <a:solidFill>
                   <a:srgbClr val="6B7280"/>
                 </a:solidFill>
@@ -6164,7 +8223,7 @@
 </p:sld>
 </file>
 
-<file path=ppt/slides/slide16.xml><?xml version="1.0" encoding="utf-8"?>
+<file path=ppt/slides/slide17.xml><?xml version="1.0" encoding="utf-8"?>
 <p:sld xmlns:a="http://schemas.openxmlformats.org/drawingml/2006/main" xmlns:p="http://schemas.openxmlformats.org/presentationml/2006/main" xmlns:r="http://schemas.openxmlformats.org/officeDocument/2006/relationships">
   <p:cSld>
     <p:spTree>
@@ -6217,7 +8276,7 @@
         <p:spPr>
           <a:xfrm>
             <a:off x="822960" y="1033271"/>
-            <a:ext cx="2377440" cy="38100"/>
+            <a:ext cx="4754880" cy="38100"/>
           </a:xfrm>
           <a:prstGeom prst="rect">
             <a:avLst/>
@@ -6284,7 +8343,7 @@
 </p:sld>
 </file>
 
-<file path=ppt/slides/slide17.xml><?xml version="1.0" encoding="utf-8"?>
+<file path=ppt/slides/slide18.xml><?xml version="1.0" encoding="utf-8"?>
 <p:sld xmlns:a="http://schemas.openxmlformats.org/drawingml/2006/main" xmlns:p="http://schemas.openxmlformats.org/presentationml/2006/main" xmlns:r="http://schemas.openxmlformats.org/officeDocument/2006/relationships">
   <p:cSld>
     <p:spTree>
@@ -6337,7 +8396,7 @@
         <p:spPr>
           <a:xfrm>
             <a:off x="822960" y="1033271"/>
-            <a:ext cx="2377440" cy="38100"/>
+            <a:ext cx="4754880" cy="38100"/>
           </a:xfrm>
           <a:prstGeom prst="rect">
             <a:avLst/>
@@ -6491,7 +8550,7 @@
 </p:sld>
 </file>
 
-<file path=ppt/slides/slide18.xml><?xml version="1.0" encoding="utf-8"?>
+<file path=ppt/slides/slide19.xml><?xml version="1.0" encoding="utf-8"?>
 <p:sld xmlns:a="http://schemas.openxmlformats.org/drawingml/2006/main" xmlns:p="http://schemas.openxmlformats.org/presentationml/2006/main" xmlns:r="http://schemas.openxmlformats.org/officeDocument/2006/relationships">
   <p:cSld>
     <p:spTree>
@@ -6544,7 +8603,7 @@
         <p:spPr>
           <a:xfrm>
             <a:off x="822960" y="1033271"/>
-            <a:ext cx="2377440" cy="38100"/>
+            <a:ext cx="4754880" cy="38100"/>
           </a:xfrm>
           <a:prstGeom prst="rect">
             <a:avLst/>
@@ -6755,94 +8814,6 @@
 </p:sld>
 </file>
 
-<file path=ppt/slides/slide19.xml><?xml version="1.0" encoding="utf-8"?>
-<p:sld xmlns:a="http://schemas.openxmlformats.org/drawingml/2006/main" xmlns:p="http://schemas.openxmlformats.org/presentationml/2006/main" xmlns:r="http://schemas.openxmlformats.org/officeDocument/2006/relationships">
-  <p:cSld>
-    <p:spTree>
-      <p:nvGrpSpPr>
-        <p:cNvPr id="1" name=""/>
-        <p:cNvGrpSpPr/>
-        <p:nvPr/>
-      </p:nvGrpSpPr>
-      <p:grpSpPr/>
-      <p:sp>
-        <p:nvSpPr>
-          <p:cNvPr id="2" name="TextBox 1"/>
-          <p:cNvSpPr txBox="1"/>
-          <p:nvPr/>
-        </p:nvSpPr>
-        <p:spPr>
-          <a:xfrm>
-            <a:off x="822960" y="2743200"/>
-            <a:ext cx="10545775" cy="1280160"/>
-          </a:xfrm>
-          <a:prstGeom prst="rect">
-            <a:avLst/>
-          </a:prstGeom>
-          <a:noFill/>
-        </p:spPr>
-        <p:txBody>
-          <a:bodyPr wrap="square" anchor="ctr">
-            <a:spAutoFit/>
-          </a:bodyPr>
-          <a:lstStyle/>
-          <a:p>
-            <a:pPr algn="ctr"/>
-            <a:r>
-              <a:rPr sz="4000" b="1" i="0">
-                <a:solidFill>
-                  <a:srgbClr val="262A2E"/>
-                </a:solidFill>
-                <a:latin typeface="Arial"/>
-              </a:rPr>
-              <a:t>Thank You</a:t>
-            </a:r>
-          </a:p>
-        </p:txBody>
-      </p:sp>
-      <p:sp>
-        <p:nvSpPr>
-          <p:cNvPr id="3" name="TextBox 2"/>
-          <p:cNvSpPr txBox="1"/>
-          <p:nvPr/>
-        </p:nvSpPr>
-        <p:spPr>
-          <a:xfrm>
-            <a:off x="822960" y="3840480"/>
-            <a:ext cx="10545775" cy="640080"/>
-          </a:xfrm>
-          <a:prstGeom prst="rect">
-            <a:avLst/>
-          </a:prstGeom>
-          <a:noFill/>
-        </p:spPr>
-        <p:txBody>
-          <a:bodyPr wrap="square">
-            <a:spAutoFit/>
-          </a:bodyPr>
-          <a:lstStyle/>
-          <a:p>
-            <a:pPr algn="ctr"/>
-            <a:r>
-              <a:rPr sz="1800" b="0" i="0">
-                <a:solidFill>
-                  <a:srgbClr val="6B7280"/>
-                </a:solidFill>
-                <a:latin typeface="Arial"/>
-              </a:rPr>
-              <a:t>name@example.com</a:t>
-            </a:r>
-          </a:p>
-        </p:txBody>
-      </p:sp>
-    </p:spTree>
-  </p:cSld>
-  <p:clrMapOvr>
-    <a:masterClrMapping/>
-  </p:clrMapOvr>
-</p:sld>
-</file>
-
 <file path=ppt/slides/slide2.xml><?xml version="1.0" encoding="utf-8"?>
 <p:sld xmlns:a="http://schemas.openxmlformats.org/drawingml/2006/main" xmlns:p="http://schemas.openxmlformats.org/presentationml/2006/main" xmlns:r="http://schemas.openxmlformats.org/officeDocument/2006/relationships">
   <p:cSld>
@@ -6896,7 +8867,7 @@
         <p:spPr>
           <a:xfrm>
             <a:off x="822960" y="1033271"/>
-            <a:ext cx="2377440" cy="38100"/>
+            <a:ext cx="4754880" cy="38100"/>
           </a:xfrm>
           <a:prstGeom prst="rect">
             <a:avLst/>
@@ -6953,7 +8924,7 @@
           </a:bodyPr>
           <a:lstStyle/>
           <a:p>
-            <a:pPr marL="114300" indent="-114300">
+            <a:pPr marL="88900" indent="-88900">
               <a:spcAft>
                 <a:spcPts val="1000"/>
               </a:spcAft>
@@ -6970,7 +8941,7 @@
             </a:r>
           </a:p>
           <a:p>
-            <a:pPr marL="114300" indent="-114300">
+            <a:pPr marL="88900" indent="-88900">
               <a:spcAft>
                 <a:spcPts val="1000"/>
               </a:spcAft>
@@ -6987,7 +8958,7 @@
             </a:r>
           </a:p>
           <a:p>
-            <a:pPr marL="114300" indent="-114300">
+            <a:pPr marL="88900" indent="-88900">
               <a:spcAft>
                 <a:spcPts val="1000"/>
               </a:spcAft>
@@ -7004,7 +8975,7 @@
             </a:r>
           </a:p>
           <a:p>
-            <a:pPr marL="114300" indent="-114300">
+            <a:pPr marL="88900" indent="-88900">
               <a:spcAft>
                 <a:spcPts val="1000"/>
               </a:spcAft>
@@ -7018,6 +8989,94 @@
                 <a:latin typeface="Arial"/>
               </a:rPr>
               <a:t>Fourth point</a:t>
+            </a:r>
+          </a:p>
+        </p:txBody>
+      </p:sp>
+    </p:spTree>
+  </p:cSld>
+  <p:clrMapOvr>
+    <a:masterClrMapping/>
+  </p:clrMapOvr>
+</p:sld>
+</file>
+
+<file path=ppt/slides/slide20.xml><?xml version="1.0" encoding="utf-8"?>
+<p:sld xmlns:a="http://schemas.openxmlformats.org/drawingml/2006/main" xmlns:p="http://schemas.openxmlformats.org/presentationml/2006/main" xmlns:r="http://schemas.openxmlformats.org/officeDocument/2006/relationships">
+  <p:cSld>
+    <p:spTree>
+      <p:nvGrpSpPr>
+        <p:cNvPr id="1" name=""/>
+        <p:cNvGrpSpPr/>
+        <p:nvPr/>
+      </p:nvGrpSpPr>
+      <p:grpSpPr/>
+      <p:sp>
+        <p:nvSpPr>
+          <p:cNvPr id="2" name="TextBox 1"/>
+          <p:cNvSpPr txBox="1"/>
+          <p:nvPr/>
+        </p:nvSpPr>
+        <p:spPr>
+          <a:xfrm>
+            <a:off x="822960" y="2743200"/>
+            <a:ext cx="10545775" cy="1280160"/>
+          </a:xfrm>
+          <a:prstGeom prst="rect">
+            <a:avLst/>
+          </a:prstGeom>
+          <a:noFill/>
+        </p:spPr>
+        <p:txBody>
+          <a:bodyPr wrap="square" anchor="ctr">
+            <a:spAutoFit/>
+          </a:bodyPr>
+          <a:lstStyle/>
+          <a:p>
+            <a:pPr algn="ctr"/>
+            <a:r>
+              <a:rPr sz="4000" b="1" i="0">
+                <a:solidFill>
+                  <a:srgbClr val="262A2E"/>
+                </a:solidFill>
+                <a:latin typeface="Arial"/>
+              </a:rPr>
+              <a:t>Thank You</a:t>
+            </a:r>
+          </a:p>
+        </p:txBody>
+      </p:sp>
+      <p:sp>
+        <p:nvSpPr>
+          <p:cNvPr id="3" name="TextBox 2"/>
+          <p:cNvSpPr txBox="1"/>
+          <p:nvPr/>
+        </p:nvSpPr>
+        <p:spPr>
+          <a:xfrm>
+            <a:off x="822960" y="3840480"/>
+            <a:ext cx="10545775" cy="640080"/>
+          </a:xfrm>
+          <a:prstGeom prst="rect">
+            <a:avLst/>
+          </a:prstGeom>
+          <a:noFill/>
+        </p:spPr>
+        <p:txBody>
+          <a:bodyPr wrap="square">
+            <a:spAutoFit/>
+          </a:bodyPr>
+          <a:lstStyle/>
+          <a:p>
+            <a:pPr algn="ctr"/>
+            <a:r>
+              <a:rPr sz="1800" b="0" i="0">
+                <a:solidFill>
+                  <a:srgbClr val="6B7280"/>
+                </a:solidFill>
+                <a:latin typeface="Arial"/>
+              </a:rPr>
+              <a:t>name@example.com</a:t>
             </a:r>
           </a:p>
         </p:txBody>
@@ -7083,7 +9142,7 @@
         <p:spPr>
           <a:xfrm>
             <a:off x="822960" y="1033271"/>
-            <a:ext cx="2377440" cy="38100"/>
+            <a:ext cx="4754880" cy="38100"/>
           </a:xfrm>
           <a:prstGeom prst="rect">
             <a:avLst/>
@@ -7140,7 +9199,7 @@
           </a:bodyPr>
           <a:lstStyle/>
           <a:p>
-            <a:pPr marL="228600" indent="-228600">
+            <a:pPr marL="152400" indent="-152400">
               <a:spcAft>
                 <a:spcPts val="1000"/>
               </a:spcAft>
@@ -7158,7 +9217,7 @@
             </a:r>
           </a:p>
           <a:p>
-            <a:pPr marL="228600" indent="-228600">
+            <a:pPr marL="152400" indent="-152400">
               <a:spcAft>
                 <a:spcPts val="1000"/>
               </a:spcAft>
@@ -7176,7 +9235,7 @@
             </a:r>
           </a:p>
           <a:p>
-            <a:pPr marL="228600" indent="-228600">
+            <a:pPr marL="152400" indent="-152400">
               <a:spcAft>
                 <a:spcPts val="1000"/>
               </a:spcAft>
@@ -7194,7 +9253,7 @@
             </a:r>
           </a:p>
           <a:p>
-            <a:pPr marL="228600" indent="-228600">
+            <a:pPr marL="152400" indent="-152400">
               <a:spcAft>
                 <a:spcPts val="1000"/>
               </a:spcAft>
@@ -7335,7 +9394,7 @@
         <p:spPr>
           <a:xfrm>
             <a:off x="822960" y="1033271"/>
-            <a:ext cx="2377440" cy="38100"/>
+            <a:ext cx="4754880" cy="38100"/>
           </a:xfrm>
           <a:prstGeom prst="rect">
             <a:avLst/>
@@ -7605,7 +9664,7 @@
         <p:spPr>
           <a:xfrm>
             <a:off x="822960" y="1033271"/>
-            <a:ext cx="2377440" cy="38100"/>
+            <a:ext cx="4754880" cy="38100"/>
           </a:xfrm>
           <a:prstGeom prst="rect">
             <a:avLst/>
@@ -7962,7 +10021,7 @@
         <p:spPr>
           <a:xfrm>
             <a:off x="822960" y="1033271"/>
-            <a:ext cx="2377440" cy="38100"/>
+            <a:ext cx="4754880" cy="38100"/>
           </a:xfrm>
           <a:prstGeom prst="rect">
             <a:avLst/>
@@ -8406,7 +10465,7 @@
         <p:spPr>
           <a:xfrm>
             <a:off x="822960" y="1033271"/>
-            <a:ext cx="2377440" cy="38100"/>
+            <a:ext cx="4754880" cy="38100"/>
           </a:xfrm>
           <a:prstGeom prst="rect">
             <a:avLst/>
@@ -8554,7 +10613,7 @@
         <p:spPr>
           <a:xfrm>
             <a:off x="822960" y="1033271"/>
-            <a:ext cx="2377440" cy="38100"/>
+            <a:ext cx="4754880" cy="38100"/>
           </a:xfrm>
           <a:prstGeom prst="rect">
             <a:avLst/>
@@ -8967,4 +11026,324 @@
   </a:objectDefaults>
   <a:extraClrSchemeLst/>
 </a:theme>
+</file>
+
+<file path=ppt/theme/theme2.xml><?xml version="1.0" encoding="utf-8"?>
+<a:theme xmlns:a="http://schemas.openxmlformats.org/drawingml/2006/main" name="Office Theme">
+  <a:themeElements>
+    <a:clrScheme name="Office">
+      <a:dk1>
+        <a:sysClr val="windowText" lastClr="000000"/>
+      </a:dk1>
+      <a:lt1>
+        <a:sysClr val="window" lastClr="FFFFFF"/>
+      </a:lt1>
+      <a:dk2>
+        <a:srgbClr val="1F497D"/>
+      </a:dk2>
+      <a:lt2>
+        <a:srgbClr val="EEECE1"/>
+      </a:lt2>
+      <a:accent1>
+        <a:srgbClr val="4F81BD"/>
+      </a:accent1>
+      <a:accent2>
+        <a:srgbClr val="C0504D"/>
+      </a:accent2>
+      <a:accent3>
+        <a:srgbClr val="9BBB59"/>
+      </a:accent3>
+      <a:accent4>
+        <a:srgbClr val="8064A2"/>
+      </a:accent4>
+      <a:accent5>
+        <a:srgbClr val="4BACC6"/>
+      </a:accent5>
+      <a:accent6>
+        <a:srgbClr val="F79646"/>
+      </a:accent6>
+      <a:hlink>
+        <a:srgbClr val="0000FF"/>
+      </a:hlink>
+      <a:folHlink>
+        <a:srgbClr val="800080"/>
+      </a:folHlink>
+    </a:clrScheme>
+    <a:fontScheme name="Office">
+      <a:majorFont>
+        <a:latin typeface="Calibri"/>
+        <a:ea typeface=""/>
+        <a:cs typeface=""/>
+        <a:font script="Jpan" typeface="ＭＳ Ｐゴシック"/>
+        <a:font script="Hang" typeface="맑은 고딕"/>
+        <a:font script="Hans" typeface="宋体"/>
+        <a:font script="Hant" typeface="新細明體"/>
+        <a:font script="Arab" typeface="Times New Roman"/>
+        <a:font script="Hebr" typeface="Times New Roman"/>
+        <a:font script="Thai" typeface="Angsana New"/>
+        <a:font script="Ethi" typeface="Nyala"/>
+        <a:font script="Beng" typeface="Vrinda"/>
+        <a:font script="Gujr" typeface="Shruti"/>
+        <a:font script="Khmr" typeface="MoolBoran"/>
+        <a:font script="Knda" typeface="Tunga"/>
+        <a:font script="Guru" typeface="Raavi"/>
+        <a:font script="Cans" typeface="Euphemia"/>
+        <a:font script="Cher" typeface="Plantagenet Cherokee"/>
+        <a:font script="Yiii" typeface="Microsoft Yi Baiti"/>
+        <a:font script="Tibt" typeface="Microsoft Himalaya"/>
+        <a:font script="Thaa" typeface="MV Boli"/>
+        <a:font script="Deva" typeface="Mangal"/>
+        <a:font script="Telu" typeface="Gautami"/>
+        <a:font script="Taml" typeface="Latha"/>
+        <a:font script="Syrc" typeface="Estrangelo Edessa"/>
+        <a:font script="Orya" typeface="Kalinga"/>
+        <a:font script="Mlym" typeface="Kartika"/>
+        <a:font script="Laoo" typeface="DokChampa"/>
+        <a:font script="Sinh" typeface="Iskoola Pota"/>
+        <a:font script="Mong" typeface="Mongolian Baiti"/>
+        <a:font script="Viet" typeface="Times New Roman"/>
+        <a:font script="Uigh" typeface="Microsoft Uighur"/>
+        <a:font script="Geor" typeface="Sylfaen"/>
+      </a:majorFont>
+      <a:minorFont>
+        <a:latin typeface="Calibri"/>
+        <a:ea typeface=""/>
+        <a:cs typeface=""/>
+        <a:font script="Jpan" typeface="ＭＳ Ｐゴシック"/>
+        <a:font script="Hang" typeface="맑은 고딕"/>
+        <a:font script="Hans" typeface="宋体"/>
+        <a:font script="Hant" typeface="新細明體"/>
+        <a:font script="Arab" typeface="Arial"/>
+        <a:font script="Hebr" typeface="Arial"/>
+        <a:font script="Thai" typeface="Cordia New"/>
+        <a:font script="Ethi" typeface="Nyala"/>
+        <a:font script="Beng" typeface="Vrinda"/>
+        <a:font script="Gujr" typeface="Shruti"/>
+        <a:font script="Khmr" typeface="DaunPenh"/>
+        <a:font script="Knda" typeface="Tunga"/>
+        <a:font script="Guru" typeface="Raavi"/>
+        <a:font script="Cans" typeface="Euphemia"/>
+        <a:font script="Cher" typeface="Plantagenet Cherokee"/>
+        <a:font script="Yiii" typeface="Microsoft Yi Baiti"/>
+        <a:font script="Tibt" typeface="Microsoft Himalaya"/>
+        <a:font script="Thaa" typeface="MV Boli"/>
+        <a:font script="Deva" typeface="Mangal"/>
+        <a:font script="Telu" typeface="Gautami"/>
+        <a:font script="Taml" typeface="Latha"/>
+        <a:font script="Syrc" typeface="Estrangelo Edessa"/>
+        <a:font script="Orya" typeface="Kalinga"/>
+        <a:font script="Mlym" typeface="Kartika"/>
+        <a:font script="Laoo" typeface="DokChampa"/>
+        <a:font script="Sinh" typeface="Iskoola Pota"/>
+        <a:font script="Mong" typeface="Mongolian Baiti"/>
+        <a:font script="Viet" typeface="Arial"/>
+        <a:font script="Uigh" typeface="Microsoft Uighur"/>
+        <a:font script="Geor" typeface="Sylfaen"/>
+      </a:minorFont>
+    </a:fontScheme>
+    <a:fmtScheme name="Office">
+      <a:fillStyleLst>
+        <a:solidFill>
+          <a:schemeClr val="phClr"/>
+        </a:solidFill>
+        <a:gradFill rotWithShape="1">
+          <a:gsLst>
+            <a:gs pos="0">
+              <a:schemeClr val="phClr">
+                <a:tint val="50000"/>
+                <a:satMod val="300000"/>
+              </a:schemeClr>
+            </a:gs>
+            <a:gs pos="35000">
+              <a:schemeClr val="phClr">
+                <a:tint val="37000"/>
+                <a:satMod val="300000"/>
+              </a:schemeClr>
+            </a:gs>
+            <a:gs pos="100000">
+              <a:schemeClr val="phClr">
+                <a:tint val="15000"/>
+                <a:satMod val="350000"/>
+              </a:schemeClr>
+            </a:gs>
+          </a:gsLst>
+          <a:lin ang="16200000" scaled="1"/>
+        </a:gradFill>
+        <a:gradFill rotWithShape="1">
+          <a:gsLst>
+            <a:gs pos="0">
+              <a:schemeClr val="phClr">
+                <a:tint val="100000"/>
+                <a:shade val="100000"/>
+                <a:satMod val="130000"/>
+              </a:schemeClr>
+            </a:gs>
+            <a:gs pos="100000">
+              <a:schemeClr val="phClr">
+                <a:tint val="50000"/>
+                <a:shade val="100000"/>
+                <a:satMod val="350000"/>
+              </a:schemeClr>
+            </a:gs>
+          </a:gsLst>
+          <a:lin ang="16200000" scaled="0"/>
+        </a:gradFill>
+      </a:fillStyleLst>
+      <a:lnStyleLst>
+        <a:ln w="9525" cap="flat" cmpd="sng" algn="ctr">
+          <a:solidFill>
+            <a:schemeClr val="phClr">
+              <a:shade val="95000"/>
+              <a:satMod val="105000"/>
+            </a:schemeClr>
+          </a:solidFill>
+          <a:prstDash val="solid"/>
+        </a:ln>
+        <a:ln w="25400" cap="flat" cmpd="sng" algn="ctr">
+          <a:solidFill>
+            <a:schemeClr val="phClr"/>
+          </a:solidFill>
+          <a:prstDash val="solid"/>
+        </a:ln>
+        <a:ln w="38100" cap="flat" cmpd="sng" algn="ctr">
+          <a:solidFill>
+            <a:schemeClr val="phClr"/>
+          </a:solidFill>
+          <a:prstDash val="solid"/>
+        </a:ln>
+      </a:lnStyleLst>
+      <a:effectStyleLst>
+        <a:effectStyle>
+          <a:effectLst>
+            <a:outerShdw blurRad="40000" dist="20000" dir="5400000" rotWithShape="0">
+              <a:srgbClr val="000000">
+                <a:alpha val="38000"/>
+              </a:srgbClr>
+            </a:outerShdw>
+          </a:effectLst>
+        </a:effectStyle>
+        <a:effectStyle>
+          <a:effectLst>
+            <a:outerShdw blurRad="40000" dist="23000" dir="5400000" rotWithShape="0">
+              <a:srgbClr val="000000">
+                <a:alpha val="35000"/>
+              </a:srgbClr>
+            </a:outerShdw>
+          </a:effectLst>
+        </a:effectStyle>
+        <a:effectStyle>
+          <a:effectLst>
+            <a:outerShdw blurRad="40000" dist="23000" dir="5400000" rotWithShape="0">
+              <a:srgbClr val="000000">
+                <a:alpha val="35000"/>
+              </a:srgbClr>
+            </a:outerShdw>
+          </a:effectLst>
+          <a:scene3d>
+            <a:camera prst="orthographicFront">
+              <a:rot lat="0" lon="0" rev="0"/>
+            </a:camera>
+            <a:lightRig rig="threePt" dir="t">
+              <a:rot lat="0" lon="0" rev="1200000"/>
+            </a:lightRig>
+          </a:scene3d>
+          <a:sp3d>
+            <a:bevelT w="63500" h="25400"/>
+          </a:sp3d>
+        </a:effectStyle>
+      </a:effectStyleLst>
+      <a:bgFillStyleLst>
+        <a:solidFill>
+          <a:schemeClr val="phClr"/>
+        </a:solidFill>
+        <a:gradFill rotWithShape="1">
+          <a:gsLst>
+            <a:gs pos="0">
+              <a:schemeClr val="phClr">
+                <a:tint val="40000"/>
+                <a:satMod val="350000"/>
+              </a:schemeClr>
+            </a:gs>
+            <a:gs pos="40000">
+              <a:schemeClr val="phClr">
+                <a:tint val="45000"/>
+                <a:shade val="99000"/>
+                <a:satMod val="350000"/>
+              </a:schemeClr>
+            </a:gs>
+            <a:gs pos="100000">
+              <a:schemeClr val="phClr">
+                <a:shade val="20000"/>
+                <a:satMod val="255000"/>
+              </a:schemeClr>
+            </a:gs>
+          </a:gsLst>
+          <a:path path="circle">
+            <a:fillToRect l="50000" t="-80000" r="50000" b="180000"/>
+          </a:path>
+        </a:gradFill>
+        <a:gradFill rotWithShape="1">
+          <a:gsLst>
+            <a:gs pos="0">
+              <a:schemeClr val="phClr">
+                <a:tint val="80000"/>
+                <a:satMod val="300000"/>
+              </a:schemeClr>
+            </a:gs>
+            <a:gs pos="100000">
+              <a:schemeClr val="phClr">
+                <a:shade val="30000"/>
+                <a:satMod val="200000"/>
+              </a:schemeClr>
+            </a:gs>
+          </a:gsLst>
+          <a:path path="circle">
+            <a:fillToRect l="50000" t="50000" r="50000" b="50000"/>
+          </a:path>
+        </a:gradFill>
+      </a:bgFillStyleLst>
+    </a:fmtScheme>
+  </a:themeElements>
+  <a:objectDefaults>
+    <a:spDef>
+      <a:spPr/>
+      <a:bodyPr/>
+      <a:lstStyle/>
+      <a:style>
+        <a:lnRef idx="1">
+          <a:schemeClr val="accent1"/>
+        </a:lnRef>
+        <a:fillRef idx="3">
+          <a:schemeClr val="accent1"/>
+        </a:fillRef>
+        <a:effectRef idx="2">
+          <a:schemeClr val="accent1"/>
+        </a:effectRef>
+        <a:fontRef idx="minor">
+          <a:schemeClr val="lt1"/>
+        </a:fontRef>
+      </a:style>
+    </a:spDef>
+    <a:lnDef>
+      <a:spPr/>
+      <a:bodyPr/>
+      <a:lstStyle/>
+      <a:style>
+        <a:lnRef idx="2">
+          <a:schemeClr val="accent1"/>
+        </a:lnRef>
+        <a:fillRef idx="0">
+          <a:schemeClr val="accent1"/>
+        </a:fillRef>
+        <a:effectRef idx="1">
+          <a:schemeClr val="accent1"/>
+        </a:effectRef>
+        <a:fontRef idx="minor">
+          <a:schemeClr val="tx1"/>
+        </a:fontRef>
+      </a:style>
+    </a:lnDef>
+  </a:objectDefaults>
+  <a:extraClrSchemeLst/>
+</a:theme>
 </file>
</xml_diff>

<commit_message>
modify design of template pptx
</commit_message>
<xml_diff>
--- a/template-source/basic_template.pptx
+++ b/template-source/basic_template.pptx
@@ -5682,6 +5682,14 @@
 <file path=ppt/slides/slide1.xml><?xml version="1.0" encoding="utf-8"?>
 <p:sld xmlns:a="http://schemas.openxmlformats.org/drawingml/2006/main" xmlns:p="http://schemas.openxmlformats.org/presentationml/2006/main" xmlns:r="http://schemas.openxmlformats.org/officeDocument/2006/relationships">
   <p:cSld>
+    <p:bg>
+      <p:bgPr>
+        <a:solidFill>
+          <a:srgbClr val="1D1D1F"/>
+        </a:solidFill>
+        <a:effectLst/>
+      </p:bgPr>
+    </p:bg>
     <p:spTree>
       <p:nvGrpSpPr>
         <p:cNvPr id="1" name=""/>
@@ -5715,7 +5723,7 @@
             <a:r>
               <a:rPr sz="4400" b="1" i="0">
                 <a:solidFill>
-                  <a:srgbClr val="262A2E"/>
+                  <a:srgbClr val="FFFFFF"/>
                 </a:solidFill>
                 <a:latin typeface="Arial"/>
               </a:rPr>
@@ -5749,7 +5757,7 @@
             <a:r>
               <a:rPr sz="2000" b="0" i="0">
                 <a:solidFill>
-                  <a:srgbClr val="6B7280"/>
+                  <a:srgbClr val="CCCCCC"/>
                 </a:solidFill>
                 <a:latin typeface="Arial"/>
               </a:rPr>
@@ -5801,7 +5809,7 @@
             <a:r>
               <a:rPr sz="3000" b="1" i="0">
                 <a:solidFill>
-                  <a:srgbClr val="262A2E"/>
+                  <a:srgbClr val="1D1D1F"/>
                 </a:solidFill>
                 <a:latin typeface="Arial"/>
               </a:rPr>
@@ -5825,7 +5833,7 @@
             <a:avLst/>
           </a:prstGeom>
           <a:solidFill>
-            <a:srgbClr val="3B6EA5"/>
+            <a:srgbClr val="0066CC"/>
           </a:solidFill>
           <a:ln>
             <a:noFill/>
@@ -5877,9 +5885,9 @@
           <a:lstStyle/>
           <a:p>
             <a:r>
-              <a:rPr sz="1600" b="0" i="0">
+              <a:rPr sz="1700" b="0" i="0">
                 <a:solidFill>
-                  <a:srgbClr val="6B7280"/>
+                  <a:srgbClr val="6E6E73"/>
                 </a:solidFill>
                 <a:latin typeface="Arial"/>
               </a:rPr>
@@ -5949,7 +5957,7 @@
             <a:r>
               <a:rPr sz="3000" b="1" i="0">
                 <a:solidFill>
-                  <a:srgbClr val="262A2E"/>
+                  <a:srgbClr val="1D1D1F"/>
                 </a:solidFill>
                 <a:latin typeface="Arial"/>
               </a:rPr>
@@ -5973,7 +5981,7 @@
             <a:avLst/>
           </a:prstGeom>
           <a:solidFill>
-            <a:srgbClr val="3B6EA5"/>
+            <a:srgbClr val="0066CC"/>
           </a:solidFill>
           <a:ln>
             <a:noFill/>
@@ -6025,9 +6033,9 @@
           <a:lstStyle/>
           <a:p>
             <a:r>
-              <a:rPr sz="1600" b="0" i="0">
+              <a:rPr sz="1700" b="0" i="0">
                 <a:solidFill>
-                  <a:srgbClr val="6B7280"/>
+                  <a:srgbClr val="6E6E73"/>
                 </a:solidFill>
                 <a:latin typeface="Arial"/>
               </a:rPr>
@@ -6097,7 +6105,7 @@
             <a:r>
               <a:rPr sz="3000" b="1" i="0">
                 <a:solidFill>
-                  <a:srgbClr val="262A2E"/>
+                  <a:srgbClr val="1D1D1F"/>
                 </a:solidFill>
                 <a:latin typeface="Arial"/>
               </a:rPr>
@@ -6121,7 +6129,7 @@
             <a:avLst/>
           </a:prstGeom>
           <a:solidFill>
-            <a:srgbClr val="3B6EA5"/>
+            <a:srgbClr val="0066CC"/>
           </a:solidFill>
           <a:ln>
             <a:noFill/>
@@ -6180,7 +6188,7 @@
             <a:r>
               <a:rPr sz="2000" b="1" i="0">
                 <a:solidFill>
-                  <a:srgbClr val="3B6EA5"/>
+                  <a:srgbClr val="0066CC"/>
                 </a:solidFill>
                 <a:latin typeface="Arial"/>
               </a:rPr>
@@ -6194,9 +6202,9 @@
               </a:spcAft>
             </a:pPr>
             <a:r>
-              <a:rPr sz="1600" b="0" i="0">
+              <a:rPr sz="1700" b="0" i="0">
                 <a:solidFill>
-                  <a:srgbClr val="262A2E"/>
+                  <a:srgbClr val="1D1D1F"/>
                 </a:solidFill>
                 <a:latin typeface="Arial"/>
               </a:rPr>
@@ -6210,9 +6218,9 @@
               </a:spcAft>
             </a:pPr>
             <a:r>
-              <a:rPr sz="1600" b="0" i="0">
+              <a:rPr sz="1700" b="0" i="0">
                 <a:solidFill>
-                  <a:srgbClr val="262A2E"/>
+                  <a:srgbClr val="1D1D1F"/>
                 </a:solidFill>
                 <a:latin typeface="Arial"/>
               </a:rPr>
@@ -6226,9 +6234,9 @@
               </a:spcAft>
             </a:pPr>
             <a:r>
-              <a:rPr sz="1600" b="0" i="0">
+              <a:rPr sz="1700" b="0" i="0">
                 <a:solidFill>
-                  <a:srgbClr val="262A2E"/>
+                  <a:srgbClr val="1D1D1F"/>
                 </a:solidFill>
                 <a:latin typeface="Arial"/>
               </a:rPr>
@@ -6298,7 +6306,7 @@
             <a:r>
               <a:rPr sz="3000" b="1" i="0">
                 <a:solidFill>
-                  <a:srgbClr val="262A2E"/>
+                  <a:srgbClr val="1D1D1F"/>
                 </a:solidFill>
                 <a:latin typeface="Arial"/>
               </a:rPr>
@@ -6322,7 +6330,7 @@
             <a:avLst/>
           </a:prstGeom>
           <a:solidFill>
-            <a:srgbClr val="3B6EA5"/>
+            <a:srgbClr val="0066CC"/>
           </a:solidFill>
           <a:ln>
             <a:noFill/>
@@ -6374,9 +6382,9 @@
           <a:lstStyle/>
           <a:p>
             <a:r>
-              <a:rPr sz="1600" b="0" i="0">
+              <a:rPr sz="1700" b="0" i="0">
                 <a:solidFill>
-                  <a:srgbClr val="6B7280"/>
+                  <a:srgbClr val="6E6E73"/>
                 </a:solidFill>
                 <a:latin typeface="Arial"/>
               </a:rPr>
@@ -6400,8 +6408,8 @@
         <a:graphic>
           <a:graphicData uri="http://schemas.openxmlformats.org/drawingml/2006/table">
             <a:tbl>
-              <a:tblPr firstRow="1" bandRow="1">
-                <a:tableStyleId>{5C22544A-7EE6-4342-B048-85BDC9FD1C3A}</a:tableStyleId>
+              <a:tblPr>
+                <a:tableStyleId>{2D5ABB26-0587-4C30-8999-92F81FD0307C}</a:tableStyleId>
               </a:tblPr>
               <a:tblGrid>
                 <a:gridCol w="3515258"/>
@@ -6414,11 +6422,11 @@
                     <a:bodyPr/>
                     <a:lstStyle/>
                     <a:p>
-                      <a:pPr algn="ctr"/>
+                      <a:pPr algn="l"/>
                       <a:r>
                         <a:rPr sz="1500" b="1" i="0">
                           <a:solidFill>
-                            <a:srgbClr val="FFFFFF"/>
+                            <a:srgbClr val="1D1D1F"/>
                           </a:solidFill>
                           <a:latin typeface="Arial"/>
                         </a:rPr>
@@ -6426,18 +6434,27 @@
                       </a:r>
                     </a:p>
                   </a:txBody>
-                  <a:tcPr anchor="ctr"/>
+                  <a:tcPr anchor="ctr" marL="109728" marR="109728">
+                    <a:lnB w="19050" cap="flat" cmpd="sng" algn="ctr">
+                      <a:solidFill>
+                        <a:srgbClr val="1D1D1F"/>
+                      </a:solidFill>
+                    </a:lnB>
+                    <a:solidFill>
+                      <a:srgbClr val="FFFFFF"/>
+                    </a:solidFill>
+                  </a:tcPr>
                 </a:tc>
                 <a:tc>
                   <a:txBody>
                     <a:bodyPr/>
                     <a:lstStyle/>
                     <a:p>
-                      <a:pPr algn="ctr"/>
+                      <a:pPr algn="r"/>
                       <a:r>
                         <a:rPr sz="1500" b="1" i="0">
                           <a:solidFill>
-                            <a:srgbClr val="FFFFFF"/>
+                            <a:srgbClr val="1D1D1F"/>
                           </a:solidFill>
                           <a:latin typeface="Arial"/>
                         </a:rPr>
@@ -6445,18 +6462,27 @@
                       </a:r>
                     </a:p>
                   </a:txBody>
-                  <a:tcPr anchor="ctr"/>
+                  <a:tcPr anchor="ctr" marL="109728" marR="109728">
+                    <a:lnB w="19050" cap="flat" cmpd="sng" algn="ctr">
+                      <a:solidFill>
+                        <a:srgbClr val="1D1D1F"/>
+                      </a:solidFill>
+                    </a:lnB>
+                    <a:solidFill>
+                      <a:srgbClr val="FFFFFF"/>
+                    </a:solidFill>
+                  </a:tcPr>
                 </a:tc>
                 <a:tc>
                   <a:txBody>
                     <a:bodyPr/>
                     <a:lstStyle/>
                     <a:p>
-                      <a:pPr algn="ctr"/>
+                      <a:pPr algn="r"/>
                       <a:r>
                         <a:rPr sz="1500" b="1" i="0">
                           <a:solidFill>
-                            <a:srgbClr val="FFFFFF"/>
+                            <a:srgbClr val="1D1D1F"/>
                           </a:solidFill>
                           <a:latin typeface="Arial"/>
                         </a:rPr>
@@ -6464,7 +6490,16 @@
                       </a:r>
                     </a:p>
                   </a:txBody>
-                  <a:tcPr anchor="ctr"/>
+                  <a:tcPr anchor="ctr" marL="109728" marR="109728">
+                    <a:lnB w="19050" cap="flat" cmpd="sng" algn="ctr">
+                      <a:solidFill>
+                        <a:srgbClr val="1D1D1F"/>
+                      </a:solidFill>
+                    </a:lnB>
+                    <a:solidFill>
+                      <a:srgbClr val="FFFFFF"/>
+                    </a:solidFill>
+                  </a:tcPr>
                 </a:tc>
               </a:tr>
               <a:tr h="662940">
@@ -6473,11 +6508,11 @@
                     <a:bodyPr/>
                     <a:lstStyle/>
                     <a:p>
-                      <a:pPr algn="ctr"/>
+                      <a:pPr algn="l"/>
                       <a:r>
                         <a:rPr sz="1500" b="0" i="0">
                           <a:solidFill>
-                            <a:srgbClr val="262A2E"/>
+                            <a:srgbClr val="1D1D1F"/>
                           </a:solidFill>
                           <a:latin typeface="Arial"/>
                         </a:rPr>
@@ -6485,17 +6520,27 @@
                       </a:r>
                     </a:p>
                   </a:txBody>
-                  <a:tcPr anchor="ctr"/>
+                  <a:tcPr anchor="ctr" marL="109728" marR="109728">
+                    <a:lnB w="9525" cap="flat" cmpd="sng" algn="ctr">
+                      <a:solidFill>
+                        <a:srgbClr val="E0E0E0"/>
+                      </a:solidFill>
+                    </a:lnB>
+                    <a:solidFill>
+                      <a:srgbClr val="FFFFFF"/>
+                    </a:solidFill>
+                  </a:tcPr>
                 </a:tc>
                 <a:tc>
                   <a:txBody>
                     <a:bodyPr/>
                     <a:lstStyle/>
                     <a:p>
+                      <a:pPr algn="r"/>
                       <a:r>
                         <a:rPr sz="1500" b="0" i="0">
                           <a:solidFill>
-                            <a:srgbClr val="262A2E"/>
+                            <a:srgbClr val="1D1D1F"/>
                           </a:solidFill>
                           <a:latin typeface="Arial"/>
                         </a:rPr>
@@ -6503,17 +6548,27 @@
                       </a:r>
                     </a:p>
                   </a:txBody>
-                  <a:tcPr anchor="ctr"/>
+                  <a:tcPr anchor="ctr" marL="109728" marR="109728">
+                    <a:lnB w="9525" cap="flat" cmpd="sng" algn="ctr">
+                      <a:solidFill>
+                        <a:srgbClr val="E0E0E0"/>
+                      </a:solidFill>
+                    </a:lnB>
+                    <a:solidFill>
+                      <a:srgbClr val="FFFFFF"/>
+                    </a:solidFill>
+                  </a:tcPr>
                 </a:tc>
                 <a:tc>
                   <a:txBody>
                     <a:bodyPr/>
                     <a:lstStyle/>
                     <a:p>
+                      <a:pPr algn="r"/>
                       <a:r>
                         <a:rPr sz="1500" b="0" i="0">
                           <a:solidFill>
-                            <a:srgbClr val="262A2E"/>
+                            <a:srgbClr val="1D1D1F"/>
                           </a:solidFill>
                           <a:latin typeface="Arial"/>
                         </a:rPr>
@@ -6521,7 +6576,16 @@
                       </a:r>
                     </a:p>
                   </a:txBody>
-                  <a:tcPr anchor="ctr"/>
+                  <a:tcPr anchor="ctr" marL="109728" marR="109728">
+                    <a:lnB w="9525" cap="flat" cmpd="sng" algn="ctr">
+                      <a:solidFill>
+                        <a:srgbClr val="E0E0E0"/>
+                      </a:solidFill>
+                    </a:lnB>
+                    <a:solidFill>
+                      <a:srgbClr val="FFFFFF"/>
+                    </a:solidFill>
+                  </a:tcPr>
                 </a:tc>
               </a:tr>
               <a:tr h="662940">
@@ -6530,11 +6594,11 @@
                     <a:bodyPr/>
                     <a:lstStyle/>
                     <a:p>
-                      <a:pPr algn="ctr"/>
+                      <a:pPr algn="l"/>
                       <a:r>
                         <a:rPr sz="1500" b="0" i="0">
                           <a:solidFill>
-                            <a:srgbClr val="262A2E"/>
+                            <a:srgbClr val="1D1D1F"/>
                           </a:solidFill>
                           <a:latin typeface="Arial"/>
                         </a:rPr>
@@ -6542,17 +6606,27 @@
                       </a:r>
                     </a:p>
                   </a:txBody>
-                  <a:tcPr anchor="ctr"/>
+                  <a:tcPr anchor="ctr" marL="109728" marR="109728">
+                    <a:lnB w="9525" cap="flat" cmpd="sng" algn="ctr">
+                      <a:solidFill>
+                        <a:srgbClr val="E0E0E0"/>
+                      </a:solidFill>
+                    </a:lnB>
+                    <a:solidFill>
+                      <a:srgbClr val="FFFFFF"/>
+                    </a:solidFill>
+                  </a:tcPr>
                 </a:tc>
                 <a:tc>
                   <a:txBody>
                     <a:bodyPr/>
                     <a:lstStyle/>
                     <a:p>
+                      <a:pPr algn="r"/>
                       <a:r>
                         <a:rPr sz="1500" b="0" i="0">
                           <a:solidFill>
-                            <a:srgbClr val="262A2E"/>
+                            <a:srgbClr val="1D1D1F"/>
                           </a:solidFill>
                           <a:latin typeface="Arial"/>
                         </a:rPr>
@@ -6560,17 +6634,27 @@
                       </a:r>
                     </a:p>
                   </a:txBody>
-                  <a:tcPr anchor="ctr"/>
+                  <a:tcPr anchor="ctr" marL="109728" marR="109728">
+                    <a:lnB w="9525" cap="flat" cmpd="sng" algn="ctr">
+                      <a:solidFill>
+                        <a:srgbClr val="E0E0E0"/>
+                      </a:solidFill>
+                    </a:lnB>
+                    <a:solidFill>
+                      <a:srgbClr val="FFFFFF"/>
+                    </a:solidFill>
+                  </a:tcPr>
                 </a:tc>
                 <a:tc>
                   <a:txBody>
                     <a:bodyPr/>
                     <a:lstStyle/>
                     <a:p>
+                      <a:pPr algn="r"/>
                       <a:r>
                         <a:rPr sz="1500" b="0" i="0">
                           <a:solidFill>
-                            <a:srgbClr val="262A2E"/>
+                            <a:srgbClr val="1D1D1F"/>
                           </a:solidFill>
                           <a:latin typeface="Arial"/>
                         </a:rPr>
@@ -6578,7 +6662,16 @@
                       </a:r>
                     </a:p>
                   </a:txBody>
-                  <a:tcPr anchor="ctr"/>
+                  <a:tcPr anchor="ctr" marL="109728" marR="109728">
+                    <a:lnB w="9525" cap="flat" cmpd="sng" algn="ctr">
+                      <a:solidFill>
+                        <a:srgbClr val="E0E0E0"/>
+                      </a:solidFill>
+                    </a:lnB>
+                    <a:solidFill>
+                      <a:srgbClr val="FFFFFF"/>
+                    </a:solidFill>
+                  </a:tcPr>
                 </a:tc>
               </a:tr>
               <a:tr h="662940">
@@ -6587,11 +6680,11 @@
                     <a:bodyPr/>
                     <a:lstStyle/>
                     <a:p>
-                      <a:pPr algn="ctr"/>
+                      <a:pPr algn="l"/>
                       <a:r>
                         <a:rPr sz="1500" b="0" i="0">
                           <a:solidFill>
-                            <a:srgbClr val="262A2E"/>
+                            <a:srgbClr val="1D1D1F"/>
                           </a:solidFill>
                           <a:latin typeface="Arial"/>
                         </a:rPr>
@@ -6599,17 +6692,22 @@
                       </a:r>
                     </a:p>
                   </a:txBody>
-                  <a:tcPr anchor="ctr"/>
+                  <a:tcPr anchor="ctr" marL="109728" marR="109728">
+                    <a:solidFill>
+                      <a:srgbClr val="FFFFFF"/>
+                    </a:solidFill>
+                  </a:tcPr>
                 </a:tc>
                 <a:tc>
                   <a:txBody>
                     <a:bodyPr/>
                     <a:lstStyle/>
                     <a:p>
+                      <a:pPr algn="r"/>
                       <a:r>
                         <a:rPr sz="1500" b="0" i="0">
                           <a:solidFill>
-                            <a:srgbClr val="262A2E"/>
+                            <a:srgbClr val="1D1D1F"/>
                           </a:solidFill>
                           <a:latin typeface="Arial"/>
                         </a:rPr>
@@ -6617,17 +6715,22 @@
                       </a:r>
                     </a:p>
                   </a:txBody>
-                  <a:tcPr anchor="ctr"/>
+                  <a:tcPr anchor="ctr" marL="109728" marR="109728">
+                    <a:solidFill>
+                      <a:srgbClr val="FFFFFF"/>
+                    </a:solidFill>
+                  </a:tcPr>
                 </a:tc>
                 <a:tc>
                   <a:txBody>
                     <a:bodyPr/>
                     <a:lstStyle/>
                     <a:p>
+                      <a:pPr algn="r"/>
                       <a:r>
                         <a:rPr sz="1500" b="0" i="0">
                           <a:solidFill>
-                            <a:srgbClr val="262A2E"/>
+                            <a:srgbClr val="1D1D1F"/>
                           </a:solidFill>
                           <a:latin typeface="Arial"/>
                         </a:rPr>
@@ -6635,7 +6738,11 @@
                       </a:r>
                     </a:p>
                   </a:txBody>
-                  <a:tcPr anchor="ctr"/>
+                  <a:tcPr anchor="ctr" marL="109728" marR="109728">
+                    <a:solidFill>
+                      <a:srgbClr val="FFFFFF"/>
+                    </a:solidFill>
+                  </a:tcPr>
                 </a:tc>
               </a:tr>
             </a:tbl>
@@ -6665,9 +6772,9 @@
           <a:lstStyle/>
           <a:p>
             <a:r>
-              <a:rPr sz="1600" b="0" i="0">
+              <a:rPr sz="1700" b="0" i="0">
                 <a:solidFill>
-                  <a:srgbClr val="6B7280"/>
+                  <a:srgbClr val="6E6E73"/>
                 </a:solidFill>
                 <a:latin typeface="Arial"/>
               </a:rPr>
@@ -6719,7 +6826,7 @@
             <a:r>
               <a:rPr sz="3000" b="1" i="0">
                 <a:solidFill>
-                  <a:srgbClr val="262A2E"/>
+                  <a:srgbClr val="1D1D1F"/>
                 </a:solidFill>
                 <a:latin typeface="Arial"/>
               </a:rPr>
@@ -6743,7 +6850,7 @@
             <a:avLst/>
           </a:prstGeom>
           <a:solidFill>
-            <a:srgbClr val="3B6EA5"/>
+            <a:srgbClr val="0066CC"/>
           </a:solidFill>
           <a:ln>
             <a:noFill/>
@@ -6795,9 +6902,9 @@
           <a:lstStyle/>
           <a:p>
             <a:r>
-              <a:rPr sz="1600" b="0" i="0">
+              <a:rPr sz="1700" b="0" i="0">
                 <a:solidFill>
-                  <a:srgbClr val="6B7280"/>
+                  <a:srgbClr val="6E6E73"/>
                 </a:solidFill>
                 <a:latin typeface="Arial"/>
               </a:rPr>
@@ -6821,8 +6928,8 @@
         <a:graphic>
           <a:graphicData uri="http://schemas.openxmlformats.org/drawingml/2006/table">
             <a:tbl>
-              <a:tblPr firstRow="1" bandRow="1">
-                <a:tableStyleId>{5C22544A-7EE6-4342-B048-85BDC9FD1C3A}</a:tableStyleId>
+              <a:tblPr>
+                <a:tableStyleId>{2D5ABB26-0587-4C30-8999-92F81FD0307C}</a:tableStyleId>
               </a:tblPr>
               <a:tblGrid>
                 <a:gridCol w="1681429"/>
@@ -6835,11 +6942,11 @@
                     <a:bodyPr/>
                     <a:lstStyle/>
                     <a:p>
-                      <a:pPr algn="ctr"/>
+                      <a:pPr algn="l"/>
                       <a:r>
-                        <a:rPr sz="1300" b="1" i="0">
+                        <a:rPr sz="1400" b="1" i="0">
                           <a:solidFill>
-                            <a:srgbClr val="FFFFFF"/>
+                            <a:srgbClr val="1D1D1F"/>
                           </a:solidFill>
                           <a:latin typeface="Arial"/>
                         </a:rPr>
@@ -6847,18 +6954,27 @@
                       </a:r>
                     </a:p>
                   </a:txBody>
-                  <a:tcPr anchor="ctr"/>
+                  <a:tcPr anchor="ctr" marL="109728" marR="109728">
+                    <a:lnB w="19050" cap="flat" cmpd="sng" algn="ctr">
+                      <a:solidFill>
+                        <a:srgbClr val="1D1D1F"/>
+                      </a:solidFill>
+                    </a:lnB>
+                    <a:solidFill>
+                      <a:srgbClr val="FFFFFF"/>
+                    </a:solidFill>
+                  </a:tcPr>
                 </a:tc>
                 <a:tc>
                   <a:txBody>
                     <a:bodyPr/>
                     <a:lstStyle/>
                     <a:p>
-                      <a:pPr algn="ctr"/>
+                      <a:pPr algn="r"/>
                       <a:r>
-                        <a:rPr sz="1300" b="1" i="0">
+                        <a:rPr sz="1400" b="1" i="0">
                           <a:solidFill>
-                            <a:srgbClr val="FFFFFF"/>
+                            <a:srgbClr val="1D1D1F"/>
                           </a:solidFill>
                           <a:latin typeface="Arial"/>
                         </a:rPr>
@@ -6866,18 +6982,27 @@
                       </a:r>
                     </a:p>
                   </a:txBody>
-                  <a:tcPr anchor="ctr"/>
+                  <a:tcPr anchor="ctr" marL="109728" marR="109728">
+                    <a:lnB w="19050" cap="flat" cmpd="sng" algn="ctr">
+                      <a:solidFill>
+                        <a:srgbClr val="1D1D1F"/>
+                      </a:solidFill>
+                    </a:lnB>
+                    <a:solidFill>
+                      <a:srgbClr val="FFFFFF"/>
+                    </a:solidFill>
+                  </a:tcPr>
                 </a:tc>
                 <a:tc>
                   <a:txBody>
                     <a:bodyPr/>
                     <a:lstStyle/>
                     <a:p>
-                      <a:pPr algn="ctr"/>
+                      <a:pPr algn="r"/>
                       <a:r>
-                        <a:rPr sz="1300" b="1" i="0">
+                        <a:rPr sz="1400" b="1" i="0">
                           <a:solidFill>
-                            <a:srgbClr val="FFFFFF"/>
+                            <a:srgbClr val="1D1D1F"/>
                           </a:solidFill>
                           <a:latin typeface="Arial"/>
                         </a:rPr>
@@ -6885,7 +7010,16 @@
                       </a:r>
                     </a:p>
                   </a:txBody>
-                  <a:tcPr anchor="ctr"/>
+                  <a:tcPr anchor="ctr" marL="109728" marR="109728">
+                    <a:lnB w="19050" cap="flat" cmpd="sng" algn="ctr">
+                      <a:solidFill>
+                        <a:srgbClr val="1D1D1F"/>
+                      </a:solidFill>
+                    </a:lnB>
+                    <a:solidFill>
+                      <a:srgbClr val="FFFFFF"/>
+                    </a:solidFill>
+                  </a:tcPr>
                 </a:tc>
               </a:tr>
               <a:tr h="662940">
@@ -6894,11 +7028,11 @@
                     <a:bodyPr/>
                     <a:lstStyle/>
                     <a:p>
-                      <a:pPr algn="ctr"/>
+                      <a:pPr algn="l"/>
                       <a:r>
-                        <a:rPr sz="1300" b="0" i="0">
+                        <a:rPr sz="1400" b="0" i="0">
                           <a:solidFill>
-                            <a:srgbClr val="262A2E"/>
+                            <a:srgbClr val="1D1D1F"/>
                           </a:solidFill>
                           <a:latin typeface="Arial"/>
                         </a:rPr>
@@ -6906,17 +7040,27 @@
                       </a:r>
                     </a:p>
                   </a:txBody>
-                  <a:tcPr anchor="ctr"/>
+                  <a:tcPr anchor="ctr" marL="109728" marR="109728">
+                    <a:lnB w="9525" cap="flat" cmpd="sng" algn="ctr">
+                      <a:solidFill>
+                        <a:srgbClr val="E0E0E0"/>
+                      </a:solidFill>
+                    </a:lnB>
+                    <a:solidFill>
+                      <a:srgbClr val="FFFFFF"/>
+                    </a:solidFill>
+                  </a:tcPr>
                 </a:tc>
                 <a:tc>
                   <a:txBody>
                     <a:bodyPr/>
                     <a:lstStyle/>
                     <a:p>
+                      <a:pPr algn="r"/>
                       <a:r>
-                        <a:rPr sz="1300" b="0" i="0">
+                        <a:rPr sz="1400" b="0" i="0">
                           <a:solidFill>
-                            <a:srgbClr val="262A2E"/>
+                            <a:srgbClr val="1D1D1F"/>
                           </a:solidFill>
                           <a:latin typeface="Arial"/>
                         </a:rPr>
@@ -6924,17 +7068,27 @@
                       </a:r>
                     </a:p>
                   </a:txBody>
-                  <a:tcPr anchor="ctr"/>
+                  <a:tcPr anchor="ctr" marL="109728" marR="109728">
+                    <a:lnB w="9525" cap="flat" cmpd="sng" algn="ctr">
+                      <a:solidFill>
+                        <a:srgbClr val="E0E0E0"/>
+                      </a:solidFill>
+                    </a:lnB>
+                    <a:solidFill>
+                      <a:srgbClr val="FFFFFF"/>
+                    </a:solidFill>
+                  </a:tcPr>
                 </a:tc>
                 <a:tc>
                   <a:txBody>
                     <a:bodyPr/>
                     <a:lstStyle/>
                     <a:p>
+                      <a:pPr algn="r"/>
                       <a:r>
-                        <a:rPr sz="1300" b="0" i="0">
+                        <a:rPr sz="1400" b="0" i="0">
                           <a:solidFill>
-                            <a:srgbClr val="262A2E"/>
+                            <a:srgbClr val="1D1D1F"/>
                           </a:solidFill>
                           <a:latin typeface="Arial"/>
                         </a:rPr>
@@ -6942,7 +7096,16 @@
                       </a:r>
                     </a:p>
                   </a:txBody>
-                  <a:tcPr anchor="ctr"/>
+                  <a:tcPr anchor="ctr" marL="109728" marR="109728">
+                    <a:lnB w="9525" cap="flat" cmpd="sng" algn="ctr">
+                      <a:solidFill>
+                        <a:srgbClr val="E0E0E0"/>
+                      </a:solidFill>
+                    </a:lnB>
+                    <a:solidFill>
+                      <a:srgbClr val="FFFFFF"/>
+                    </a:solidFill>
+                  </a:tcPr>
                 </a:tc>
               </a:tr>
               <a:tr h="662940">
@@ -6951,11 +7114,11 @@
                     <a:bodyPr/>
                     <a:lstStyle/>
                     <a:p>
-                      <a:pPr algn="ctr"/>
+                      <a:pPr algn="l"/>
                       <a:r>
-                        <a:rPr sz="1300" b="0" i="0">
+                        <a:rPr sz="1400" b="0" i="0">
                           <a:solidFill>
-                            <a:srgbClr val="262A2E"/>
+                            <a:srgbClr val="1D1D1F"/>
                           </a:solidFill>
                           <a:latin typeface="Arial"/>
                         </a:rPr>
@@ -6963,17 +7126,27 @@
                       </a:r>
                     </a:p>
                   </a:txBody>
-                  <a:tcPr anchor="ctr"/>
+                  <a:tcPr anchor="ctr" marL="109728" marR="109728">
+                    <a:lnB w="9525" cap="flat" cmpd="sng" algn="ctr">
+                      <a:solidFill>
+                        <a:srgbClr val="E0E0E0"/>
+                      </a:solidFill>
+                    </a:lnB>
+                    <a:solidFill>
+                      <a:srgbClr val="FFFFFF"/>
+                    </a:solidFill>
+                  </a:tcPr>
                 </a:tc>
                 <a:tc>
                   <a:txBody>
                     <a:bodyPr/>
                     <a:lstStyle/>
                     <a:p>
+                      <a:pPr algn="r"/>
                       <a:r>
-                        <a:rPr sz="1300" b="0" i="0">
+                        <a:rPr sz="1400" b="0" i="0">
                           <a:solidFill>
-                            <a:srgbClr val="262A2E"/>
+                            <a:srgbClr val="1D1D1F"/>
                           </a:solidFill>
                           <a:latin typeface="Arial"/>
                         </a:rPr>
@@ -6981,17 +7154,27 @@
                       </a:r>
                     </a:p>
                   </a:txBody>
-                  <a:tcPr anchor="ctr"/>
+                  <a:tcPr anchor="ctr" marL="109728" marR="109728">
+                    <a:lnB w="9525" cap="flat" cmpd="sng" algn="ctr">
+                      <a:solidFill>
+                        <a:srgbClr val="E0E0E0"/>
+                      </a:solidFill>
+                    </a:lnB>
+                    <a:solidFill>
+                      <a:srgbClr val="FFFFFF"/>
+                    </a:solidFill>
+                  </a:tcPr>
                 </a:tc>
                 <a:tc>
                   <a:txBody>
                     <a:bodyPr/>
                     <a:lstStyle/>
                     <a:p>
+                      <a:pPr algn="r"/>
                       <a:r>
-                        <a:rPr sz="1300" b="0" i="0">
+                        <a:rPr sz="1400" b="0" i="0">
                           <a:solidFill>
-                            <a:srgbClr val="262A2E"/>
+                            <a:srgbClr val="1D1D1F"/>
                           </a:solidFill>
                           <a:latin typeface="Arial"/>
                         </a:rPr>
@@ -6999,7 +7182,16 @@
                       </a:r>
                     </a:p>
                   </a:txBody>
-                  <a:tcPr anchor="ctr"/>
+                  <a:tcPr anchor="ctr" marL="109728" marR="109728">
+                    <a:lnB w="9525" cap="flat" cmpd="sng" algn="ctr">
+                      <a:solidFill>
+                        <a:srgbClr val="E0E0E0"/>
+                      </a:solidFill>
+                    </a:lnB>
+                    <a:solidFill>
+                      <a:srgbClr val="FFFFFF"/>
+                    </a:solidFill>
+                  </a:tcPr>
                 </a:tc>
               </a:tr>
               <a:tr h="662940">
@@ -7008,11 +7200,11 @@
                     <a:bodyPr/>
                     <a:lstStyle/>
                     <a:p>
-                      <a:pPr algn="ctr"/>
+                      <a:pPr algn="l"/>
                       <a:r>
-                        <a:rPr sz="1300" b="0" i="0">
+                        <a:rPr sz="1400" b="0" i="0">
                           <a:solidFill>
-                            <a:srgbClr val="262A2E"/>
+                            <a:srgbClr val="1D1D1F"/>
                           </a:solidFill>
                           <a:latin typeface="Arial"/>
                         </a:rPr>
@@ -7020,17 +7212,22 @@
                       </a:r>
                     </a:p>
                   </a:txBody>
-                  <a:tcPr anchor="ctr"/>
+                  <a:tcPr anchor="ctr" marL="109728" marR="109728">
+                    <a:solidFill>
+                      <a:srgbClr val="FFFFFF"/>
+                    </a:solidFill>
+                  </a:tcPr>
                 </a:tc>
                 <a:tc>
                   <a:txBody>
                     <a:bodyPr/>
                     <a:lstStyle/>
                     <a:p>
+                      <a:pPr algn="r"/>
                       <a:r>
-                        <a:rPr sz="1300" b="0" i="0">
+                        <a:rPr sz="1400" b="0" i="0">
                           <a:solidFill>
-                            <a:srgbClr val="262A2E"/>
+                            <a:srgbClr val="1D1D1F"/>
                           </a:solidFill>
                           <a:latin typeface="Arial"/>
                         </a:rPr>
@@ -7038,17 +7235,22 @@
                       </a:r>
                     </a:p>
                   </a:txBody>
-                  <a:tcPr anchor="ctr"/>
+                  <a:tcPr anchor="ctr" marL="109728" marR="109728">
+                    <a:solidFill>
+                      <a:srgbClr val="FFFFFF"/>
+                    </a:solidFill>
+                  </a:tcPr>
                 </a:tc>
                 <a:tc>
                   <a:txBody>
                     <a:bodyPr/>
                     <a:lstStyle/>
                     <a:p>
+                      <a:pPr algn="r"/>
                       <a:r>
-                        <a:rPr sz="1300" b="0" i="0">
+                        <a:rPr sz="1400" b="0" i="0">
                           <a:solidFill>
-                            <a:srgbClr val="262A2E"/>
+                            <a:srgbClr val="1D1D1F"/>
                           </a:solidFill>
                           <a:latin typeface="Arial"/>
                         </a:rPr>
@@ -7056,7 +7258,11 @@
                       </a:r>
                     </a:p>
                   </a:txBody>
-                  <a:tcPr anchor="ctr"/>
+                  <a:tcPr anchor="ctr" marL="109728" marR="109728">
+                    <a:solidFill>
+                      <a:srgbClr val="FFFFFF"/>
+                    </a:solidFill>
+                  </a:tcPr>
                 </a:tc>
               </a:tr>
             </a:tbl>
@@ -7078,8 +7284,8 @@
         <a:graphic>
           <a:graphicData uri="http://schemas.openxmlformats.org/drawingml/2006/table">
             <a:tbl>
-              <a:tblPr firstRow="1" bandRow="1">
-                <a:tableStyleId>{5C22544A-7EE6-4342-B048-85BDC9FD1C3A}</a:tableStyleId>
+              <a:tblPr>
+                <a:tableStyleId>{2D5ABB26-0587-4C30-8999-92F81FD0307C}</a:tableStyleId>
               </a:tblPr>
               <a:tblGrid>
                 <a:gridCol w="1681429"/>
@@ -7092,11 +7298,11 @@
                     <a:bodyPr/>
                     <a:lstStyle/>
                     <a:p>
-                      <a:pPr algn="ctr"/>
+                      <a:pPr algn="l"/>
                       <a:r>
-                        <a:rPr sz="1300" b="1" i="0">
+                        <a:rPr sz="1400" b="1" i="0">
                           <a:solidFill>
-                            <a:srgbClr val="FFFFFF"/>
+                            <a:srgbClr val="1D1D1F"/>
                           </a:solidFill>
                           <a:latin typeface="Arial"/>
                         </a:rPr>
@@ -7104,18 +7310,27 @@
                       </a:r>
                     </a:p>
                   </a:txBody>
-                  <a:tcPr anchor="ctr"/>
+                  <a:tcPr anchor="ctr" marL="109728" marR="109728">
+                    <a:lnB w="19050" cap="flat" cmpd="sng" algn="ctr">
+                      <a:solidFill>
+                        <a:srgbClr val="1D1D1F"/>
+                      </a:solidFill>
+                    </a:lnB>
+                    <a:solidFill>
+                      <a:srgbClr val="FFFFFF"/>
+                    </a:solidFill>
+                  </a:tcPr>
                 </a:tc>
                 <a:tc>
                   <a:txBody>
                     <a:bodyPr/>
                     <a:lstStyle/>
                     <a:p>
-                      <a:pPr algn="ctr"/>
+                      <a:pPr algn="r"/>
                       <a:r>
-                        <a:rPr sz="1300" b="1" i="0">
+                        <a:rPr sz="1400" b="1" i="0">
                           <a:solidFill>
-                            <a:srgbClr val="FFFFFF"/>
+                            <a:srgbClr val="1D1D1F"/>
                           </a:solidFill>
                           <a:latin typeface="Arial"/>
                         </a:rPr>
@@ -7123,18 +7338,27 @@
                       </a:r>
                     </a:p>
                   </a:txBody>
-                  <a:tcPr anchor="ctr"/>
+                  <a:tcPr anchor="ctr" marL="109728" marR="109728">
+                    <a:lnB w="19050" cap="flat" cmpd="sng" algn="ctr">
+                      <a:solidFill>
+                        <a:srgbClr val="1D1D1F"/>
+                      </a:solidFill>
+                    </a:lnB>
+                    <a:solidFill>
+                      <a:srgbClr val="FFFFFF"/>
+                    </a:solidFill>
+                  </a:tcPr>
                 </a:tc>
                 <a:tc>
                   <a:txBody>
                     <a:bodyPr/>
                     <a:lstStyle/>
                     <a:p>
-                      <a:pPr algn="ctr"/>
+                      <a:pPr algn="r"/>
                       <a:r>
-                        <a:rPr sz="1300" b="1" i="0">
+                        <a:rPr sz="1400" b="1" i="0">
                           <a:solidFill>
-                            <a:srgbClr val="FFFFFF"/>
+                            <a:srgbClr val="1D1D1F"/>
                           </a:solidFill>
                           <a:latin typeface="Arial"/>
                         </a:rPr>
@@ -7142,7 +7366,16 @@
                       </a:r>
                     </a:p>
                   </a:txBody>
-                  <a:tcPr anchor="ctr"/>
+                  <a:tcPr anchor="ctr" marL="109728" marR="109728">
+                    <a:lnB w="19050" cap="flat" cmpd="sng" algn="ctr">
+                      <a:solidFill>
+                        <a:srgbClr val="1D1D1F"/>
+                      </a:solidFill>
+                    </a:lnB>
+                    <a:solidFill>
+                      <a:srgbClr val="FFFFFF"/>
+                    </a:solidFill>
+                  </a:tcPr>
                 </a:tc>
               </a:tr>
               <a:tr h="662940">
@@ -7151,11 +7384,11 @@
                     <a:bodyPr/>
                     <a:lstStyle/>
                     <a:p>
-                      <a:pPr algn="ctr"/>
+                      <a:pPr algn="l"/>
                       <a:r>
-                        <a:rPr sz="1300" b="0" i="0">
+                        <a:rPr sz="1400" b="0" i="0">
                           <a:solidFill>
-                            <a:srgbClr val="262A2E"/>
+                            <a:srgbClr val="1D1D1F"/>
                           </a:solidFill>
                           <a:latin typeface="Arial"/>
                         </a:rPr>
@@ -7163,17 +7396,27 @@
                       </a:r>
                     </a:p>
                   </a:txBody>
-                  <a:tcPr anchor="ctr"/>
+                  <a:tcPr anchor="ctr" marL="109728" marR="109728">
+                    <a:lnB w="9525" cap="flat" cmpd="sng" algn="ctr">
+                      <a:solidFill>
+                        <a:srgbClr val="E0E0E0"/>
+                      </a:solidFill>
+                    </a:lnB>
+                    <a:solidFill>
+                      <a:srgbClr val="FFFFFF"/>
+                    </a:solidFill>
+                  </a:tcPr>
                 </a:tc>
                 <a:tc>
                   <a:txBody>
                     <a:bodyPr/>
                     <a:lstStyle/>
                     <a:p>
+                      <a:pPr algn="r"/>
                       <a:r>
-                        <a:rPr sz="1300" b="0" i="0">
+                        <a:rPr sz="1400" b="0" i="0">
                           <a:solidFill>
-                            <a:srgbClr val="262A2E"/>
+                            <a:srgbClr val="1D1D1F"/>
                           </a:solidFill>
                           <a:latin typeface="Arial"/>
                         </a:rPr>
@@ -7181,17 +7424,27 @@
                       </a:r>
                     </a:p>
                   </a:txBody>
-                  <a:tcPr anchor="ctr"/>
+                  <a:tcPr anchor="ctr" marL="109728" marR="109728">
+                    <a:lnB w="9525" cap="flat" cmpd="sng" algn="ctr">
+                      <a:solidFill>
+                        <a:srgbClr val="E0E0E0"/>
+                      </a:solidFill>
+                    </a:lnB>
+                    <a:solidFill>
+                      <a:srgbClr val="FFFFFF"/>
+                    </a:solidFill>
+                  </a:tcPr>
                 </a:tc>
                 <a:tc>
                   <a:txBody>
                     <a:bodyPr/>
                     <a:lstStyle/>
                     <a:p>
+                      <a:pPr algn="r"/>
                       <a:r>
-                        <a:rPr sz="1300" b="0" i="0">
+                        <a:rPr sz="1400" b="0" i="0">
                           <a:solidFill>
-                            <a:srgbClr val="262A2E"/>
+                            <a:srgbClr val="1D1D1F"/>
                           </a:solidFill>
                           <a:latin typeface="Arial"/>
                         </a:rPr>
@@ -7199,7 +7452,16 @@
                       </a:r>
                     </a:p>
                   </a:txBody>
-                  <a:tcPr anchor="ctr"/>
+                  <a:tcPr anchor="ctr" marL="109728" marR="109728">
+                    <a:lnB w="9525" cap="flat" cmpd="sng" algn="ctr">
+                      <a:solidFill>
+                        <a:srgbClr val="E0E0E0"/>
+                      </a:solidFill>
+                    </a:lnB>
+                    <a:solidFill>
+                      <a:srgbClr val="FFFFFF"/>
+                    </a:solidFill>
+                  </a:tcPr>
                 </a:tc>
               </a:tr>
               <a:tr h="662940">
@@ -7208,11 +7470,11 @@
                     <a:bodyPr/>
                     <a:lstStyle/>
                     <a:p>
-                      <a:pPr algn="ctr"/>
+                      <a:pPr algn="l"/>
                       <a:r>
-                        <a:rPr sz="1300" b="0" i="0">
+                        <a:rPr sz="1400" b="0" i="0">
                           <a:solidFill>
-                            <a:srgbClr val="262A2E"/>
+                            <a:srgbClr val="1D1D1F"/>
                           </a:solidFill>
                           <a:latin typeface="Arial"/>
                         </a:rPr>
@@ -7220,17 +7482,27 @@
                       </a:r>
                     </a:p>
                   </a:txBody>
-                  <a:tcPr anchor="ctr"/>
+                  <a:tcPr anchor="ctr" marL="109728" marR="109728">
+                    <a:lnB w="9525" cap="flat" cmpd="sng" algn="ctr">
+                      <a:solidFill>
+                        <a:srgbClr val="E0E0E0"/>
+                      </a:solidFill>
+                    </a:lnB>
+                    <a:solidFill>
+                      <a:srgbClr val="FFFFFF"/>
+                    </a:solidFill>
+                  </a:tcPr>
                 </a:tc>
                 <a:tc>
                   <a:txBody>
                     <a:bodyPr/>
                     <a:lstStyle/>
                     <a:p>
+                      <a:pPr algn="r"/>
                       <a:r>
-                        <a:rPr sz="1300" b="0" i="0">
+                        <a:rPr sz="1400" b="0" i="0">
                           <a:solidFill>
-                            <a:srgbClr val="262A2E"/>
+                            <a:srgbClr val="1D1D1F"/>
                           </a:solidFill>
                           <a:latin typeface="Arial"/>
                         </a:rPr>
@@ -7238,17 +7510,27 @@
                       </a:r>
                     </a:p>
                   </a:txBody>
-                  <a:tcPr anchor="ctr"/>
+                  <a:tcPr anchor="ctr" marL="109728" marR="109728">
+                    <a:lnB w="9525" cap="flat" cmpd="sng" algn="ctr">
+                      <a:solidFill>
+                        <a:srgbClr val="E0E0E0"/>
+                      </a:solidFill>
+                    </a:lnB>
+                    <a:solidFill>
+                      <a:srgbClr val="FFFFFF"/>
+                    </a:solidFill>
+                  </a:tcPr>
                 </a:tc>
                 <a:tc>
                   <a:txBody>
                     <a:bodyPr/>
                     <a:lstStyle/>
                     <a:p>
+                      <a:pPr algn="r"/>
                       <a:r>
-                        <a:rPr sz="1300" b="0" i="0">
+                        <a:rPr sz="1400" b="0" i="0">
                           <a:solidFill>
-                            <a:srgbClr val="262A2E"/>
+                            <a:srgbClr val="1D1D1F"/>
                           </a:solidFill>
                           <a:latin typeface="Arial"/>
                         </a:rPr>
@@ -7256,7 +7538,16 @@
                       </a:r>
                     </a:p>
                   </a:txBody>
-                  <a:tcPr anchor="ctr"/>
+                  <a:tcPr anchor="ctr" marL="109728" marR="109728">
+                    <a:lnB w="9525" cap="flat" cmpd="sng" algn="ctr">
+                      <a:solidFill>
+                        <a:srgbClr val="E0E0E0"/>
+                      </a:solidFill>
+                    </a:lnB>
+                    <a:solidFill>
+                      <a:srgbClr val="FFFFFF"/>
+                    </a:solidFill>
+                  </a:tcPr>
                 </a:tc>
               </a:tr>
               <a:tr h="662940">
@@ -7265,11 +7556,11 @@
                     <a:bodyPr/>
                     <a:lstStyle/>
                     <a:p>
-                      <a:pPr algn="ctr"/>
+                      <a:pPr algn="l"/>
                       <a:r>
-                        <a:rPr sz="1300" b="0" i="0">
+                        <a:rPr sz="1400" b="0" i="0">
                           <a:solidFill>
-                            <a:srgbClr val="262A2E"/>
+                            <a:srgbClr val="1D1D1F"/>
                           </a:solidFill>
                           <a:latin typeface="Arial"/>
                         </a:rPr>
@@ -7277,17 +7568,22 @@
                       </a:r>
                     </a:p>
                   </a:txBody>
-                  <a:tcPr anchor="ctr"/>
+                  <a:tcPr anchor="ctr" marL="109728" marR="109728">
+                    <a:solidFill>
+                      <a:srgbClr val="FFFFFF"/>
+                    </a:solidFill>
+                  </a:tcPr>
                 </a:tc>
                 <a:tc>
                   <a:txBody>
                     <a:bodyPr/>
                     <a:lstStyle/>
                     <a:p>
+                      <a:pPr algn="r"/>
                       <a:r>
-                        <a:rPr sz="1300" b="0" i="0">
+                        <a:rPr sz="1400" b="0" i="0">
                           <a:solidFill>
-                            <a:srgbClr val="262A2E"/>
+                            <a:srgbClr val="1D1D1F"/>
                           </a:solidFill>
                           <a:latin typeface="Arial"/>
                         </a:rPr>
@@ -7295,17 +7591,22 @@
                       </a:r>
                     </a:p>
                   </a:txBody>
-                  <a:tcPr anchor="ctr"/>
+                  <a:tcPr anchor="ctr" marL="109728" marR="109728">
+                    <a:solidFill>
+                      <a:srgbClr val="FFFFFF"/>
+                    </a:solidFill>
+                  </a:tcPr>
                 </a:tc>
                 <a:tc>
                   <a:txBody>
                     <a:bodyPr/>
                     <a:lstStyle/>
                     <a:p>
+                      <a:pPr algn="r"/>
                       <a:r>
-                        <a:rPr sz="1300" b="0" i="0">
+                        <a:rPr sz="1400" b="0" i="0">
                           <a:solidFill>
-                            <a:srgbClr val="262A2E"/>
+                            <a:srgbClr val="1D1D1F"/>
                           </a:solidFill>
                           <a:latin typeface="Arial"/>
                         </a:rPr>
@@ -7313,7 +7614,11 @@
                       </a:r>
                     </a:p>
                   </a:txBody>
-                  <a:tcPr anchor="ctr"/>
+                  <a:tcPr anchor="ctr" marL="109728" marR="109728">
+                    <a:solidFill>
+                      <a:srgbClr val="FFFFFF"/>
+                    </a:solidFill>
+                  </a:tcPr>
                 </a:tc>
               </a:tr>
             </a:tbl>
@@ -7343,9 +7648,9 @@
           <a:lstStyle/>
           <a:p>
             <a:r>
-              <a:rPr sz="1600" b="0" i="0">
+              <a:rPr sz="1700" b="0" i="0">
                 <a:solidFill>
-                  <a:srgbClr val="6B7280"/>
+                  <a:srgbClr val="6E6E73"/>
                 </a:solidFill>
                 <a:latin typeface="Arial"/>
               </a:rPr>
@@ -7397,7 +7702,7 @@
             <a:r>
               <a:rPr sz="3000" b="1" i="0">
                 <a:solidFill>
-                  <a:srgbClr val="262A2E"/>
+                  <a:srgbClr val="1D1D1F"/>
                 </a:solidFill>
                 <a:latin typeface="Arial"/>
               </a:rPr>
@@ -7421,7 +7726,7 @@
             <a:avLst/>
           </a:prstGeom>
           <a:solidFill>
-            <a:srgbClr val="3B6EA5"/>
+            <a:srgbClr val="0066CC"/>
           </a:solidFill>
           <a:ln>
             <a:noFill/>
@@ -7473,9 +7778,9 @@
           <a:lstStyle/>
           <a:p>
             <a:r>
-              <a:rPr sz="1600" b="0" i="0">
+              <a:rPr sz="1700" b="0" i="0">
                 <a:solidFill>
-                  <a:srgbClr val="6B7280"/>
+                  <a:srgbClr val="6E6E73"/>
                 </a:solidFill>
                 <a:latin typeface="Arial"/>
               </a:rPr>
@@ -7499,8 +7804,8 @@
         <a:graphic>
           <a:graphicData uri="http://schemas.openxmlformats.org/drawingml/2006/table">
             <a:tbl>
-              <a:tblPr firstRow="1" bandRow="1">
-                <a:tableStyleId>{5C22544A-7EE6-4342-B048-85BDC9FD1C3A}</a:tableStyleId>
+              <a:tblPr>
+                <a:tableStyleId>{2D5ABB26-0587-4C30-8999-92F81FD0307C}</a:tableStyleId>
               </a:tblPr>
               <a:tblGrid>
                 <a:gridCol w="1645920"/>
@@ -7513,11 +7818,11 @@
                     <a:bodyPr/>
                     <a:lstStyle/>
                     <a:p>
-                      <a:pPr algn="ctr"/>
+                      <a:pPr algn="l"/>
                       <a:r>
-                        <a:rPr sz="1300" b="1" i="0">
+                        <a:rPr sz="1400" b="1" i="0">
                           <a:solidFill>
-                            <a:srgbClr val="FFFFFF"/>
+                            <a:srgbClr val="1D1D1F"/>
                           </a:solidFill>
                           <a:latin typeface="Arial"/>
                         </a:rPr>
@@ -7525,18 +7830,27 @@
                       </a:r>
                     </a:p>
                   </a:txBody>
-                  <a:tcPr anchor="ctr"/>
+                  <a:tcPr anchor="ctr" marL="109728" marR="109728">
+                    <a:lnB w="19050" cap="flat" cmpd="sng" algn="ctr">
+                      <a:solidFill>
+                        <a:srgbClr val="1D1D1F"/>
+                      </a:solidFill>
+                    </a:lnB>
+                    <a:solidFill>
+                      <a:srgbClr val="FFFFFF"/>
+                    </a:solidFill>
+                  </a:tcPr>
                 </a:tc>
                 <a:tc>
                   <a:txBody>
                     <a:bodyPr/>
                     <a:lstStyle/>
                     <a:p>
-                      <a:pPr algn="ctr"/>
+                      <a:pPr algn="r"/>
                       <a:r>
-                        <a:rPr sz="1300" b="1" i="0">
+                        <a:rPr sz="1400" b="1" i="0">
                           <a:solidFill>
-                            <a:srgbClr val="FFFFFF"/>
+                            <a:srgbClr val="1D1D1F"/>
                           </a:solidFill>
                           <a:latin typeface="Arial"/>
                         </a:rPr>
@@ -7544,18 +7858,27 @@
                       </a:r>
                     </a:p>
                   </a:txBody>
-                  <a:tcPr anchor="ctr"/>
+                  <a:tcPr anchor="ctr" marL="109728" marR="109728">
+                    <a:lnB w="19050" cap="flat" cmpd="sng" algn="ctr">
+                      <a:solidFill>
+                        <a:srgbClr val="1D1D1F"/>
+                      </a:solidFill>
+                    </a:lnB>
+                    <a:solidFill>
+                      <a:srgbClr val="FFFFFF"/>
+                    </a:solidFill>
+                  </a:tcPr>
                 </a:tc>
                 <a:tc>
                   <a:txBody>
                     <a:bodyPr/>
                     <a:lstStyle/>
                     <a:p>
-                      <a:pPr algn="ctr"/>
+                      <a:pPr algn="r"/>
                       <a:r>
-                        <a:rPr sz="1300" b="1" i="0">
+                        <a:rPr sz="1400" b="1" i="0">
                           <a:solidFill>
-                            <a:srgbClr val="FFFFFF"/>
+                            <a:srgbClr val="1D1D1F"/>
                           </a:solidFill>
                           <a:latin typeface="Arial"/>
                         </a:rPr>
@@ -7563,7 +7886,16 @@
                       </a:r>
                     </a:p>
                   </a:txBody>
-                  <a:tcPr anchor="ctr"/>
+                  <a:tcPr anchor="ctr" marL="109728" marR="109728">
+                    <a:lnB w="19050" cap="flat" cmpd="sng" algn="ctr">
+                      <a:solidFill>
+                        <a:srgbClr val="1D1D1F"/>
+                      </a:solidFill>
+                    </a:lnB>
+                    <a:solidFill>
+                      <a:srgbClr val="FFFFFF"/>
+                    </a:solidFill>
+                  </a:tcPr>
                 </a:tc>
               </a:tr>
               <a:tr h="585216">
@@ -7572,11 +7904,11 @@
                     <a:bodyPr/>
                     <a:lstStyle/>
                     <a:p>
-                      <a:pPr algn="ctr"/>
+                      <a:pPr algn="l"/>
                       <a:r>
-                        <a:rPr sz="1300" b="0" i="0">
+                        <a:rPr sz="1400" b="0" i="0">
                           <a:solidFill>
-                            <a:srgbClr val="262A2E"/>
+                            <a:srgbClr val="1D1D1F"/>
                           </a:solidFill>
                           <a:latin typeface="Arial"/>
                         </a:rPr>
@@ -7584,17 +7916,27 @@
                       </a:r>
                     </a:p>
                   </a:txBody>
-                  <a:tcPr anchor="ctr"/>
+                  <a:tcPr anchor="ctr" marL="109728" marR="109728">
+                    <a:lnB w="9525" cap="flat" cmpd="sng" algn="ctr">
+                      <a:solidFill>
+                        <a:srgbClr val="E0E0E0"/>
+                      </a:solidFill>
+                    </a:lnB>
+                    <a:solidFill>
+                      <a:srgbClr val="FFFFFF"/>
+                    </a:solidFill>
+                  </a:tcPr>
                 </a:tc>
                 <a:tc>
                   <a:txBody>
                     <a:bodyPr/>
                     <a:lstStyle/>
                     <a:p>
+                      <a:pPr algn="r"/>
                       <a:r>
-                        <a:rPr sz="1300" b="0" i="0">
+                        <a:rPr sz="1400" b="0" i="0">
                           <a:solidFill>
-                            <a:srgbClr val="262A2E"/>
+                            <a:srgbClr val="1D1D1F"/>
                           </a:solidFill>
                           <a:latin typeface="Arial"/>
                         </a:rPr>
@@ -7602,17 +7944,27 @@
                       </a:r>
                     </a:p>
                   </a:txBody>
-                  <a:tcPr anchor="ctr"/>
+                  <a:tcPr anchor="ctr" marL="109728" marR="109728">
+                    <a:lnB w="9525" cap="flat" cmpd="sng" algn="ctr">
+                      <a:solidFill>
+                        <a:srgbClr val="E0E0E0"/>
+                      </a:solidFill>
+                    </a:lnB>
+                    <a:solidFill>
+                      <a:srgbClr val="FFFFFF"/>
+                    </a:solidFill>
+                  </a:tcPr>
                 </a:tc>
                 <a:tc>
                   <a:txBody>
                     <a:bodyPr/>
                     <a:lstStyle/>
                     <a:p>
+                      <a:pPr algn="r"/>
                       <a:r>
-                        <a:rPr sz="1300" b="0" i="0">
+                        <a:rPr sz="1400" b="0" i="0">
                           <a:solidFill>
-                            <a:srgbClr val="262A2E"/>
+                            <a:srgbClr val="1D1D1F"/>
                           </a:solidFill>
                           <a:latin typeface="Arial"/>
                         </a:rPr>
@@ -7620,7 +7972,16 @@
                       </a:r>
                     </a:p>
                   </a:txBody>
-                  <a:tcPr anchor="ctr"/>
+                  <a:tcPr anchor="ctr" marL="109728" marR="109728">
+                    <a:lnB w="9525" cap="flat" cmpd="sng" algn="ctr">
+                      <a:solidFill>
+                        <a:srgbClr val="E0E0E0"/>
+                      </a:solidFill>
+                    </a:lnB>
+                    <a:solidFill>
+                      <a:srgbClr val="FFFFFF"/>
+                    </a:solidFill>
+                  </a:tcPr>
                 </a:tc>
               </a:tr>
               <a:tr h="585216">
@@ -7629,11 +7990,11 @@
                     <a:bodyPr/>
                     <a:lstStyle/>
                     <a:p>
-                      <a:pPr algn="ctr"/>
+                      <a:pPr algn="l"/>
                       <a:r>
-                        <a:rPr sz="1300" b="0" i="0">
+                        <a:rPr sz="1400" b="0" i="0">
                           <a:solidFill>
-                            <a:srgbClr val="262A2E"/>
+                            <a:srgbClr val="1D1D1F"/>
                           </a:solidFill>
                           <a:latin typeface="Arial"/>
                         </a:rPr>
@@ -7641,17 +8002,27 @@
                       </a:r>
                     </a:p>
                   </a:txBody>
-                  <a:tcPr anchor="ctr"/>
+                  <a:tcPr anchor="ctr" marL="109728" marR="109728">
+                    <a:lnB w="9525" cap="flat" cmpd="sng" algn="ctr">
+                      <a:solidFill>
+                        <a:srgbClr val="E0E0E0"/>
+                      </a:solidFill>
+                    </a:lnB>
+                    <a:solidFill>
+                      <a:srgbClr val="FFFFFF"/>
+                    </a:solidFill>
+                  </a:tcPr>
                 </a:tc>
                 <a:tc>
                   <a:txBody>
                     <a:bodyPr/>
                     <a:lstStyle/>
                     <a:p>
+                      <a:pPr algn="r"/>
                       <a:r>
-                        <a:rPr sz="1300" b="0" i="0">
+                        <a:rPr sz="1400" b="0" i="0">
                           <a:solidFill>
-                            <a:srgbClr val="262A2E"/>
+                            <a:srgbClr val="1D1D1F"/>
                           </a:solidFill>
                           <a:latin typeface="Arial"/>
                         </a:rPr>
@@ -7659,17 +8030,27 @@
                       </a:r>
                     </a:p>
                   </a:txBody>
-                  <a:tcPr anchor="ctr"/>
+                  <a:tcPr anchor="ctr" marL="109728" marR="109728">
+                    <a:lnB w="9525" cap="flat" cmpd="sng" algn="ctr">
+                      <a:solidFill>
+                        <a:srgbClr val="E0E0E0"/>
+                      </a:solidFill>
+                    </a:lnB>
+                    <a:solidFill>
+                      <a:srgbClr val="FFFFFF"/>
+                    </a:solidFill>
+                  </a:tcPr>
                 </a:tc>
                 <a:tc>
                   <a:txBody>
                     <a:bodyPr/>
                     <a:lstStyle/>
                     <a:p>
+                      <a:pPr algn="r"/>
                       <a:r>
-                        <a:rPr sz="1300" b="0" i="0">
+                        <a:rPr sz="1400" b="0" i="0">
                           <a:solidFill>
-                            <a:srgbClr val="262A2E"/>
+                            <a:srgbClr val="1D1D1F"/>
                           </a:solidFill>
                           <a:latin typeface="Arial"/>
                         </a:rPr>
@@ -7677,7 +8058,16 @@
                       </a:r>
                     </a:p>
                   </a:txBody>
-                  <a:tcPr anchor="ctr"/>
+                  <a:tcPr anchor="ctr" marL="109728" marR="109728">
+                    <a:lnB w="9525" cap="flat" cmpd="sng" algn="ctr">
+                      <a:solidFill>
+                        <a:srgbClr val="E0E0E0"/>
+                      </a:solidFill>
+                    </a:lnB>
+                    <a:solidFill>
+                      <a:srgbClr val="FFFFFF"/>
+                    </a:solidFill>
+                  </a:tcPr>
                 </a:tc>
               </a:tr>
               <a:tr h="585216">
@@ -7686,11 +8076,11 @@
                     <a:bodyPr/>
                     <a:lstStyle/>
                     <a:p>
-                      <a:pPr algn="ctr"/>
+                      <a:pPr algn="l"/>
                       <a:r>
-                        <a:rPr sz="1300" b="0" i="0">
+                        <a:rPr sz="1400" b="0" i="0">
                           <a:solidFill>
-                            <a:srgbClr val="262A2E"/>
+                            <a:srgbClr val="1D1D1F"/>
                           </a:solidFill>
                           <a:latin typeface="Arial"/>
                         </a:rPr>
@@ -7698,17 +8088,27 @@
                       </a:r>
                     </a:p>
                   </a:txBody>
-                  <a:tcPr anchor="ctr"/>
+                  <a:tcPr anchor="ctr" marL="109728" marR="109728">
+                    <a:lnB w="9525" cap="flat" cmpd="sng" algn="ctr">
+                      <a:solidFill>
+                        <a:srgbClr val="E0E0E0"/>
+                      </a:solidFill>
+                    </a:lnB>
+                    <a:solidFill>
+                      <a:srgbClr val="FFFFFF"/>
+                    </a:solidFill>
+                  </a:tcPr>
                 </a:tc>
                 <a:tc>
                   <a:txBody>
                     <a:bodyPr/>
                     <a:lstStyle/>
                     <a:p>
+                      <a:pPr algn="r"/>
                       <a:r>
-                        <a:rPr sz="1300" b="0" i="0">
+                        <a:rPr sz="1400" b="0" i="0">
                           <a:solidFill>
-                            <a:srgbClr val="262A2E"/>
+                            <a:srgbClr val="1D1D1F"/>
                           </a:solidFill>
                           <a:latin typeface="Arial"/>
                         </a:rPr>
@@ -7716,17 +8116,27 @@
                       </a:r>
                     </a:p>
                   </a:txBody>
-                  <a:tcPr anchor="ctr"/>
+                  <a:tcPr anchor="ctr" marL="109728" marR="109728">
+                    <a:lnB w="9525" cap="flat" cmpd="sng" algn="ctr">
+                      <a:solidFill>
+                        <a:srgbClr val="E0E0E0"/>
+                      </a:solidFill>
+                    </a:lnB>
+                    <a:solidFill>
+                      <a:srgbClr val="FFFFFF"/>
+                    </a:solidFill>
+                  </a:tcPr>
                 </a:tc>
                 <a:tc>
                   <a:txBody>
                     <a:bodyPr/>
                     <a:lstStyle/>
                     <a:p>
+                      <a:pPr algn="r"/>
                       <a:r>
-                        <a:rPr sz="1300" b="0" i="0">
+                        <a:rPr sz="1400" b="0" i="0">
                           <a:solidFill>
-                            <a:srgbClr val="262A2E"/>
+                            <a:srgbClr val="1D1D1F"/>
                           </a:solidFill>
                           <a:latin typeface="Arial"/>
                         </a:rPr>
@@ -7734,7 +8144,16 @@
                       </a:r>
                     </a:p>
                   </a:txBody>
-                  <a:tcPr anchor="ctr"/>
+                  <a:tcPr anchor="ctr" marL="109728" marR="109728">
+                    <a:lnB w="9525" cap="flat" cmpd="sng" algn="ctr">
+                      <a:solidFill>
+                        <a:srgbClr val="E0E0E0"/>
+                      </a:solidFill>
+                    </a:lnB>
+                    <a:solidFill>
+                      <a:srgbClr val="FFFFFF"/>
+                    </a:solidFill>
+                  </a:tcPr>
                 </a:tc>
               </a:tr>
               <a:tr h="585216">
@@ -7743,11 +8162,11 @@
                     <a:bodyPr/>
                     <a:lstStyle/>
                     <a:p>
-                      <a:pPr algn="ctr"/>
+                      <a:pPr algn="l"/>
                       <a:r>
-                        <a:rPr sz="1300" b="0" i="0">
+                        <a:rPr sz="1400" b="0" i="0">
                           <a:solidFill>
-                            <a:srgbClr val="262A2E"/>
+                            <a:srgbClr val="1D1D1F"/>
                           </a:solidFill>
                           <a:latin typeface="Arial"/>
                         </a:rPr>
@@ -7755,17 +8174,22 @@
                       </a:r>
                     </a:p>
                   </a:txBody>
-                  <a:tcPr anchor="ctr"/>
+                  <a:tcPr anchor="ctr" marL="109728" marR="109728">
+                    <a:solidFill>
+                      <a:srgbClr val="FFFFFF"/>
+                    </a:solidFill>
+                  </a:tcPr>
                 </a:tc>
                 <a:tc>
                   <a:txBody>
                     <a:bodyPr/>
                     <a:lstStyle/>
                     <a:p>
+                      <a:pPr algn="r"/>
                       <a:r>
-                        <a:rPr sz="1300" b="0" i="0">
+                        <a:rPr sz="1400" b="0" i="0">
                           <a:solidFill>
-                            <a:srgbClr val="262A2E"/>
+                            <a:srgbClr val="1D1D1F"/>
                           </a:solidFill>
                           <a:latin typeface="Arial"/>
                         </a:rPr>
@@ -7773,17 +8197,22 @@
                       </a:r>
                     </a:p>
                   </a:txBody>
-                  <a:tcPr anchor="ctr"/>
+                  <a:tcPr anchor="ctr" marL="109728" marR="109728">
+                    <a:solidFill>
+                      <a:srgbClr val="FFFFFF"/>
+                    </a:solidFill>
+                  </a:tcPr>
                 </a:tc>
                 <a:tc>
                   <a:txBody>
                     <a:bodyPr/>
                     <a:lstStyle/>
                     <a:p>
+                      <a:pPr algn="r"/>
                       <a:r>
-                        <a:rPr sz="1300" b="0" i="0">
+                        <a:rPr sz="1400" b="0" i="0">
                           <a:solidFill>
-                            <a:srgbClr val="262A2E"/>
+                            <a:srgbClr val="1D1D1F"/>
                           </a:solidFill>
                           <a:latin typeface="Arial"/>
                         </a:rPr>
@@ -7791,7 +8220,11 @@
                       </a:r>
                     </a:p>
                   </a:txBody>
-                  <a:tcPr anchor="ctr"/>
+                  <a:tcPr anchor="ctr" marL="109728" marR="109728">
+                    <a:solidFill>
+                      <a:srgbClr val="FFFFFF"/>
+                    </a:solidFill>
+                  </a:tcPr>
                 </a:tc>
               </a:tr>
             </a:tbl>
@@ -7839,9 +8272,9 @@
           <a:lstStyle/>
           <a:p>
             <a:r>
-              <a:rPr sz="1600" b="0" i="0">
+              <a:rPr sz="1700" b="0" i="0">
                 <a:solidFill>
-                  <a:srgbClr val="6B7280"/>
+                  <a:srgbClr val="6E6E73"/>
                 </a:solidFill>
                 <a:latin typeface="Arial"/>
               </a:rPr>
@@ -7893,7 +8326,7 @@
             <a:r>
               <a:rPr sz="3000" b="1" i="0">
                 <a:solidFill>
-                  <a:srgbClr val="262A2E"/>
+                  <a:srgbClr val="1D1D1F"/>
                 </a:solidFill>
                 <a:latin typeface="Arial"/>
               </a:rPr>
@@ -7917,7 +8350,7 @@
             <a:avLst/>
           </a:prstGeom>
           <a:solidFill>
-            <a:srgbClr val="3B6EA5"/>
+            <a:srgbClr val="0066CC"/>
           </a:solidFill>
           <a:ln>
             <a:noFill/>
@@ -7969,9 +8402,9 @@
           <a:lstStyle/>
           <a:p>
             <a:r>
-              <a:rPr sz="1600" b="0" i="0">
+              <a:rPr sz="1700" b="0" i="0">
                 <a:solidFill>
-                  <a:srgbClr val="6B7280"/>
+                  <a:srgbClr val="6E6E73"/>
                 </a:solidFill>
                 <a:latin typeface="Arial"/>
               </a:rPr>
@@ -7992,14 +8425,16 @@
             <a:ext cx="3271418" cy="2468880"/>
           </a:xfrm>
           <a:prstGeom prst="roundRect">
-            <a:avLst/>
+            <a:avLst>
+              <a:gd name="adj" fmla="val 7000"/>
+            </a:avLst>
           </a:prstGeom>
           <a:solidFill>
-            <a:srgbClr val="F4F5F7"/>
+            <a:srgbClr val="F5F5F7"/>
           </a:solidFill>
           <a:ln w="9525">
             <a:solidFill>
-              <a:srgbClr val="D7DBE0"/>
+              <a:srgbClr val="E0E0E0"/>
             </a:solidFill>
           </a:ln>
           <a:effectLst/>
@@ -8026,7 +8461,7 @@
             <a:r>
               <a:rPr sz="3000" b="1" i="0">
                 <a:solidFill>
-                  <a:srgbClr val="3B6EA5"/>
+                  <a:srgbClr val="0066CC"/>
                 </a:solidFill>
                 <a:latin typeface="Arial"/>
               </a:rPr>
@@ -8038,7 +8473,7 @@
             <a:r>
               <a:rPr sz="1500" b="0" i="0">
                 <a:solidFill>
-                  <a:srgbClr val="6B7280"/>
+                  <a:srgbClr val="6E6E73"/>
                 </a:solidFill>
                 <a:latin typeface="Arial"/>
               </a:rPr>
@@ -8059,14 +8494,16 @@
             <a:ext cx="3271418" cy="2468880"/>
           </a:xfrm>
           <a:prstGeom prst="roundRect">
-            <a:avLst/>
+            <a:avLst>
+              <a:gd name="adj" fmla="val 7000"/>
+            </a:avLst>
           </a:prstGeom>
           <a:solidFill>
-            <a:srgbClr val="F4F5F7"/>
+            <a:srgbClr val="F5F5F7"/>
           </a:solidFill>
           <a:ln w="9525">
             <a:solidFill>
-              <a:srgbClr val="D7DBE0"/>
+              <a:srgbClr val="E0E0E0"/>
             </a:solidFill>
           </a:ln>
           <a:effectLst/>
@@ -8093,7 +8530,7 @@
             <a:r>
               <a:rPr sz="3000" b="1" i="0">
                 <a:solidFill>
-                  <a:srgbClr val="3B6EA5"/>
+                  <a:srgbClr val="0066CC"/>
                 </a:solidFill>
                 <a:latin typeface="Arial"/>
               </a:rPr>
@@ -8105,7 +8542,7 @@
             <a:r>
               <a:rPr sz="1500" b="0" i="0">
                 <a:solidFill>
-                  <a:srgbClr val="6B7280"/>
+                  <a:srgbClr val="6E6E73"/>
                 </a:solidFill>
                 <a:latin typeface="Arial"/>
               </a:rPr>
@@ -8126,14 +8563,16 @@
             <a:ext cx="3271418" cy="2468880"/>
           </a:xfrm>
           <a:prstGeom prst="roundRect">
-            <a:avLst/>
+            <a:avLst>
+              <a:gd name="adj" fmla="val 7000"/>
+            </a:avLst>
           </a:prstGeom>
           <a:solidFill>
-            <a:srgbClr val="F4F5F7"/>
+            <a:srgbClr val="F5F5F7"/>
           </a:solidFill>
           <a:ln w="9525">
             <a:solidFill>
-              <a:srgbClr val="D7DBE0"/>
+              <a:srgbClr val="E0E0E0"/>
             </a:solidFill>
           </a:ln>
           <a:effectLst/>
@@ -8160,7 +8599,7 @@
             <a:r>
               <a:rPr sz="3000" b="1" i="0">
                 <a:solidFill>
-                  <a:srgbClr val="3B6EA5"/>
+                  <a:srgbClr val="0066CC"/>
                 </a:solidFill>
                 <a:latin typeface="Arial"/>
               </a:rPr>
@@ -8172,7 +8611,7 @@
             <a:r>
               <a:rPr sz="1500" b="0" i="0">
                 <a:solidFill>
-                  <a:srgbClr val="6B7280"/>
+                  <a:srgbClr val="6E6E73"/>
                 </a:solidFill>
                 <a:latin typeface="Arial"/>
               </a:rPr>
@@ -8204,9 +8643,9 @@
           <a:lstStyle/>
           <a:p>
             <a:r>
-              <a:rPr sz="1600" b="0" i="0">
+              <a:rPr sz="1700" b="0" i="0">
                 <a:solidFill>
-                  <a:srgbClr val="6B7280"/>
+                  <a:srgbClr val="6E6E73"/>
                 </a:solidFill>
                 <a:latin typeface="Arial"/>
               </a:rPr>
@@ -8258,7 +8697,7 @@
             <a:r>
               <a:rPr sz="3000" b="1" i="0">
                 <a:solidFill>
-                  <a:srgbClr val="262A2E"/>
+                  <a:srgbClr val="1D1D1F"/>
                 </a:solidFill>
                 <a:latin typeface="Arial"/>
               </a:rPr>
@@ -8282,7 +8721,7 @@
             <a:avLst/>
           </a:prstGeom>
           <a:solidFill>
-            <a:srgbClr val="3B6EA5"/>
+            <a:srgbClr val="0066CC"/>
           </a:solidFill>
           <a:ln>
             <a:noFill/>
@@ -8378,7 +8817,7 @@
             <a:r>
               <a:rPr sz="3000" b="1" i="0">
                 <a:solidFill>
-                  <a:srgbClr val="262A2E"/>
+                  <a:srgbClr val="1D1D1F"/>
                 </a:solidFill>
                 <a:latin typeface="Arial"/>
               </a:rPr>
@@ -8402,7 +8841,7 @@
             <a:avLst/>
           </a:prstGeom>
           <a:solidFill>
-            <a:srgbClr val="3B6EA5"/>
+            <a:srgbClr val="0066CC"/>
           </a:solidFill>
           <a:ln>
             <a:noFill/>
@@ -8461,7 +8900,7 @@
             <a:r>
               <a:rPr sz="2000" b="1" i="0">
                 <a:solidFill>
-                  <a:srgbClr val="3B6EA5"/>
+                  <a:srgbClr val="0066CC"/>
                 </a:solidFill>
                 <a:latin typeface="Arial"/>
               </a:rPr>
@@ -8475,9 +8914,9 @@
               </a:spcAft>
             </a:pPr>
             <a:r>
-              <a:rPr sz="1600" b="0" i="0">
+              <a:rPr sz="1700" b="0" i="0">
                 <a:solidFill>
-                  <a:srgbClr val="262A2E"/>
+                  <a:srgbClr val="1D1D1F"/>
                 </a:solidFill>
                 <a:latin typeface="Arial"/>
               </a:rPr>
@@ -8491,9 +8930,9 @@
               </a:spcAft>
             </a:pPr>
             <a:r>
-              <a:rPr sz="1600" b="0" i="0">
+              <a:rPr sz="1700" b="0" i="0">
                 <a:solidFill>
-                  <a:srgbClr val="262A2E"/>
+                  <a:srgbClr val="1D1D1F"/>
                 </a:solidFill>
                 <a:latin typeface="Arial"/>
               </a:rPr>
@@ -8507,9 +8946,9 @@
               </a:spcAft>
             </a:pPr>
             <a:r>
-              <a:rPr sz="1600" b="0" i="0">
+              <a:rPr sz="1700" b="0" i="0">
                 <a:solidFill>
-                  <a:srgbClr val="262A2E"/>
+                  <a:srgbClr val="1D1D1F"/>
                 </a:solidFill>
                 <a:latin typeface="Arial"/>
               </a:rPr>
@@ -8585,7 +9024,7 @@
             <a:r>
               <a:rPr sz="3000" b="1" i="0">
                 <a:solidFill>
-                  <a:srgbClr val="262A2E"/>
+                  <a:srgbClr val="1D1D1F"/>
                 </a:solidFill>
                 <a:latin typeface="Arial"/>
               </a:rPr>
@@ -8609,7 +9048,7 @@
             <a:avLst/>
           </a:prstGeom>
           <a:solidFill>
-            <a:srgbClr val="3B6EA5"/>
+            <a:srgbClr val="0066CC"/>
           </a:solidFill>
           <a:ln>
             <a:noFill/>
@@ -8668,7 +9107,7 @@
             <a:r>
               <a:rPr sz="1800" b="0" i="0">
                 <a:solidFill>
-                  <a:srgbClr val="262A2E"/>
+                  <a:srgbClr val="1D1D1F"/>
                 </a:solidFill>
                 <a:latin typeface="Arial"/>
               </a:rPr>
@@ -8684,7 +9123,7 @@
             <a:r>
               <a:rPr sz="1800" b="0" i="0">
                 <a:solidFill>
-                  <a:srgbClr val="262A2E"/>
+                  <a:srgbClr val="1D1D1F"/>
                 </a:solidFill>
                 <a:latin typeface="Arial"/>
               </a:rPr>
@@ -8700,7 +9139,7 @@
             <a:r>
               <a:rPr sz="1800" b="0" i="0">
                 <a:solidFill>
-                  <a:srgbClr val="262A2E"/>
+                  <a:srgbClr val="1D1D1F"/>
                 </a:solidFill>
                 <a:latin typeface="Arial"/>
               </a:rPr>
@@ -8724,7 +9163,7 @@
             <a:avLst/>
           </a:prstGeom>
           <a:solidFill>
-            <a:srgbClr val="F4F5F7"/>
+            <a:srgbClr val="F5F5F7"/>
           </a:solidFill>
           <a:ln>
             <a:noFill/>
@@ -8749,11 +9188,11 @@
           <a:bodyPr rtlCol="0" anchor="ctr" wrap="square" lIns="274320"/>
           <a:lstStyle/>
           <a:p>
-            <a:pPr algn="ctr"/>
+            <a:pPr algn="l"/>
             <a:r>
               <a:rPr sz="1800" b="1" i="0">
                 <a:solidFill>
-                  <a:srgbClr val="262A2E"/>
+                  <a:srgbClr val="1D1D1F"/>
                 </a:solidFill>
                 <a:latin typeface="Arial"/>
               </a:rPr>
@@ -8777,7 +9216,7 @@
             <a:avLst/>
           </a:prstGeom>
           <a:solidFill>
-            <a:srgbClr val="3B6EA5"/>
+            <a:srgbClr val="0066CC"/>
           </a:solidFill>
           <a:ln>
             <a:noFill/>
@@ -8849,7 +9288,7 @@
             <a:r>
               <a:rPr sz="3000" b="1" i="0">
                 <a:solidFill>
-                  <a:srgbClr val="262A2E"/>
+                  <a:srgbClr val="1D1D1F"/>
                 </a:solidFill>
                 <a:latin typeface="Arial"/>
               </a:rPr>
@@ -8873,7 +9312,7 @@
             <a:avLst/>
           </a:prstGeom>
           <a:solidFill>
-            <a:srgbClr val="3B6EA5"/>
+            <a:srgbClr val="0066CC"/>
           </a:solidFill>
           <a:ln>
             <a:noFill/>
@@ -8925,6 +9364,9 @@
           <a:lstStyle/>
           <a:p>
             <a:pPr marL="88900" indent="-88900">
+              <a:lnSpc>
+                <a:spcPct val="115000"/>
+              </a:lnSpc>
               <a:spcAft>
                 <a:spcPts val="1000"/>
               </a:spcAft>
@@ -8933,7 +9375,7 @@
             <a:r>
               <a:rPr sz="1800" b="0" i="0">
                 <a:solidFill>
-                  <a:srgbClr val="262A2E"/>
+                  <a:srgbClr val="1D1D1F"/>
                 </a:solidFill>
                 <a:latin typeface="Arial"/>
               </a:rPr>
@@ -8942,6 +9384,9 @@
           </a:p>
           <a:p>
             <a:pPr marL="88900" indent="-88900">
+              <a:lnSpc>
+                <a:spcPct val="115000"/>
+              </a:lnSpc>
               <a:spcAft>
                 <a:spcPts val="1000"/>
               </a:spcAft>
@@ -8950,7 +9395,7 @@
             <a:r>
               <a:rPr sz="1800" b="0" i="0">
                 <a:solidFill>
-                  <a:srgbClr val="262A2E"/>
+                  <a:srgbClr val="1D1D1F"/>
                 </a:solidFill>
                 <a:latin typeface="Arial"/>
               </a:rPr>
@@ -8959,6 +9404,9 @@
           </a:p>
           <a:p>
             <a:pPr marL="88900" indent="-88900">
+              <a:lnSpc>
+                <a:spcPct val="115000"/>
+              </a:lnSpc>
               <a:spcAft>
                 <a:spcPts val="1000"/>
               </a:spcAft>
@@ -8967,7 +9415,7 @@
             <a:r>
               <a:rPr sz="1800" b="0" i="0">
                 <a:solidFill>
-                  <a:srgbClr val="262A2E"/>
+                  <a:srgbClr val="1D1D1F"/>
                 </a:solidFill>
                 <a:latin typeface="Arial"/>
               </a:rPr>
@@ -8976,6 +9424,9 @@
           </a:p>
           <a:p>
             <a:pPr marL="88900" indent="-88900">
+              <a:lnSpc>
+                <a:spcPct val="115000"/>
+              </a:lnSpc>
               <a:spcAft>
                 <a:spcPts val="1000"/>
               </a:spcAft>
@@ -8984,7 +9435,7 @@
             <a:r>
               <a:rPr sz="1800" b="0" i="0">
                 <a:solidFill>
-                  <a:srgbClr val="262A2E"/>
+                  <a:srgbClr val="1D1D1F"/>
                 </a:solidFill>
                 <a:latin typeface="Arial"/>
               </a:rPr>
@@ -9004,6 +9455,14 @@
 <file path=ppt/slides/slide20.xml><?xml version="1.0" encoding="utf-8"?>
 <p:sld xmlns:a="http://schemas.openxmlformats.org/drawingml/2006/main" xmlns:p="http://schemas.openxmlformats.org/presentationml/2006/main" xmlns:r="http://schemas.openxmlformats.org/officeDocument/2006/relationships">
   <p:cSld>
+    <p:bg>
+      <p:bgPr>
+        <a:solidFill>
+          <a:srgbClr val="1D1D1F"/>
+        </a:solidFill>
+        <a:effectLst/>
+      </p:bgPr>
+    </p:bg>
     <p:spTree>
       <p:nvGrpSpPr>
         <p:cNvPr id="1" name=""/>
@@ -9037,7 +9496,7 @@
             <a:r>
               <a:rPr sz="4000" b="1" i="0">
                 <a:solidFill>
-                  <a:srgbClr val="262A2E"/>
+                  <a:srgbClr val="FFFFFF"/>
                 </a:solidFill>
                 <a:latin typeface="Arial"/>
               </a:rPr>
@@ -9072,7 +9531,7 @@
             <a:r>
               <a:rPr sz="1800" b="0" i="0">
                 <a:solidFill>
-                  <a:srgbClr val="6B7280"/>
+                  <a:srgbClr val="CCCCCC"/>
                 </a:solidFill>
                 <a:latin typeface="Arial"/>
               </a:rPr>
@@ -9124,7 +9583,7 @@
             <a:r>
               <a:rPr sz="3000" b="1" i="0">
                 <a:solidFill>
-                  <a:srgbClr val="262A2E"/>
+                  <a:srgbClr val="1D1D1F"/>
                 </a:solidFill>
                 <a:latin typeface="Arial"/>
               </a:rPr>
@@ -9148,7 +9607,7 @@
             <a:avLst/>
           </a:prstGeom>
           <a:solidFill>
-            <a:srgbClr val="3B6EA5"/>
+            <a:srgbClr val="0066CC"/>
           </a:solidFill>
           <a:ln>
             <a:noFill/>
@@ -9200,6 +9659,9 @@
           <a:lstStyle/>
           <a:p>
             <a:pPr marL="152400" indent="-152400">
+              <a:lnSpc>
+                <a:spcPct val="115000"/>
+              </a:lnSpc>
               <a:spcAft>
                 <a:spcPts val="1000"/>
               </a:spcAft>
@@ -9209,7 +9671,7 @@
             <a:r>
               <a:rPr sz="1800" b="0" i="0">
                 <a:solidFill>
-                  <a:srgbClr val="262A2E"/>
+                  <a:srgbClr val="1D1D1F"/>
                 </a:solidFill>
                 <a:latin typeface="Arial"/>
               </a:rPr>
@@ -9218,6 +9680,9 @@
           </a:p>
           <a:p>
             <a:pPr marL="152400" indent="-152400">
+              <a:lnSpc>
+                <a:spcPct val="115000"/>
+              </a:lnSpc>
               <a:spcAft>
                 <a:spcPts val="1000"/>
               </a:spcAft>
@@ -9227,7 +9692,7 @@
             <a:r>
               <a:rPr sz="1800" b="0" i="0">
                 <a:solidFill>
-                  <a:srgbClr val="262A2E"/>
+                  <a:srgbClr val="1D1D1F"/>
                 </a:solidFill>
                 <a:latin typeface="Arial"/>
               </a:rPr>
@@ -9236,6 +9701,9 @@
           </a:p>
           <a:p>
             <a:pPr marL="152400" indent="-152400">
+              <a:lnSpc>
+                <a:spcPct val="115000"/>
+              </a:lnSpc>
               <a:spcAft>
                 <a:spcPts val="1000"/>
               </a:spcAft>
@@ -9245,7 +9713,7 @@
             <a:r>
               <a:rPr sz="1800" b="0" i="0">
                 <a:solidFill>
-                  <a:srgbClr val="262A2E"/>
+                  <a:srgbClr val="1D1D1F"/>
                 </a:solidFill>
                 <a:latin typeface="Arial"/>
               </a:rPr>
@@ -9254,6 +9722,9 @@
           </a:p>
           <a:p>
             <a:pPr marL="152400" indent="-152400">
+              <a:lnSpc>
+                <a:spcPct val="115000"/>
+              </a:lnSpc>
               <a:spcAft>
                 <a:spcPts val="1000"/>
               </a:spcAft>
@@ -9263,7 +9734,7 @@
             <a:r>
               <a:rPr sz="1800" b="0" i="0">
                 <a:solidFill>
-                  <a:srgbClr val="262A2E"/>
+                  <a:srgbClr val="1D1D1F"/>
                 </a:solidFill>
                 <a:latin typeface="Arial"/>
               </a:rPr>
@@ -9286,7 +9757,7 @@
     <p:bg>
       <p:bgPr>
         <a:solidFill>
-          <a:srgbClr val="E8EAED"/>
+          <a:srgbClr val="1D1D1F"/>
         </a:solidFill>
         <a:effectLst/>
       </p:bgPr>
@@ -9324,7 +9795,7 @@
             <a:r>
               <a:rPr sz="3400" b="1" i="0">
                 <a:solidFill>
-                  <a:srgbClr val="262A2E"/>
+                  <a:srgbClr val="FFFFFF"/>
                 </a:solidFill>
                 <a:latin typeface="Arial"/>
               </a:rPr>
@@ -9376,7 +9847,7 @@
             <a:r>
               <a:rPr sz="3000" b="1" i="0">
                 <a:solidFill>
-                  <a:srgbClr val="262A2E"/>
+                  <a:srgbClr val="1D1D1F"/>
                 </a:solidFill>
                 <a:latin typeface="Arial"/>
               </a:rPr>
@@ -9400,7 +9871,7 @@
             <a:avLst/>
           </a:prstGeom>
           <a:solidFill>
-            <a:srgbClr val="3B6EA5"/>
+            <a:srgbClr val="0066CC"/>
           </a:solidFill>
           <a:ln>
             <a:noFill/>
@@ -9459,7 +9930,7 @@
             <a:r>
               <a:rPr sz="2000" b="1" i="0">
                 <a:solidFill>
-                  <a:srgbClr val="3B6EA5"/>
+                  <a:srgbClr val="0066CC"/>
                 </a:solidFill>
                 <a:latin typeface="Arial"/>
               </a:rPr>
@@ -9475,7 +9946,7 @@
             <a:r>
               <a:rPr sz="1700" b="0" i="0">
                 <a:solidFill>
-                  <a:srgbClr val="262A2E"/>
+                  <a:srgbClr val="1D1D1F"/>
                 </a:solidFill>
                 <a:latin typeface="Arial"/>
               </a:rPr>
@@ -9491,7 +9962,7 @@
             <a:r>
               <a:rPr sz="1700" b="0" i="0">
                 <a:solidFill>
-                  <a:srgbClr val="262A2E"/>
+                  <a:srgbClr val="1D1D1F"/>
                 </a:solidFill>
                 <a:latin typeface="Arial"/>
               </a:rPr>
@@ -9507,7 +9978,7 @@
             <a:r>
               <a:rPr sz="1700" b="0" i="0">
                 <a:solidFill>
-                  <a:srgbClr val="262A2E"/>
+                  <a:srgbClr val="1D1D1F"/>
                 </a:solidFill>
                 <a:latin typeface="Arial"/>
               </a:rPr>
@@ -9546,7 +10017,7 @@
             <a:r>
               <a:rPr sz="2000" b="1" i="0">
                 <a:solidFill>
-                  <a:srgbClr val="3B6EA5"/>
+                  <a:srgbClr val="0066CC"/>
                 </a:solidFill>
                 <a:latin typeface="Arial"/>
               </a:rPr>
@@ -9562,7 +10033,7 @@
             <a:r>
               <a:rPr sz="1700" b="0" i="0">
                 <a:solidFill>
-                  <a:srgbClr val="262A2E"/>
+                  <a:srgbClr val="1D1D1F"/>
                 </a:solidFill>
                 <a:latin typeface="Arial"/>
               </a:rPr>
@@ -9578,7 +10049,7 @@
             <a:r>
               <a:rPr sz="1700" b="0" i="0">
                 <a:solidFill>
-                  <a:srgbClr val="262A2E"/>
+                  <a:srgbClr val="1D1D1F"/>
                 </a:solidFill>
                 <a:latin typeface="Arial"/>
               </a:rPr>
@@ -9594,7 +10065,7 @@
             <a:r>
               <a:rPr sz="1700" b="0" i="0">
                 <a:solidFill>
-                  <a:srgbClr val="262A2E"/>
+                  <a:srgbClr val="1D1D1F"/>
                 </a:solidFill>
                 <a:latin typeface="Arial"/>
               </a:rPr>
@@ -9646,7 +10117,7 @@
             <a:r>
               <a:rPr sz="3000" b="1" i="0">
                 <a:solidFill>
-                  <a:srgbClr val="262A2E"/>
+                  <a:srgbClr val="1D1D1F"/>
                 </a:solidFill>
                 <a:latin typeface="Arial"/>
               </a:rPr>
@@ -9670,7 +10141,7 @@
             <a:avLst/>
           </a:prstGeom>
           <a:solidFill>
-            <a:srgbClr val="3B6EA5"/>
+            <a:srgbClr val="0066CC"/>
           </a:solidFill>
           <a:ln>
             <a:noFill/>
@@ -9729,7 +10200,7 @@
             <a:r>
               <a:rPr sz="1800" b="1" i="0">
                 <a:solidFill>
-                  <a:srgbClr val="3B6EA5"/>
+                  <a:srgbClr val="0066CC"/>
                 </a:solidFill>
                 <a:latin typeface="Arial"/>
               </a:rPr>
@@ -9745,7 +10216,7 @@
             <a:r>
               <a:rPr sz="1600" b="0" i="0">
                 <a:solidFill>
-                  <a:srgbClr val="262A2E"/>
+                  <a:srgbClr val="1D1D1F"/>
                 </a:solidFill>
                 <a:latin typeface="Arial"/>
               </a:rPr>
@@ -9761,7 +10232,7 @@
             <a:r>
               <a:rPr sz="1600" b="0" i="0">
                 <a:solidFill>
-                  <a:srgbClr val="262A2E"/>
+                  <a:srgbClr val="1D1D1F"/>
                 </a:solidFill>
                 <a:latin typeface="Arial"/>
               </a:rPr>
@@ -9777,7 +10248,7 @@
             <a:r>
               <a:rPr sz="1600" b="0" i="0">
                 <a:solidFill>
-                  <a:srgbClr val="262A2E"/>
+                  <a:srgbClr val="1D1D1F"/>
                 </a:solidFill>
                 <a:latin typeface="Arial"/>
               </a:rPr>
@@ -9816,7 +10287,7 @@
             <a:r>
               <a:rPr sz="1800" b="1" i="0">
                 <a:solidFill>
-                  <a:srgbClr val="3B6EA5"/>
+                  <a:srgbClr val="0066CC"/>
                 </a:solidFill>
                 <a:latin typeface="Arial"/>
               </a:rPr>
@@ -9832,7 +10303,7 @@
             <a:r>
               <a:rPr sz="1600" b="0" i="0">
                 <a:solidFill>
-                  <a:srgbClr val="262A2E"/>
+                  <a:srgbClr val="1D1D1F"/>
                 </a:solidFill>
                 <a:latin typeface="Arial"/>
               </a:rPr>
@@ -9848,7 +10319,7 @@
             <a:r>
               <a:rPr sz="1600" b="0" i="0">
                 <a:solidFill>
-                  <a:srgbClr val="262A2E"/>
+                  <a:srgbClr val="1D1D1F"/>
                 </a:solidFill>
                 <a:latin typeface="Arial"/>
               </a:rPr>
@@ -9864,7 +10335,7 @@
             <a:r>
               <a:rPr sz="1600" b="0" i="0">
                 <a:solidFill>
-                  <a:srgbClr val="262A2E"/>
+                  <a:srgbClr val="1D1D1F"/>
                 </a:solidFill>
                 <a:latin typeface="Arial"/>
               </a:rPr>
@@ -9903,7 +10374,7 @@
             <a:r>
               <a:rPr sz="1800" b="1" i="0">
                 <a:solidFill>
-                  <a:srgbClr val="3B6EA5"/>
+                  <a:srgbClr val="0066CC"/>
                 </a:solidFill>
                 <a:latin typeface="Arial"/>
               </a:rPr>
@@ -9919,7 +10390,7 @@
             <a:r>
               <a:rPr sz="1600" b="0" i="0">
                 <a:solidFill>
-                  <a:srgbClr val="262A2E"/>
+                  <a:srgbClr val="1D1D1F"/>
                 </a:solidFill>
                 <a:latin typeface="Arial"/>
               </a:rPr>
@@ -9935,7 +10406,7 @@
             <a:r>
               <a:rPr sz="1600" b="0" i="0">
                 <a:solidFill>
-                  <a:srgbClr val="262A2E"/>
+                  <a:srgbClr val="1D1D1F"/>
                 </a:solidFill>
                 <a:latin typeface="Arial"/>
               </a:rPr>
@@ -9951,7 +10422,7 @@
             <a:r>
               <a:rPr sz="1600" b="0" i="0">
                 <a:solidFill>
-                  <a:srgbClr val="262A2E"/>
+                  <a:srgbClr val="1D1D1F"/>
                 </a:solidFill>
                 <a:latin typeface="Arial"/>
               </a:rPr>
@@ -10003,7 +10474,7 @@
             <a:r>
               <a:rPr sz="3000" b="1" i="0">
                 <a:solidFill>
-                  <a:srgbClr val="262A2E"/>
+                  <a:srgbClr val="1D1D1F"/>
                 </a:solidFill>
                 <a:latin typeface="Arial"/>
               </a:rPr>
@@ -10027,7 +10498,7 @@
             <a:avLst/>
           </a:prstGeom>
           <a:solidFill>
-            <a:srgbClr val="3B6EA5"/>
+            <a:srgbClr val="0066CC"/>
           </a:solidFill>
           <a:ln>
             <a:noFill/>
@@ -10086,7 +10557,7 @@
             <a:r>
               <a:rPr sz="1800" b="1" i="0">
                 <a:solidFill>
-                  <a:srgbClr val="3B6EA5"/>
+                  <a:srgbClr val="0066CC"/>
                 </a:solidFill>
                 <a:latin typeface="Arial"/>
               </a:rPr>
@@ -10102,7 +10573,7 @@
             <a:r>
               <a:rPr sz="1400" b="0" i="0">
                 <a:solidFill>
-                  <a:srgbClr val="262A2E"/>
+                  <a:srgbClr val="1D1D1F"/>
                 </a:solidFill>
                 <a:latin typeface="Arial"/>
               </a:rPr>
@@ -10118,7 +10589,7 @@
             <a:r>
               <a:rPr sz="1400" b="0" i="0">
                 <a:solidFill>
-                  <a:srgbClr val="262A2E"/>
+                  <a:srgbClr val="1D1D1F"/>
                 </a:solidFill>
                 <a:latin typeface="Arial"/>
               </a:rPr>
@@ -10134,7 +10605,7 @@
             <a:r>
               <a:rPr sz="1400" b="0" i="0">
                 <a:solidFill>
-                  <a:srgbClr val="262A2E"/>
+                  <a:srgbClr val="1D1D1F"/>
                 </a:solidFill>
                 <a:latin typeface="Arial"/>
               </a:rPr>
@@ -10173,7 +10644,7 @@
             <a:r>
               <a:rPr sz="1800" b="1" i="0">
                 <a:solidFill>
-                  <a:srgbClr val="3B6EA5"/>
+                  <a:srgbClr val="0066CC"/>
                 </a:solidFill>
                 <a:latin typeface="Arial"/>
               </a:rPr>
@@ -10189,7 +10660,7 @@
             <a:r>
               <a:rPr sz="1400" b="0" i="0">
                 <a:solidFill>
-                  <a:srgbClr val="262A2E"/>
+                  <a:srgbClr val="1D1D1F"/>
                 </a:solidFill>
                 <a:latin typeface="Arial"/>
               </a:rPr>
@@ -10205,7 +10676,7 @@
             <a:r>
               <a:rPr sz="1400" b="0" i="0">
                 <a:solidFill>
-                  <a:srgbClr val="262A2E"/>
+                  <a:srgbClr val="1D1D1F"/>
                 </a:solidFill>
                 <a:latin typeface="Arial"/>
               </a:rPr>
@@ -10221,7 +10692,7 @@
             <a:r>
               <a:rPr sz="1400" b="0" i="0">
                 <a:solidFill>
-                  <a:srgbClr val="262A2E"/>
+                  <a:srgbClr val="1D1D1F"/>
                 </a:solidFill>
                 <a:latin typeface="Arial"/>
               </a:rPr>
@@ -10260,7 +10731,7 @@
             <a:r>
               <a:rPr sz="1800" b="1" i="0">
                 <a:solidFill>
-                  <a:srgbClr val="3B6EA5"/>
+                  <a:srgbClr val="0066CC"/>
                 </a:solidFill>
                 <a:latin typeface="Arial"/>
               </a:rPr>
@@ -10276,7 +10747,7 @@
             <a:r>
               <a:rPr sz="1400" b="0" i="0">
                 <a:solidFill>
-                  <a:srgbClr val="262A2E"/>
+                  <a:srgbClr val="1D1D1F"/>
                 </a:solidFill>
                 <a:latin typeface="Arial"/>
               </a:rPr>
@@ -10292,7 +10763,7 @@
             <a:r>
               <a:rPr sz="1400" b="0" i="0">
                 <a:solidFill>
-                  <a:srgbClr val="262A2E"/>
+                  <a:srgbClr val="1D1D1F"/>
                 </a:solidFill>
                 <a:latin typeface="Arial"/>
               </a:rPr>
@@ -10308,7 +10779,7 @@
             <a:r>
               <a:rPr sz="1400" b="0" i="0">
                 <a:solidFill>
-                  <a:srgbClr val="262A2E"/>
+                  <a:srgbClr val="1D1D1F"/>
                 </a:solidFill>
                 <a:latin typeface="Arial"/>
               </a:rPr>
@@ -10347,7 +10818,7 @@
             <a:r>
               <a:rPr sz="1800" b="1" i="0">
                 <a:solidFill>
-                  <a:srgbClr val="3B6EA5"/>
+                  <a:srgbClr val="0066CC"/>
                 </a:solidFill>
                 <a:latin typeface="Arial"/>
               </a:rPr>
@@ -10363,7 +10834,7 @@
             <a:r>
               <a:rPr sz="1400" b="0" i="0">
                 <a:solidFill>
-                  <a:srgbClr val="262A2E"/>
+                  <a:srgbClr val="1D1D1F"/>
                 </a:solidFill>
                 <a:latin typeface="Arial"/>
               </a:rPr>
@@ -10379,7 +10850,7 @@
             <a:r>
               <a:rPr sz="1400" b="0" i="0">
                 <a:solidFill>
-                  <a:srgbClr val="262A2E"/>
+                  <a:srgbClr val="1D1D1F"/>
                 </a:solidFill>
                 <a:latin typeface="Arial"/>
               </a:rPr>
@@ -10395,7 +10866,7 @@
             <a:r>
               <a:rPr sz="1400" b="0" i="0">
                 <a:solidFill>
-                  <a:srgbClr val="262A2E"/>
+                  <a:srgbClr val="1D1D1F"/>
                 </a:solidFill>
                 <a:latin typeface="Arial"/>
               </a:rPr>
@@ -10447,7 +10918,7 @@
             <a:r>
               <a:rPr sz="3000" b="1" i="0">
                 <a:solidFill>
-                  <a:srgbClr val="262A2E"/>
+                  <a:srgbClr val="1D1D1F"/>
                 </a:solidFill>
                 <a:latin typeface="Arial"/>
               </a:rPr>
@@ -10471,7 +10942,7 @@
             <a:avLst/>
           </a:prstGeom>
           <a:solidFill>
-            <a:srgbClr val="3B6EA5"/>
+            <a:srgbClr val="0066CC"/>
           </a:solidFill>
           <a:ln>
             <a:noFill/>
@@ -10523,9 +10994,9 @@
           <a:lstStyle/>
           <a:p>
             <a:r>
-              <a:rPr sz="1600" b="0" i="0">
+              <a:rPr sz="1700" b="0" i="0">
                 <a:solidFill>
-                  <a:srgbClr val="6B7280"/>
+                  <a:srgbClr val="6E6E73"/>
                 </a:solidFill>
                 <a:latin typeface="Arial"/>
               </a:rPr>
@@ -10595,7 +11066,7 @@
             <a:r>
               <a:rPr sz="3000" b="1" i="0">
                 <a:solidFill>
-                  <a:srgbClr val="262A2E"/>
+                  <a:srgbClr val="1D1D1F"/>
                 </a:solidFill>
                 <a:latin typeface="Arial"/>
               </a:rPr>
@@ -10619,7 +11090,7 @@
             <a:avLst/>
           </a:prstGeom>
           <a:solidFill>
-            <a:srgbClr val="3B6EA5"/>
+            <a:srgbClr val="0066CC"/>
           </a:solidFill>
           <a:ln>
             <a:noFill/>
@@ -10671,9 +11142,9 @@
           <a:lstStyle/>
           <a:p>
             <a:r>
-              <a:rPr sz="1600" b="0" i="0">
+              <a:rPr sz="1700" b="0" i="0">
                 <a:solidFill>
-                  <a:srgbClr val="6B7280"/>
+                  <a:srgbClr val="6E6E73"/>
                 </a:solidFill>
                 <a:latin typeface="Arial"/>
               </a:rPr>
@@ -10725,22 +11196,22 @@
         <a:srgbClr val="EEECE1"/>
       </a:lt2>
       <a:accent1>
-        <a:srgbClr val="4F81BD"/>
+        <a:srgbClr val="0066CC"/>
       </a:accent1>
       <a:accent2>
-        <a:srgbClr val="C0504D"/>
+        <a:srgbClr val="E8893B"/>
       </a:accent2>
       <a:accent3>
-        <a:srgbClr val="9BBB59"/>
+        <a:srgbClr val="34A853"/>
       </a:accent3>
       <a:accent4>
-        <a:srgbClr val="8064A2"/>
+        <a:srgbClr val="C44D8A"/>
       </a:accent4>
       <a:accent5>
-        <a:srgbClr val="4BACC6"/>
+        <a:srgbClr val="5AC8DC"/>
       </a:accent5>
       <a:accent6>
-        <a:srgbClr val="F79646"/>
+        <a:srgbClr val="5E5CE6"/>
       </a:accent6>
       <a:hlink>
         <a:srgbClr val="0000FF"/>
@@ -11045,22 +11516,22 @@
         <a:srgbClr val="EEECE1"/>
       </a:lt2>
       <a:accent1>
-        <a:srgbClr val="4F81BD"/>
+        <a:srgbClr val="0066CC"/>
       </a:accent1>
       <a:accent2>
-        <a:srgbClr val="C0504D"/>
+        <a:srgbClr val="E8893B"/>
       </a:accent2>
       <a:accent3>
-        <a:srgbClr val="9BBB59"/>
+        <a:srgbClr val="34A853"/>
       </a:accent3>
       <a:accent4>
-        <a:srgbClr val="8064A2"/>
+        <a:srgbClr val="C44D8A"/>
       </a:accent4>
       <a:accent5>
-        <a:srgbClr val="4BACC6"/>
+        <a:srgbClr val="5AC8DC"/>
       </a:accent5>
       <a:accent6>
-        <a:srgbClr val="F79646"/>
+        <a:srgbClr val="5E5CE6"/>
       </a:accent6>
       <a:hlink>
         <a:srgbClr val="0000FF"/>

</xml_diff>

<commit_message>
modify compose-pptx skill md
</commit_message>
<xml_diff>
--- a/template-source/basic_template.pptx
+++ b/template-source/basic_template.pptx
@@ -152,6 +152,13 @@
               </c:strCache>
             </c:strRef>
           </c:tx>
+          <c:spPr>
+            <a:solidFill>
+              <a:schemeClr val="accent1">
+                <a:alpha val="87000"/>
+              </a:schemeClr>
+            </a:solidFill>
+          </c:spPr>
           <c:cat>
             <c:strRef>
               <c:f>Sheet1!$A$2:$A$5</c:f>
@@ -208,6 +215,13 @@
               </c:strCache>
             </c:strRef>
           </c:tx>
+          <c:spPr>
+            <a:solidFill>
+              <a:schemeClr val="accent2">
+                <a:alpha val="87000"/>
+              </a:schemeClr>
+            </a:solidFill>
+          </c:spPr>
           <c:cat>
             <c:strRef>
               <c:f>Sheet1!$A$2:$A$5</c:f>
@@ -277,7 +291,16 @@
         <c:scaling/>
         <c:delete val="0"/>
         <c:axPos val="l"/>
-        <c:majorGridlines/>
+        <c:majorGridlines>
+          <c:spPr>
+            <a:ln w="9525">
+              <a:solidFill>
+                <a:srgbClr val="D9D9D9"/>
+              </a:solidFill>
+              <a:prstDash val="sysDot"/>
+            </a:ln>
+          </c:spPr>
+        </c:majorGridlines>
         <c:majorTickMark val="out"/>
         <c:minorTickMark val="none"/>
         <c:tickLblPos val="nextTo"/>
@@ -330,6 +353,15 @@
               </c:strCache>
             </c:strRef>
           </c:tx>
+          <c:spPr>
+            <a:ln>
+              <a:solidFill>
+                <a:schemeClr val="accent1">
+                  <a:alpha val="87000"/>
+                </a:schemeClr>
+              </a:solidFill>
+            </a:ln>
+          </c:spPr>
           <c:cat>
             <c:strRef>
               <c:f>Sheet1!$A$2:$A$7</c:f>
@@ -412,7 +444,16 @@
         <c:scaling/>
         <c:delete val="0"/>
         <c:axPos val="l"/>
-        <c:majorGridlines/>
+        <c:majorGridlines>
+          <c:spPr>
+            <a:ln w="9525">
+              <a:solidFill>
+                <a:srgbClr val="D9D9D9"/>
+              </a:solidFill>
+              <a:prstDash val="sysDot"/>
+            </a:ln>
+          </c:spPr>
+        </c:majorGridlines>
         <c:majorTickMark val="out"/>
         <c:minorTickMark val="none"/>
         <c:tickLblPos val="nextTo"/>
@@ -466,6 +507,46 @@
               </c:strCache>
             </c:strRef>
           </c:tx>
+          <c:dPt>
+            <c:idx val="0"/>
+            <c:spPr>
+              <a:solidFill>
+                <a:schemeClr val="accent1">
+                  <a:alpha val="87000"/>
+                </a:schemeClr>
+              </a:solidFill>
+            </c:spPr>
+          </c:dPt>
+          <c:dPt>
+            <c:idx val="1"/>
+            <c:spPr>
+              <a:solidFill>
+                <a:schemeClr val="accent2">
+                  <a:alpha val="87000"/>
+                </a:schemeClr>
+              </a:solidFill>
+            </c:spPr>
+          </c:dPt>
+          <c:dPt>
+            <c:idx val="2"/>
+            <c:spPr>
+              <a:solidFill>
+                <a:schemeClr val="accent3">
+                  <a:alpha val="87000"/>
+                </a:schemeClr>
+              </a:solidFill>
+            </c:spPr>
+          </c:dPt>
+          <c:dPt>
+            <c:idx val="3"/>
+            <c:spPr>
+              <a:solidFill>
+                <a:schemeClr val="accent4">
+                  <a:alpha val="87000"/>
+                </a:schemeClr>
+              </a:solidFill>
+            </c:spPr>
+          </c:dPt>
           <c:cat>
             <c:strRef>
               <c:f>Sheet1!$A$2:$A$5</c:f>
@@ -564,6 +645,13 @@
               </c:strCache>
             </c:strRef>
           </c:tx>
+          <c:spPr>
+            <a:solidFill>
+              <a:schemeClr val="accent1">
+                <a:alpha val="87000"/>
+              </a:schemeClr>
+            </a:solidFill>
+          </c:spPr>
           <c:cat>
             <c:strRef>
               <c:f>Sheet1!$A$2:$A$6</c:f>
@@ -638,7 +726,16 @@
         <c:scaling/>
         <c:delete val="0"/>
         <c:axPos val="l"/>
-        <c:majorGridlines/>
+        <c:majorGridlines>
+          <c:spPr>
+            <a:ln w="9525">
+              <a:solidFill>
+                <a:srgbClr val="D9D9D9"/>
+              </a:solidFill>
+              <a:prstDash val="sysDot"/>
+            </a:ln>
+          </c:spPr>
+        </c:majorGridlines>
         <c:majorTickMark val="out"/>
         <c:minorTickMark val="none"/>
         <c:tickLblPos val="nextTo"/>
@@ -687,6 +784,13 @@
               </c:strCache>
             </c:strRef>
           </c:tx>
+          <c:spPr>
+            <a:solidFill>
+              <a:schemeClr val="accent1">
+                <a:alpha val="87000"/>
+              </a:schemeClr>
+            </a:solidFill>
+          </c:spPr>
           <c:cat>
             <c:strRef>
               <c:f>Sheet1!$A$2:$A$5</c:f>
@@ -754,7 +858,16 @@
         <c:scaling/>
         <c:delete val="0"/>
         <c:axPos val="l"/>
-        <c:majorGridlines/>
+        <c:majorGridlines>
+          <c:spPr>
+            <a:ln w="9525">
+              <a:solidFill>
+                <a:srgbClr val="D9D9D9"/>
+              </a:solidFill>
+              <a:prstDash val="sysDot"/>
+            </a:ln>
+          </c:spPr>
+        </c:majorGridlines>
         <c:majorTickMark val="out"/>
         <c:minorTickMark val="none"/>
         <c:tickLblPos val="nextTo"/>
@@ -803,6 +916,13 @@
               </c:strCache>
             </c:strRef>
           </c:tx>
+          <c:spPr>
+            <a:solidFill>
+              <a:schemeClr val="accent1">
+                <a:alpha val="87000"/>
+              </a:schemeClr>
+            </a:solidFill>
+          </c:spPr>
           <c:cat>
             <c:strRef>
               <c:f>Sheet1!$A$2:$A$5</c:f>
@@ -859,6 +979,13 @@
               </c:strCache>
             </c:strRef>
           </c:tx>
+          <c:spPr>
+            <a:solidFill>
+              <a:schemeClr val="accent2">
+                <a:alpha val="87000"/>
+              </a:schemeClr>
+            </a:solidFill>
+          </c:spPr>
           <c:cat>
             <c:strRef>
               <c:f>Sheet1!$A$2:$A$5</c:f>
@@ -928,7 +1055,16 @@
         <c:scaling/>
         <c:delete val="0"/>
         <c:axPos val="l"/>
-        <c:majorGridlines/>
+        <c:majorGridlines>
+          <c:spPr>
+            <a:ln w="9525">
+              <a:solidFill>
+                <a:srgbClr val="D9D9D9"/>
+              </a:solidFill>
+              <a:prstDash val="sysDot"/>
+            </a:ln>
+          </c:spPr>
+        </c:majorGridlines>
         <c:majorTickMark val="out"/>
         <c:minorTickMark val="none"/>
         <c:tickLblPos val="nextTo"/>
@@ -5833,7 +5969,9 @@
             <a:avLst/>
           </a:prstGeom>
           <a:solidFill>
-            <a:srgbClr val="0066CC"/>
+            <a:srgbClr val="0066CC">
+              <a:alpha val="87000"/>
+            </a:srgbClr>
           </a:solidFill>
           <a:ln>
             <a:noFill/>
@@ -5905,8 +6043,8 @@
           <p:nvPr/>
         </p:nvGraphicFramePr>
         <p:xfrm>
-          <a:off x="822960" y="2148840"/>
-          <a:ext cx="10545775" cy="4160520"/>
+          <a:off x="2932115" y="2148840"/>
+          <a:ext cx="6327465" cy="4160520"/>
         </p:xfrm>
         <a:graphic>
           <a:graphicData uri="http://schemas.openxmlformats.org/drawingml/2006/chart">
@@ -5981,7 +6119,9 @@
             <a:avLst/>
           </a:prstGeom>
           <a:solidFill>
-            <a:srgbClr val="0066CC"/>
+            <a:srgbClr val="0066CC">
+              <a:alpha val="87000"/>
+            </a:srgbClr>
           </a:solidFill>
           <a:ln>
             <a:noFill/>
@@ -6129,7 +6269,9 @@
             <a:avLst/>
           </a:prstGeom>
           <a:solidFill>
-            <a:srgbClr val="0066CC"/>
+            <a:srgbClr val="0066CC">
+              <a:alpha val="87000"/>
+            </a:srgbClr>
           </a:solidFill>
           <a:ln>
             <a:noFill/>
@@ -6330,7 +6472,9 @@
             <a:avLst/>
           </a:prstGeom>
           <a:solidFill>
-            <a:srgbClr val="0066CC"/>
+            <a:srgbClr val="0066CC">
+              <a:alpha val="87000"/>
+            </a:srgbClr>
           </a:solidFill>
           <a:ln>
             <a:noFill/>
@@ -6850,7 +6994,9 @@
             <a:avLst/>
           </a:prstGeom>
           <a:solidFill>
-            <a:srgbClr val="0066CC"/>
+            <a:srgbClr val="0066CC">
+              <a:alpha val="87000"/>
+            </a:srgbClr>
           </a:solidFill>
           <a:ln>
             <a:noFill/>
@@ -7726,7 +7872,9 @@
             <a:avLst/>
           </a:prstGeom>
           <a:solidFill>
-            <a:srgbClr val="0066CC"/>
+            <a:srgbClr val="0066CC">
+              <a:alpha val="87000"/>
+            </a:srgbClr>
           </a:solidFill>
           <a:ln>
             <a:noFill/>
@@ -8350,7 +8498,9 @@
             <a:avLst/>
           </a:prstGeom>
           <a:solidFill>
-            <a:srgbClr val="0066CC"/>
+            <a:srgbClr val="0066CC">
+              <a:alpha val="87000"/>
+            </a:srgbClr>
           </a:solidFill>
           <a:ln>
             <a:noFill/>
@@ -8721,7 +8871,9 @@
             <a:avLst/>
           </a:prstGeom>
           <a:solidFill>
-            <a:srgbClr val="0066CC"/>
+            <a:srgbClr val="0066CC">
+              <a:alpha val="87000"/>
+            </a:srgbClr>
           </a:solidFill>
           <a:ln>
             <a:noFill/>
@@ -8841,7 +8993,9 @@
             <a:avLst/>
           </a:prstGeom>
           <a:solidFill>
-            <a:srgbClr val="0066CC"/>
+            <a:srgbClr val="0066CC">
+              <a:alpha val="87000"/>
+            </a:srgbClr>
           </a:solidFill>
           <a:ln>
             <a:noFill/>
@@ -9048,7 +9202,9 @@
             <a:avLst/>
           </a:prstGeom>
           <a:solidFill>
-            <a:srgbClr val="0066CC"/>
+            <a:srgbClr val="0066CC">
+              <a:alpha val="87000"/>
+            </a:srgbClr>
           </a:solidFill>
           <a:ln>
             <a:noFill/>
@@ -9216,7 +9372,9 @@
             <a:avLst/>
           </a:prstGeom>
           <a:solidFill>
-            <a:srgbClr val="0066CC"/>
+            <a:srgbClr val="0066CC">
+              <a:alpha val="87000"/>
+            </a:srgbClr>
           </a:solidFill>
           <a:ln>
             <a:noFill/>
@@ -9312,7 +9470,9 @@
             <a:avLst/>
           </a:prstGeom>
           <a:solidFill>
-            <a:srgbClr val="0066CC"/>
+            <a:srgbClr val="0066CC">
+              <a:alpha val="87000"/>
+            </a:srgbClr>
           </a:solidFill>
           <a:ln>
             <a:noFill/>
@@ -9363,7 +9523,7 @@
           </a:bodyPr>
           <a:lstStyle/>
           <a:p>
-            <a:pPr marL="88900" indent="-88900">
+            <a:pPr marL="247650" indent="-247650">
               <a:lnSpc>
                 <a:spcPct val="115000"/>
               </a:lnSpc>
@@ -9383,7 +9543,7 @@
             </a:r>
           </a:p>
           <a:p>
-            <a:pPr marL="88900" indent="-88900">
+            <a:pPr marL="247650" indent="-247650">
               <a:lnSpc>
                 <a:spcPct val="115000"/>
               </a:lnSpc>
@@ -9403,7 +9563,7 @@
             </a:r>
           </a:p>
           <a:p>
-            <a:pPr marL="88900" indent="-88900">
+            <a:pPr marL="247650" indent="-247650">
               <a:lnSpc>
                 <a:spcPct val="115000"/>
               </a:lnSpc>
@@ -9423,7 +9583,7 @@
             </a:r>
           </a:p>
           <a:p>
-            <a:pPr marL="88900" indent="-88900">
+            <a:pPr marL="247650" indent="-247650">
               <a:lnSpc>
                 <a:spcPct val="115000"/>
               </a:lnSpc>
@@ -9607,7 +9767,9 @@
             <a:avLst/>
           </a:prstGeom>
           <a:solidFill>
-            <a:srgbClr val="0066CC"/>
+            <a:srgbClr val="0066CC">
+              <a:alpha val="87000"/>
+            </a:srgbClr>
           </a:solidFill>
           <a:ln>
             <a:noFill/>
@@ -9658,7 +9820,7 @@
           </a:bodyPr>
           <a:lstStyle/>
           <a:p>
-            <a:pPr marL="152400" indent="-152400">
+            <a:pPr marL="203200" indent="-203200">
               <a:lnSpc>
                 <a:spcPct val="115000"/>
               </a:lnSpc>
@@ -9679,7 +9841,7 @@
             </a:r>
           </a:p>
           <a:p>
-            <a:pPr marL="152400" indent="-152400">
+            <a:pPr marL="203200" indent="-203200">
               <a:lnSpc>
                 <a:spcPct val="115000"/>
               </a:lnSpc>
@@ -9700,7 +9862,7 @@
             </a:r>
           </a:p>
           <a:p>
-            <a:pPr marL="152400" indent="-152400">
+            <a:pPr marL="203200" indent="-203200">
               <a:lnSpc>
                 <a:spcPct val="115000"/>
               </a:lnSpc>
@@ -9721,7 +9883,7 @@
             </a:r>
           </a:p>
           <a:p>
-            <a:pPr marL="152400" indent="-152400">
+            <a:pPr marL="203200" indent="-203200">
               <a:lnSpc>
                 <a:spcPct val="115000"/>
               </a:lnSpc>
@@ -9871,7 +10033,9 @@
             <a:avLst/>
           </a:prstGeom>
           <a:solidFill>
-            <a:srgbClr val="0066CC"/>
+            <a:srgbClr val="0066CC">
+              <a:alpha val="87000"/>
+            </a:srgbClr>
           </a:solidFill>
           <a:ln>
             <a:noFill/>
@@ -10141,7 +10305,9 @@
             <a:avLst/>
           </a:prstGeom>
           <a:solidFill>
-            <a:srgbClr val="0066CC"/>
+            <a:srgbClr val="0066CC">
+              <a:alpha val="87000"/>
+            </a:srgbClr>
           </a:solidFill>
           <a:ln>
             <a:noFill/>
@@ -10498,7 +10664,9 @@
             <a:avLst/>
           </a:prstGeom>
           <a:solidFill>
-            <a:srgbClr val="0066CC"/>
+            <a:srgbClr val="0066CC">
+              <a:alpha val="87000"/>
+            </a:srgbClr>
           </a:solidFill>
           <a:ln>
             <a:noFill/>
@@ -10942,7 +11110,9 @@
             <a:avLst/>
           </a:prstGeom>
           <a:solidFill>
-            <a:srgbClr val="0066CC"/>
+            <a:srgbClr val="0066CC">
+              <a:alpha val="87000"/>
+            </a:srgbClr>
           </a:solidFill>
           <a:ln>
             <a:noFill/>
@@ -11090,7 +11260,9 @@
             <a:avLst/>
           </a:prstGeom>
           <a:solidFill>
-            <a:srgbClr val="0066CC"/>
+            <a:srgbClr val="0066CC">
+              <a:alpha val="87000"/>
+            </a:srgbClr>
           </a:solidFill>
           <a:ln>
             <a:noFill/>

</xml_diff>